<commit_message>
docs(review2): name the most predictable food apps in the slide 13 notes
</commit_message>
<xml_diff>
--- a/docs/Review_2_Presentation.pptx
+++ b/docs/Review_2_Presentation.pptx
@@ -127,7 +127,7 @@
   <p:extLst>
     <p:ext uri="{521415D9-36F7-43E2-AB2F-B90AF26B5E84}">
       <p14:sectionLst xmlns:p14="http://schemas.microsoft.com/office/powerpoint/2010/main">
-        <p14:section name="Aditya: introduction and Stage 1" id="{2b038608-898f-f992-3845-1275a4e7c9e5}">
+        <p14:section name="Aditya: introduction and Stage 1" id="{2f6c343a-553e-e520-631c-906ed09bb9dd}">
           <p14:sldIdLst>
             <p14:sldId id="256"/>
             <p14:sldId id="257"/>
@@ -136,28 +136,28 @@
             <p14:sldId id="260"/>
           </p14:sldIdLst>
         </p14:section>
-        <p14:section name="Saketh: text mining" id="{0e6bfca8-b559-9ae9-ad36-a21ca61c6137}">
+        <p14:section name="Saketh: text mining" id="{0cfe82dc-9696-f5a2-ef2d-1d06f4d0cb3f}">
           <p14:sldIdLst>
             <p14:sldId id="261"/>
             <p14:sldId id="262"/>
             <p14:sldId id="263"/>
           </p14:sldIdLst>
         </p14:section>
-        <p14:section name="Akshay: forecasting" id="{23000d6f-ba45-27fd-8527-f63cb305baaa}">
+        <p14:section name="Akshay: forecasting" id="{6425d9fa-a9cc-1bcc-0966-4fe8f7f86f03}">
           <p14:sldIdLst>
             <p14:sldId id="264"/>
             <p14:sldId id="265"/>
             <p14:sldId id="266"/>
           </p14:sldIdLst>
         </p14:section>
-        <p14:section name="Harshini: forecast evaluation" id="{e811d453-b031-39e6-a42c-b34b680e5015}">
+        <p14:section name="Harshini: forecast evaluation" id="{b6c0fffa-366f-f963-ad9a-b6d8a9fd929f}">
           <p14:sldIdLst>
             <p14:sldId id="267"/>
             <p14:sldId id="268"/>
             <p14:sldId id="269"/>
           </p14:sldIdLst>
         </p14:section>
-        <p14:section name="Kanishka: update impact and insights" id="{9bf2bed5-18a2-58e7-deec-4ecbcd882253}">
+        <p14:section name="Kanishka: update impact and insights" id="{b700684d-cf0e-5fd8-2b5d-2f65cf772a70}">
           <p14:sldIdLst>
             <p14:sldId id="270"/>
             <p14:sldId id="271"/>
@@ -166,7 +166,7 @@
             <p14:sldId id="274"/>
           </p14:sldIdLst>
         </p14:section>
-        <p14:section name="Aditya: tracking and close" id="{affec2aa-8d31-4094-d2b7-62361fc29d56}">
+        <p14:section name="Aditya: tracking and close" id="{de321740-0017-b109-c642-a6b4d88e4895}">
           <p14:sldIdLst>
             <p14:sldId id="275"/>
             <p14:sldId id="276"/>
@@ -2293,7 +2293,7 @@
           <a:p>
             <a:r>
               <a:rPr lang="en-US" dirty="0"/>
-              <a:t>[Harshini, about 40 s] A day is flagged as unusual when its count falls outside the 95 percent interval. Because the backtest windows overlap, the 201 flagged forecasts are 83 distinct days, most of them above the forecast. The largest was Swiggy on 24 July: 469 complaints against 157 expected. Flipkart has the most alerts. An alert means an unexpected count, not a proven cause. The food apps are the most predictable because of their weekly rhythm. Shopping apps with level shifts are the hardest, and Google Pay and Paytm should be used with care. Next is the check-a-review page I built.</a:t>
+              <a:t>[Harshini, about 40 s] A day is flagged as unusual when its count falls outside the 95 percent interval. Because the backtest windows overlap, the 201 flagged forecasts are 83 distinct days, most of them above the forecast. The largest was Swiggy on 24 July: 469 complaints against 157 expected. Flipkart has the most alerts. An alert means an unexpected count, not a proven cause. Food apps with a steady weekly rhythm, like Zomato and Blinkit, are the most predictable. Shopping apps with level shifts are the hardest, and Google Pay and Paytm should be used with care. Next is the check-a-review page I built.</a:t>
             </a:r>
             <a:endParaRPr lang="en-US" dirty="0"/>
           </a:p>

</xml_diff>

<commit_message>
docs(review2): add the project board screenshot slide and move contributions to their own slide
</commit_message>
<xml_diff>
--- a/docs/Review_2_Presentation.pptx
+++ b/docs/Review_2_Presentation.pptx
@@ -26,9 +26,10 @@
     <p:sldId id="274" r:id="rId20"/>
     <p:sldId id="275" r:id="rId21"/>
     <p:sldId id="276" r:id="rId22"/>
+    <p:sldId id="277" r:id="rId23"/>
   </p:sldIdLst>
   <p:notesMasterIdLst>
-    <p:notesMasterId r:id="rId23"/>
+    <p:notesMasterId r:id="rId24"/>
   </p:notesMasterIdLst>
   <p:sldSz cx="12192000" cy="6858000"/>
   <p:notesSz cx="6858000" cy="12192000"/>
@@ -127,7 +128,7 @@
   <p:extLst>
     <p:ext uri="{521415D9-36F7-43E2-AB2F-B90AF26B5E84}">
       <p14:sectionLst xmlns:p14="http://schemas.microsoft.com/office/powerpoint/2010/main">
-        <p14:section name="Aditya: introduction and Stage 1" id="{2f6c343a-553e-e520-631c-906ed09bb9dd}">
+        <p14:section name="Aditya: introduction and Stage 1" id="{a006aa79-b06c-894f-e076-3125ab3e5882}">
           <p14:sldIdLst>
             <p14:sldId id="256"/>
             <p14:sldId id="257"/>
@@ -136,28 +137,28 @@
             <p14:sldId id="260"/>
           </p14:sldIdLst>
         </p14:section>
-        <p14:section name="Saketh: text mining" id="{0cfe82dc-9696-f5a2-ef2d-1d06f4d0cb3f}">
+        <p14:section name="Saketh: text mining" id="{2c6b6956-a680-865f-cd9d-3142dccbde35}">
           <p14:sldIdLst>
             <p14:sldId id="261"/>
             <p14:sldId id="262"/>
             <p14:sldId id="263"/>
           </p14:sldIdLst>
         </p14:section>
-        <p14:section name="Akshay: forecasting" id="{6425d9fa-a9cc-1bcc-0966-4fe8f7f86f03}">
+        <p14:section name="Akshay: forecasting" id="{5a5bacf6-cc13-34c0-5369-e14f578ed9ec}">
           <p14:sldIdLst>
             <p14:sldId id="264"/>
             <p14:sldId id="265"/>
             <p14:sldId id="266"/>
           </p14:sldIdLst>
         </p14:section>
-        <p14:section name="Harshini: forecast evaluation" id="{b6c0fffa-366f-f963-ad9a-b6d8a9fd929f}">
+        <p14:section name="Harshini: forecast evaluation" id="{0ac7f2f6-66ea-1075-6789-4d44c2ed0300}">
           <p14:sldIdLst>
             <p14:sldId id="267"/>
             <p14:sldId id="268"/>
             <p14:sldId id="269"/>
           </p14:sldIdLst>
         </p14:section>
-        <p14:section name="Kanishka: update impact and insights" id="{b700684d-cf0e-5fd8-2b5d-2f65cf772a70}">
+        <p14:section name="Kanishka: update impact and insights" id="{f3750ee9-13b0-0d52-a5e2-e3f43a19ff6a}">
           <p14:sldIdLst>
             <p14:sldId id="270"/>
             <p14:sldId id="271"/>
@@ -166,10 +167,11 @@
             <p14:sldId id="274"/>
           </p14:sldIdLst>
         </p14:section>
-        <p14:section name="Aditya: tracking and close" id="{de321740-0017-b109-c642-a6b4d88e4895}">
+        <p14:section name="Aditya: tracking and close" id="{707a2d00-7ee6-ee43-2b52-d2d6e1bea4a3}">
           <p14:sldIdLst>
             <p14:sldId id="275"/>
             <p14:sldId id="276"/>
+            <p14:sldId id="277"/>
           </p14:sldIdLst>
         </p14:section>
       </p14:sectionLst>
@@ -2997,7 +2999,7 @@
           <a:p>
             <a:r>
               <a:rPr lang="en-US" dirty="0"/>
-              <a:t>[Aditya, about 30 s] We tracked the work on our GitHub Projects board with the five required stages. Review 2 had 14 tasks, each assigned to one member with a due date, and all 14 are completed. Every task is linked to a merged pull request, and the stages were merged one after another between 8 and 11 October. The table shows what each member owned and where the evidence is. After Stage 5 I built this deck, the final report and the contribution summary.</a:t>
+              <a:t>[Aditya, about 20 s] We tracked the work on our GitHub Projects board with the five required stages. This is the board for Review 2: 14 tasks, each assigned to one member with a due date of 11 October, each linked to its merged pull request, and all 14 are completed.</a:t>
             </a:r>
             <a:endParaRPr lang="en-US" dirty="0"/>
           </a:p>
@@ -3085,7 +3087,7 @@
           <a:p>
             <a:r>
               <a:rPr lang="en-US" dirty="0"/>
-              <a:t>[Aditya, about 40 s] To conclude: users complain about service more than about the apps themselves, and the topic models cover the 43 percent of complaints that keyword rules missed. ARIMA forecasts complaints better than the baseline for 10 of 11 apps, most releases change nothing, and Paytm 10.84.5 clearly made things worse. The apps to fix first are Swiggy, Flipkart, Amazon and Paytm. The main limits are the short six-month window and that a low rating is a user's judgement, not a confirmed defect. All our links are on this slide. Thank you; we are happy to take questions.</a:t>
+              <a:t>[Aditya, about 25 s] This table shows what each member owned and where the evidence is. The stages were merged one after another between 8 and 11 October, and every member wrote code and a dashboard part. After Stage 5 I built this deck, the final report and the contribution summary.</a:t>
             </a:r>
             <a:endParaRPr lang="en-US" dirty="0"/>
           </a:p>
@@ -3109,6 +3111,94 @@
             <a:fld id="{F7021451-1387-4CA6-816F-3879F97B5CBC}" type="slidenum">
               <a:rPr lang="en-US"/>
               <a:t>21</a:t>
+            </a:fld>
+            <a:endParaRPr lang="en-US"/>
+          </a:p>
+        </p:txBody>
+      </p:sp>
+    </p:spTree>
+    <p:extLst>
+      <p:ext uri="{BB962C8B-B14F-4D97-AF65-F5344CB8AC3E}">
+        <p14:creationId xmlns:p14="http://schemas.microsoft.com/office/powerpoint/2010/main" val="1024086991"/>
+      </p:ext>
+    </p:extLst>
+  </p:cSld>
+  <p:clrMapOvr>
+    <a:masterClrMapping/>
+  </p:clrMapOvr>
+</p:notes>
+</file>
+
+<file path=ppt/notesSlides/notesSlide22.xml><?xml version="1.0" encoding="utf-8"?>
+<p:notes xmlns:a="http://schemas.openxmlformats.org/drawingml/2006/main" xmlns:r="http://schemas.openxmlformats.org/officeDocument/2006/relationships" xmlns:p="http://schemas.openxmlformats.org/presentationml/2006/main">
+  <p:cSld>
+    <p:spTree>
+      <p:nvGrpSpPr>
+        <p:cNvPr id="1" name=""/>
+        <p:cNvGrpSpPr/>
+        <p:nvPr/>
+      </p:nvGrpSpPr>
+      <p:grpSpPr>
+        <a:xfrm>
+          <a:off x="0" y="0"/>
+          <a:ext cx="0" cy="0"/>
+          <a:chOff x="0" y="0"/>
+          <a:chExt cx="0" cy="0"/>
+        </a:xfrm>
+      </p:grpSpPr>
+      <p:sp>
+        <p:nvSpPr>
+          <p:cNvPr id="2" name="Slide Image Placeholder 1"/>
+          <p:cNvSpPr>
+            <a:spLocks noGrp="1" noRot="1" noChangeAspect="1"/>
+          </p:cNvSpPr>
+          <p:nvPr>
+            <p:ph type="sldImg"/>
+          </p:nvPr>
+        </p:nvSpPr>
+        <p:spPr/>
+      </p:sp>
+      <p:sp>
+        <p:nvSpPr>
+          <p:cNvPr id="3" name="Notes Placeholder 2"/>
+          <p:cNvSpPr>
+            <a:spLocks noGrp="1"/>
+          </p:cNvSpPr>
+          <p:nvPr>
+            <p:ph type="body" idx="1"/>
+          </p:nvPr>
+        </p:nvSpPr>
+        <p:spPr/>
+        <p:txBody>
+          <a:bodyPr/>
+          <a:lstStyle/>
+          <a:p>
+            <a:r>
+              <a:rPr lang="en-US" dirty="0"/>
+              <a:t>[Aditya, about 40 s] To conclude: users complain about service more than about the apps themselves, and the topic models cover the 43 percent of complaints that keyword rules missed. ARIMA forecasts complaints better than the baseline for 10 of 11 apps, most releases change nothing, and Paytm 10.84.5 clearly made things worse. The apps to fix first are Swiggy, Flipkart, Amazon and Paytm. The main limits are the short six-month window and that a low rating is a user's judgement, not a confirmed defect. All our links are on this slide. Thank you; we are happy to take questions.</a:t>
+            </a:r>
+            <a:endParaRPr lang="en-US" dirty="0"/>
+          </a:p>
+        </p:txBody>
+      </p:sp>
+      <p:sp>
+        <p:nvSpPr>
+          <p:cNvPr id="4" name="Slide Number Placeholder 3"/>
+          <p:cNvSpPr>
+            <a:spLocks noGrp="1"/>
+          </p:cNvSpPr>
+          <p:nvPr>
+            <p:ph type="sldNum" sz="quarter" idx="10"/>
+          </p:nvPr>
+        </p:nvSpPr>
+        <p:spPr/>
+        <p:txBody>
+          <a:bodyPr/>
+          <a:lstStyle/>
+          <a:p>
+            <a:fld id="{F7021451-1387-4CA6-816F-3879F97B5CBC}" type="slidenum">
+              <a:rPr lang="en-US"/>
+              <a:t>22</a:t>
             </a:fld>
             <a:endParaRPr lang="en-US"/>
           </a:p>
@@ -22485,7 +22575,7 @@
                   <a:schemeClr val="accent6"/>
                 </a:solidFill>
               </a:rPr>
-              <a:t>13  |  PROJECT TRACKING AND INDIVIDUAL CONTRIBUTIONS</a:t>
+              <a:t>13  |  PROJECT TRACKING AND PROGRESS</a:t>
             </a:r>
             <a:endParaRPr lang="en-US" sz="1100" dirty="0"/>
           </a:p>
@@ -22526,7 +22616,7 @@
                 <a:ea typeface="Cambria" pitchFamily="34" charset="-122"/>
                 <a:cs typeface="Cambria" pitchFamily="34" charset="-120"/>
               </a:rPr>
-              <a:t>Project Tracking and Individual Contributions</a:t>
+              <a:t>Project Tracking and Progress</a:t>
             </a:r>
             <a:endParaRPr lang="en-US" sz="2800" dirty="0"/>
           </a:p>
@@ -22562,7 +22652,7 @@
                   <a:schemeClr val="tx1"/>
                 </a:solidFill>
               </a:rPr>
-              <a:t>Board: </a:t>
+              <a:t>Tool and board link: </a:t>
             </a:r>
             <a:pPr indent="0" marL="0">
               <a:buNone/>
@@ -22580,7 +22670,7 @@
                   </a:extLst>
                 </a:hlinkClick>
               </a:rPr>
-              <a:t>github.com/users/Adithya-Monish-Kumar-K/projects/4</a:t>
+              <a:t>GitHub Projects, github.com/users/Adithya-Monish-Kumar-K/projects/4</a:t>
             </a:r>
             <a:pPr indent="0" marL="0">
               <a:buNone/>
@@ -22924,2107 +23014,22 @@
                   <a:srgbClr val="FFFFFF"/>
                 </a:solidFill>
               </a:rPr>
-              <a:t>Completed: 14 of 14 tasks</a:t>
+              <a:t>Completed</a:t>
             </a:r>
             <a:endParaRPr lang="en-US" sz="1150" dirty="0"/>
           </a:p>
         </p:txBody>
       </p:sp>
-      <p:graphicFrame>
-        <p:nvGraphicFramePr>
-          <p:cNvPr id="21" name="Table 0"/>
-          <p:cNvGraphicFramePr>
-            <a:graphicFrameLocks noGrp="1"/>
-          </p:cNvGraphicFramePr>
-          <p:nvPr>
-            <p:extLst>
-              <p:ext uri="{D42A27DB-BD31-4B8C-83A1-F6EECF244321}">
-                <p14:modId xmlns:p14="http://schemas.microsoft.com/office/powerpoint/2010/main" val="1579011935"/>
-              </p:ext>
-            </p:extLst>
-          </p:nvPr>
-        </p:nvGraphicFramePr>
-        <p:xfrm>
-          <a:off x="640080" y="2240280"/>
-          <a:ext cx="10911535" cy="914400"/>
-        </p:xfrm>
-        <a:graphic>
-          <a:graphicData uri="http://schemas.openxmlformats.org/drawingml/2006/table">
-            <a:tbl>
-              <a:tblPr/>
-              <a:tblGrid>
-                <a:gridCol w="2011680"/>
-                <a:gridCol w="548640"/>
-                <a:gridCol w="4069080"/>
-                <a:gridCol w="1600200"/>
-                <a:gridCol w="2681935"/>
-              </a:tblGrid>
-              <a:tr h="329184">
-                <a:tc>
-                  <a:txBody>
-                    <a:bodyPr/>
-                    <a:lstStyle/>
-                    <a:p>
-                      <a:pPr algn="l" indent="0" marL="0">
-                        <a:buNone/>
-                      </a:pPr>
-                      <a:r>
-                        <a:rPr lang="en-US" sz="1100" b="1" dirty="0">
-                          <a:solidFill>
-                            <a:srgbClr val="FFFFFF"/>
-                          </a:solidFill>
-                          <a:latin typeface="Calibri" pitchFamily="34" charset="0"/>
-                          <a:ea typeface="Calibri" pitchFamily="34" charset="-122"/>
-                          <a:cs typeface="Calibri" pitchFamily="34" charset="-120"/>
-                        </a:rPr>
-                        <a:t>Member</a:t>
-                      </a:r>
-                      <a:endParaRPr lang="en-US" sz="1100" dirty="0">
-                        <a:latin typeface="Calibri" charset="0"/>
-                        <a:ea typeface="Calibri" charset="0"/>
-                        <a:cs typeface="Calibri" charset="0"/>
-                      </a:endParaRPr>
-                    </a:p>
-                  </a:txBody>
-                  <a:tcPr marL="63500" marR="63500" marT="25400" marB="25400" anchor="ctr">
-                    <a:lnL w="9525" cap="flat" cmpd="sng" algn="ctr">
-                      <a:solidFill>
-                        <a:srgbClr val="E3E8EF"/>
-                      </a:solidFill>
-                      <a:prstDash val="solid"/>
-                      <a:round/>
-                      <a:headEnd type="none" w="med" len="med"/>
-                      <a:tailEnd type="none" w="med" len="med"/>
-                    </a:lnL>
-                    <a:lnR w="9525" cap="flat" cmpd="sng" algn="ctr">
-                      <a:solidFill>
-                        <a:srgbClr val="E3E8EF"/>
-                      </a:solidFill>
-                      <a:prstDash val="solid"/>
-                      <a:round/>
-                      <a:headEnd type="none" w="med" len="med"/>
-                      <a:tailEnd type="none" w="med" len="med"/>
-                    </a:lnR>
-                    <a:lnT w="9525" cap="flat" cmpd="sng" algn="ctr">
-                      <a:solidFill>
-                        <a:srgbClr val="E3E8EF"/>
-                      </a:solidFill>
-                      <a:prstDash val="solid"/>
-                      <a:round/>
-                      <a:headEnd type="none" w="med" len="med"/>
-                      <a:tailEnd type="none" w="med" len="med"/>
-                    </a:lnT>
-                    <a:lnB w="9525" cap="flat" cmpd="sng" algn="ctr">
-                      <a:solidFill>
-                        <a:srgbClr val="E3E8EF"/>
-                      </a:solidFill>
-                      <a:prstDash val="solid"/>
-                      <a:round/>
-                      <a:headEnd type="none" w="med" len="med"/>
-                      <a:tailEnd type="none" w="med" len="med"/>
-                    </a:lnB>
-                    <a:solidFill>
-                      <a:srgbClr val="132C43"/>
-                    </a:solidFill>
-                  </a:tcPr>
-                </a:tc>
-                <a:tc>
-                  <a:txBody>
-                    <a:bodyPr/>
-                    <a:lstStyle/>
-                    <a:p>
-                      <a:pPr algn="ctr" indent="0" marL="0">
-                        <a:buNone/>
-                      </a:pPr>
-                      <a:r>
-                        <a:rPr lang="en-US" sz="1100" b="1" dirty="0">
-                          <a:solidFill>
-                            <a:srgbClr val="FFFFFF"/>
-                          </a:solidFill>
-                          <a:latin typeface="Calibri" pitchFamily="34" charset="0"/>
-                          <a:ea typeface="Calibri" pitchFamily="34" charset="-122"/>
-                          <a:cs typeface="Calibri" pitchFamily="34" charset="-120"/>
-                        </a:rPr>
-                        <a:t>Stage</a:t>
-                      </a:r>
-                      <a:endParaRPr lang="en-US" sz="1100" dirty="0">
-                        <a:latin typeface="Calibri" charset="0"/>
-                        <a:ea typeface="Calibri" charset="0"/>
-                        <a:cs typeface="Calibri" charset="0"/>
-                      </a:endParaRPr>
-                    </a:p>
-                  </a:txBody>
-                  <a:tcPr marL="63500" marR="63500" marT="25400" marB="25400" anchor="ctr">
-                    <a:lnL w="9525" cap="flat" cmpd="sng" algn="ctr">
-                      <a:solidFill>
-                        <a:srgbClr val="E3E8EF"/>
-                      </a:solidFill>
-                      <a:prstDash val="solid"/>
-                      <a:round/>
-                      <a:headEnd type="none" w="med" len="med"/>
-                      <a:tailEnd type="none" w="med" len="med"/>
-                    </a:lnL>
-                    <a:lnR w="9525" cap="flat" cmpd="sng" algn="ctr">
-                      <a:solidFill>
-                        <a:srgbClr val="E3E8EF"/>
-                      </a:solidFill>
-                      <a:prstDash val="solid"/>
-                      <a:round/>
-                      <a:headEnd type="none" w="med" len="med"/>
-                      <a:tailEnd type="none" w="med" len="med"/>
-                    </a:lnR>
-                    <a:lnT w="9525" cap="flat" cmpd="sng" algn="ctr">
-                      <a:solidFill>
-                        <a:srgbClr val="E3E8EF"/>
-                      </a:solidFill>
-                      <a:prstDash val="solid"/>
-                      <a:round/>
-                      <a:headEnd type="none" w="med" len="med"/>
-                      <a:tailEnd type="none" w="med" len="med"/>
-                    </a:lnT>
-                    <a:lnB w="9525" cap="flat" cmpd="sng" algn="ctr">
-                      <a:solidFill>
-                        <a:srgbClr val="E3E8EF"/>
-                      </a:solidFill>
-                      <a:prstDash val="solid"/>
-                      <a:round/>
-                      <a:headEnd type="none" w="med" len="med"/>
-                      <a:tailEnd type="none" w="med" len="med"/>
-                    </a:lnB>
-                    <a:solidFill>
-                      <a:srgbClr val="132C43"/>
-                    </a:solidFill>
-                  </a:tcPr>
-                </a:tc>
-                <a:tc>
-                  <a:txBody>
-                    <a:bodyPr/>
-                    <a:lstStyle/>
-                    <a:p>
-                      <a:pPr algn="l" indent="0" marL="0">
-                        <a:buNone/>
-                      </a:pPr>
-                      <a:r>
-                        <a:rPr lang="en-US" sz="1100" b="1" dirty="0">
-                          <a:solidFill>
-                            <a:srgbClr val="FFFFFF"/>
-                          </a:solidFill>
-                          <a:latin typeface="Calibri" pitchFamily="34" charset="0"/>
-                          <a:ea typeface="Calibri" pitchFamily="34" charset="-122"/>
-                          <a:cs typeface="Calibri" pitchFamily="34" charset="-120"/>
-                        </a:rPr>
-                        <a:t>Board tasks (all due 11 Oct, all Completed)</a:t>
-                      </a:r>
-                      <a:endParaRPr lang="en-US" sz="1100" dirty="0">
-                        <a:latin typeface="Calibri" charset="0"/>
-                        <a:ea typeface="Calibri" charset="0"/>
-                        <a:cs typeface="Calibri" charset="0"/>
-                      </a:endParaRPr>
-                    </a:p>
-                  </a:txBody>
-                  <a:tcPr marL="63500" marR="63500" marT="25400" marB="25400" anchor="ctr">
-                    <a:lnL w="9525" cap="flat" cmpd="sng" algn="ctr">
-                      <a:solidFill>
-                        <a:srgbClr val="E3E8EF"/>
-                      </a:solidFill>
-                      <a:prstDash val="solid"/>
-                      <a:round/>
-                      <a:headEnd type="none" w="med" len="med"/>
-                      <a:tailEnd type="none" w="med" len="med"/>
-                    </a:lnL>
-                    <a:lnR w="9525" cap="flat" cmpd="sng" algn="ctr">
-                      <a:solidFill>
-                        <a:srgbClr val="E3E8EF"/>
-                      </a:solidFill>
-                      <a:prstDash val="solid"/>
-                      <a:round/>
-                      <a:headEnd type="none" w="med" len="med"/>
-                      <a:tailEnd type="none" w="med" len="med"/>
-                    </a:lnR>
-                    <a:lnT w="9525" cap="flat" cmpd="sng" algn="ctr">
-                      <a:solidFill>
-                        <a:srgbClr val="E3E8EF"/>
-                      </a:solidFill>
-                      <a:prstDash val="solid"/>
-                      <a:round/>
-                      <a:headEnd type="none" w="med" len="med"/>
-                      <a:tailEnd type="none" w="med" len="med"/>
-                    </a:lnT>
-                    <a:lnB w="9525" cap="flat" cmpd="sng" algn="ctr">
-                      <a:solidFill>
-                        <a:srgbClr val="E3E8EF"/>
-                      </a:solidFill>
-                      <a:prstDash val="solid"/>
-                      <a:round/>
-                      <a:headEnd type="none" w="med" len="med"/>
-                      <a:tailEnd type="none" w="med" len="med"/>
-                    </a:lnB>
-                    <a:solidFill>
-                      <a:srgbClr val="132C43"/>
-                    </a:solidFill>
-                  </a:tcPr>
-                </a:tc>
-                <a:tc>
-                  <a:txBody>
-                    <a:bodyPr/>
-                    <a:lstStyle/>
-                    <a:p>
-                      <a:pPr algn="l" indent="0" marL="0">
-                        <a:buNone/>
-                      </a:pPr>
-                      <a:r>
-                        <a:rPr lang="en-US" sz="1100" b="1" dirty="0">
-                          <a:solidFill>
-                            <a:srgbClr val="FFFFFF"/>
-                          </a:solidFill>
-                          <a:latin typeface="Calibri" pitchFamily="34" charset="0"/>
-                          <a:ea typeface="Calibri" pitchFamily="34" charset="-122"/>
-                          <a:cs typeface="Calibri" pitchFamily="34" charset="-120"/>
-                        </a:rPr>
-                        <a:t>Pull requests (merged)</a:t>
-                      </a:r>
-                      <a:endParaRPr lang="en-US" sz="1100" dirty="0">
-                        <a:latin typeface="Calibri" charset="0"/>
-                        <a:ea typeface="Calibri" charset="0"/>
-                        <a:cs typeface="Calibri" charset="0"/>
-                      </a:endParaRPr>
-                    </a:p>
-                  </a:txBody>
-                  <a:tcPr marL="63500" marR="63500" marT="25400" marB="25400" anchor="ctr">
-                    <a:lnL w="9525" cap="flat" cmpd="sng" algn="ctr">
-                      <a:solidFill>
-                        <a:srgbClr val="E3E8EF"/>
-                      </a:solidFill>
-                      <a:prstDash val="solid"/>
-                      <a:round/>
-                      <a:headEnd type="none" w="med" len="med"/>
-                      <a:tailEnd type="none" w="med" len="med"/>
-                    </a:lnL>
-                    <a:lnR w="9525" cap="flat" cmpd="sng" algn="ctr">
-                      <a:solidFill>
-                        <a:srgbClr val="E3E8EF"/>
-                      </a:solidFill>
-                      <a:prstDash val="solid"/>
-                      <a:round/>
-                      <a:headEnd type="none" w="med" len="med"/>
-                      <a:tailEnd type="none" w="med" len="med"/>
-                    </a:lnR>
-                    <a:lnT w="9525" cap="flat" cmpd="sng" algn="ctr">
-                      <a:solidFill>
-                        <a:srgbClr val="E3E8EF"/>
-                      </a:solidFill>
-                      <a:prstDash val="solid"/>
-                      <a:round/>
-                      <a:headEnd type="none" w="med" len="med"/>
-                      <a:tailEnd type="none" w="med" len="med"/>
-                    </a:lnT>
-                    <a:lnB w="9525" cap="flat" cmpd="sng" algn="ctr">
-                      <a:solidFill>
-                        <a:srgbClr val="E3E8EF"/>
-                      </a:solidFill>
-                      <a:prstDash val="solid"/>
-                      <a:round/>
-                      <a:headEnd type="none" w="med" len="med"/>
-                      <a:tailEnd type="none" w="med" len="med"/>
-                    </a:lnB>
-                    <a:solidFill>
-                      <a:srgbClr val="132C43"/>
-                    </a:solidFill>
-                  </a:tcPr>
-                </a:tc>
-                <a:tc>
-                  <a:txBody>
-                    <a:bodyPr/>
-                    <a:lstStyle/>
-                    <a:p>
-                      <a:pPr algn="l" indent="0" marL="0">
-                        <a:buNone/>
-                      </a:pPr>
-                      <a:r>
-                        <a:rPr lang="en-US" sz="1100" b="1" dirty="0">
-                          <a:solidFill>
-                            <a:srgbClr val="FFFFFF"/>
-                          </a:solidFill>
-                          <a:latin typeface="Calibri" pitchFamily="34" charset="0"/>
-                          <a:ea typeface="Calibri" pitchFamily="34" charset="-122"/>
-                          <a:cs typeface="Calibri" pitchFamily="34" charset="-120"/>
-                        </a:rPr>
-                        <a:t>Evidence</a:t>
-                      </a:r>
-                      <a:endParaRPr lang="en-US" sz="1100" dirty="0">
-                        <a:latin typeface="Calibri" charset="0"/>
-                        <a:ea typeface="Calibri" charset="0"/>
-                        <a:cs typeface="Calibri" charset="0"/>
-                      </a:endParaRPr>
-                    </a:p>
-                  </a:txBody>
-                  <a:tcPr marL="63500" marR="63500" marT="25400" marB="25400" anchor="ctr">
-                    <a:lnL w="9525" cap="flat" cmpd="sng" algn="ctr">
-                      <a:solidFill>
-                        <a:srgbClr val="E3E8EF"/>
-                      </a:solidFill>
-                      <a:prstDash val="solid"/>
-                      <a:round/>
-                      <a:headEnd type="none" w="med" len="med"/>
-                      <a:tailEnd type="none" w="med" len="med"/>
-                    </a:lnL>
-                    <a:lnR w="9525" cap="flat" cmpd="sng" algn="ctr">
-                      <a:solidFill>
-                        <a:srgbClr val="E3E8EF"/>
-                      </a:solidFill>
-                      <a:prstDash val="solid"/>
-                      <a:round/>
-                      <a:headEnd type="none" w="med" len="med"/>
-                      <a:tailEnd type="none" w="med" len="med"/>
-                    </a:lnR>
-                    <a:lnT w="9525" cap="flat" cmpd="sng" algn="ctr">
-                      <a:solidFill>
-                        <a:srgbClr val="E3E8EF"/>
-                      </a:solidFill>
-                      <a:prstDash val="solid"/>
-                      <a:round/>
-                      <a:headEnd type="none" w="med" len="med"/>
-                      <a:tailEnd type="none" w="med" len="med"/>
-                    </a:lnT>
-                    <a:lnB w="9525" cap="flat" cmpd="sng" algn="ctr">
-                      <a:solidFill>
-                        <a:srgbClr val="E3E8EF"/>
-                      </a:solidFill>
-                      <a:prstDash val="solid"/>
-                      <a:round/>
-                      <a:headEnd type="none" w="med" len="med"/>
-                      <a:tailEnd type="none" w="med" len="med"/>
-                    </a:lnB>
-                    <a:solidFill>
-                      <a:srgbClr val="132C43"/>
-                    </a:solidFill>
-                  </a:tcPr>
-                </a:tc>
-              </a:tr>
-              <a:tr h="621792">
-                <a:tc>
-                  <a:txBody>
-                    <a:bodyPr/>
-                    <a:lstStyle/>
-                    <a:p>
-                      <a:pPr algn="l" indent="0" marL="0">
-                        <a:buNone/>
-                      </a:pPr>
-                      <a:r>
-                        <a:rPr lang="en-US" sz="1100" b="1" dirty="0">
-                          <a:solidFill>
-                            <a:srgbClr val="1F2D3D"/>
-                          </a:solidFill>
-                          <a:latin typeface="Calibri" pitchFamily="34" charset="0"/>
-                          <a:ea typeface="Calibri" pitchFamily="34" charset="-122"/>
-                          <a:cs typeface="Calibri" pitchFamily="34" charset="-120"/>
-                        </a:rPr>
-                        <a:t>Aditya Monish Kumar K - CB.SC.U4CSE23103</a:t>
-                      </a:r>
-                      <a:endParaRPr lang="en-US" sz="1100" dirty="0">
-                        <a:latin typeface="Calibri" charset="0"/>
-                        <a:ea typeface="Calibri" charset="0"/>
-                        <a:cs typeface="Calibri" charset="0"/>
-                      </a:endParaRPr>
-                    </a:p>
-                  </a:txBody>
-                  <a:tcPr marL="63500" marR="63500" marT="25400" marB="25400" anchor="ctr">
-                    <a:lnL w="9525" cap="flat" cmpd="sng" algn="ctr">
-                      <a:solidFill>
-                        <a:srgbClr val="E3E8EF"/>
-                      </a:solidFill>
-                      <a:prstDash val="solid"/>
-                      <a:round/>
-                      <a:headEnd type="none" w="med" len="med"/>
-                      <a:tailEnd type="none" w="med" len="med"/>
-                    </a:lnL>
-                    <a:lnR w="9525" cap="flat" cmpd="sng" algn="ctr">
-                      <a:solidFill>
-                        <a:srgbClr val="E3E8EF"/>
-                      </a:solidFill>
-                      <a:prstDash val="solid"/>
-                      <a:round/>
-                      <a:headEnd type="none" w="med" len="med"/>
-                      <a:tailEnd type="none" w="med" len="med"/>
-                    </a:lnR>
-                    <a:lnT w="9525" cap="flat" cmpd="sng" algn="ctr">
-                      <a:solidFill>
-                        <a:srgbClr val="E3E8EF"/>
-                      </a:solidFill>
-                      <a:prstDash val="solid"/>
-                      <a:round/>
-                      <a:headEnd type="none" w="med" len="med"/>
-                      <a:tailEnd type="none" w="med" len="med"/>
-                    </a:lnT>
-                    <a:lnB w="9525" cap="flat" cmpd="sng" algn="ctr">
-                      <a:solidFill>
-                        <a:srgbClr val="E3E8EF"/>
-                      </a:solidFill>
-                      <a:prstDash val="solid"/>
-                      <a:round/>
-                      <a:headEnd type="none" w="med" len="med"/>
-                      <a:tailEnd type="none" w="med" len="med"/>
-                    </a:lnB>
-                    <a:solidFill>
-                      <a:srgbClr val="FFFFFF"/>
-                    </a:solidFill>
-                  </a:tcPr>
-                </a:tc>
-                <a:tc>
-                  <a:txBody>
-                    <a:bodyPr/>
-                    <a:lstStyle/>
-                    <a:p>
-                      <a:pPr algn="ctr" indent="0" marL="0">
-                        <a:buNone/>
-                      </a:pPr>
-                      <a:r>
-                        <a:rPr lang="en-US" sz="1100" dirty="0">
-                          <a:solidFill>
-                            <a:srgbClr val="1F2D3D"/>
-                          </a:solidFill>
-                          <a:latin typeface="Calibri" pitchFamily="34" charset="0"/>
-                          <a:ea typeface="Calibri" pitchFamily="34" charset="-122"/>
-                          <a:cs typeface="Calibri" pitchFamily="34" charset="-120"/>
-                        </a:rPr>
-                        <a:t>1 and 6</a:t>
-                      </a:r>
-                      <a:endParaRPr lang="en-US" sz="1100" dirty="0">
-                        <a:latin typeface="Calibri" charset="0"/>
-                        <a:ea typeface="Calibri" charset="0"/>
-                        <a:cs typeface="Calibri" charset="0"/>
-                      </a:endParaRPr>
-                    </a:p>
-                  </a:txBody>
-                  <a:tcPr marL="63500" marR="63500" marT="25400" marB="25400" anchor="ctr">
-                    <a:lnL w="9525" cap="flat" cmpd="sng" algn="ctr">
-                      <a:solidFill>
-                        <a:srgbClr val="E3E8EF"/>
-                      </a:solidFill>
-                      <a:prstDash val="solid"/>
-                      <a:round/>
-                      <a:headEnd type="none" w="med" len="med"/>
-                      <a:tailEnd type="none" w="med" len="med"/>
-                    </a:lnL>
-                    <a:lnR w="9525" cap="flat" cmpd="sng" algn="ctr">
-                      <a:solidFill>
-                        <a:srgbClr val="E3E8EF"/>
-                      </a:solidFill>
-                      <a:prstDash val="solid"/>
-                      <a:round/>
-                      <a:headEnd type="none" w="med" len="med"/>
-                      <a:tailEnd type="none" w="med" len="med"/>
-                    </a:lnR>
-                    <a:lnT w="9525" cap="flat" cmpd="sng" algn="ctr">
-                      <a:solidFill>
-                        <a:srgbClr val="E3E8EF"/>
-                      </a:solidFill>
-                      <a:prstDash val="solid"/>
-                      <a:round/>
-                      <a:headEnd type="none" w="med" len="med"/>
-                      <a:tailEnd type="none" w="med" len="med"/>
-                    </a:lnT>
-                    <a:lnB w="9525" cap="flat" cmpd="sng" algn="ctr">
-                      <a:solidFill>
-                        <a:srgbClr val="E3E8EF"/>
-                      </a:solidFill>
-                      <a:prstDash val="solid"/>
-                      <a:round/>
-                      <a:headEnd type="none" w="med" len="med"/>
-                      <a:tailEnd type="none" w="med" len="med"/>
-                    </a:lnB>
-                    <a:solidFill>
-                      <a:srgbClr val="FFFFFF"/>
-                    </a:solidFill>
-                  </a:tcPr>
-                </a:tc>
-                <a:tc>
-                  <a:txBody>
-                    <a:bodyPr/>
-                    <a:lstStyle/>
-                    <a:p>
-                      <a:pPr algn="l" indent="0" marL="0">
-                        <a:buNone/>
-                      </a:pPr>
-                      <a:r>
-                        <a:rPr lang="en-US" sz="1100" dirty="0">
-                          <a:solidFill>
-                            <a:srgbClr val="1F2D3D"/>
-                          </a:solidFill>
-                          <a:latin typeface="Calibri" pitchFamily="34" charset="0"/>
-                          <a:ea typeface="Calibri" pitchFamily="34" charset="-122"/>
-                          <a:cs typeface="Calibri" pitchFamily="34" charset="-120"/>
-                        </a:rPr>
-                        <a:t>#131 time series and patterns, #132 text preprocessing, #133 dashboard skeleton and overview; Stage 6: deck, final report, contribution summary</a:t>
-                      </a:r>
-                      <a:endParaRPr lang="en-US" sz="1100" dirty="0">
-                        <a:latin typeface="Calibri" charset="0"/>
-                        <a:ea typeface="Calibri" charset="0"/>
-                        <a:cs typeface="Calibri" charset="0"/>
-                      </a:endParaRPr>
-                    </a:p>
-                  </a:txBody>
-                  <a:tcPr marL="63500" marR="63500" marT="25400" marB="25400" anchor="ctr">
-                    <a:lnL w="9525" cap="flat" cmpd="sng" algn="ctr">
-                      <a:solidFill>
-                        <a:srgbClr val="E3E8EF"/>
-                      </a:solidFill>
-                      <a:prstDash val="solid"/>
-                      <a:round/>
-                      <a:headEnd type="none" w="med" len="med"/>
-                      <a:tailEnd type="none" w="med" len="med"/>
-                    </a:lnL>
-                    <a:lnR w="9525" cap="flat" cmpd="sng" algn="ctr">
-                      <a:solidFill>
-                        <a:srgbClr val="E3E8EF"/>
-                      </a:solidFill>
-                      <a:prstDash val="solid"/>
-                      <a:round/>
-                      <a:headEnd type="none" w="med" len="med"/>
-                      <a:tailEnd type="none" w="med" len="med"/>
-                    </a:lnR>
-                    <a:lnT w="9525" cap="flat" cmpd="sng" algn="ctr">
-                      <a:solidFill>
-                        <a:srgbClr val="E3E8EF"/>
-                      </a:solidFill>
-                      <a:prstDash val="solid"/>
-                      <a:round/>
-                      <a:headEnd type="none" w="med" len="med"/>
-                      <a:tailEnd type="none" w="med" len="med"/>
-                    </a:lnT>
-                    <a:lnB w="9525" cap="flat" cmpd="sng" algn="ctr">
-                      <a:solidFill>
-                        <a:srgbClr val="E3E8EF"/>
-                      </a:solidFill>
-                      <a:prstDash val="solid"/>
-                      <a:round/>
-                      <a:headEnd type="none" w="med" len="med"/>
-                      <a:tailEnd type="none" w="med" len="med"/>
-                    </a:lnB>
-                    <a:solidFill>
-                      <a:srgbClr val="FFFFFF"/>
-                    </a:solidFill>
-                  </a:tcPr>
-                </a:tc>
-                <a:tc>
-                  <a:txBody>
-                    <a:bodyPr/>
-                    <a:lstStyle/>
-                    <a:p>
-                      <a:pPr algn="l" indent="0" marL="0">
-                        <a:buNone/>
-                      </a:pPr>
-                      <a:r>
-                        <a:rPr lang="en-US" sz="1100" dirty="0">
-                          <a:solidFill>
-                            <a:srgbClr val="1F2D3D"/>
-                          </a:solidFill>
-                          <a:latin typeface="Calibri" pitchFamily="34" charset="0"/>
-                          <a:ea typeface="Calibri" pitchFamily="34" charset="-122"/>
-                          <a:cs typeface="Calibri" pitchFamily="34" charset="-120"/>
-                        </a:rPr>
-                        <a:t>#147, #148, #149 (8 Oct)</a:t>
-                      </a:r>
-                      <a:endParaRPr lang="en-US" sz="1100" dirty="0">
-                        <a:latin typeface="Calibri" charset="0"/>
-                        <a:ea typeface="Calibri" charset="0"/>
-                        <a:cs typeface="Calibri" charset="0"/>
-                      </a:endParaRPr>
-                    </a:p>
-                  </a:txBody>
-                  <a:tcPr marL="63500" marR="63500" marT="25400" marB="25400" anchor="ctr">
-                    <a:lnL w="9525" cap="flat" cmpd="sng" algn="ctr">
-                      <a:solidFill>
-                        <a:srgbClr val="E3E8EF"/>
-                      </a:solidFill>
-                      <a:prstDash val="solid"/>
-                      <a:round/>
-                      <a:headEnd type="none" w="med" len="med"/>
-                      <a:tailEnd type="none" w="med" len="med"/>
-                    </a:lnL>
-                    <a:lnR w="9525" cap="flat" cmpd="sng" algn="ctr">
-                      <a:solidFill>
-                        <a:srgbClr val="E3E8EF"/>
-                      </a:solidFill>
-                      <a:prstDash val="solid"/>
-                      <a:round/>
-                      <a:headEnd type="none" w="med" len="med"/>
-                      <a:tailEnd type="none" w="med" len="med"/>
-                    </a:lnR>
-                    <a:lnT w="9525" cap="flat" cmpd="sng" algn="ctr">
-                      <a:solidFill>
-                        <a:srgbClr val="E3E8EF"/>
-                      </a:solidFill>
-                      <a:prstDash val="solid"/>
-                      <a:round/>
-                      <a:headEnd type="none" w="med" len="med"/>
-                      <a:tailEnd type="none" w="med" len="med"/>
-                    </a:lnT>
-                    <a:lnB w="9525" cap="flat" cmpd="sng" algn="ctr">
-                      <a:solidFill>
-                        <a:srgbClr val="E3E8EF"/>
-                      </a:solidFill>
-                      <a:prstDash val="solid"/>
-                      <a:round/>
-                      <a:headEnd type="none" w="med" len="med"/>
-                      <a:tailEnd type="none" w="med" len="med"/>
-                    </a:lnB>
-                    <a:solidFill>
-                      <a:srgbClr val="FFFFFF"/>
-                    </a:solidFill>
-                  </a:tcPr>
-                </a:tc>
-                <a:tc>
-                  <a:txBody>
-                    <a:bodyPr/>
-                    <a:lstStyle/>
-                    <a:p>
-                      <a:pPr algn="l" indent="0" marL="0">
-                        <a:buNone/>
-                      </a:pPr>
-                      <a:r>
-                        <a:rPr lang="en-US" sz="1100" dirty="0">
-                          <a:solidFill>
-                            <a:srgbClr val="1F2D3D"/>
-                          </a:solidFill>
-                          <a:latin typeface="Calibri" pitchFamily="34" charset="0"/>
-                          <a:ea typeface="Calibri" pitchFamily="34" charset="-122"/>
-                          <a:cs typeface="Calibri" pitchFamily="34" charset="-120"/>
-                        </a:rPr>
-                        <a:t>scripts 15–16, dashboard/, FINAL_REPORT.md</a:t>
-                      </a:r>
-                      <a:endParaRPr lang="en-US" sz="1100" dirty="0">
-                        <a:latin typeface="Calibri" charset="0"/>
-                        <a:ea typeface="Calibri" charset="0"/>
-                        <a:cs typeface="Calibri" charset="0"/>
-                      </a:endParaRPr>
-                    </a:p>
-                  </a:txBody>
-                  <a:tcPr marL="63500" marR="63500" marT="25400" marB="25400" anchor="ctr">
-                    <a:lnL w="9525" cap="flat" cmpd="sng" algn="ctr">
-                      <a:solidFill>
-                        <a:srgbClr val="E3E8EF"/>
-                      </a:solidFill>
-                      <a:prstDash val="solid"/>
-                      <a:round/>
-                      <a:headEnd type="none" w="med" len="med"/>
-                      <a:tailEnd type="none" w="med" len="med"/>
-                    </a:lnL>
-                    <a:lnR w="9525" cap="flat" cmpd="sng" algn="ctr">
-                      <a:solidFill>
-                        <a:srgbClr val="E3E8EF"/>
-                      </a:solidFill>
-                      <a:prstDash val="solid"/>
-                      <a:round/>
-                      <a:headEnd type="none" w="med" len="med"/>
-                      <a:tailEnd type="none" w="med" len="med"/>
-                    </a:lnR>
-                    <a:lnT w="9525" cap="flat" cmpd="sng" algn="ctr">
-                      <a:solidFill>
-                        <a:srgbClr val="E3E8EF"/>
-                      </a:solidFill>
-                      <a:prstDash val="solid"/>
-                      <a:round/>
-                      <a:headEnd type="none" w="med" len="med"/>
-                      <a:tailEnd type="none" w="med" len="med"/>
-                    </a:lnT>
-                    <a:lnB w="9525" cap="flat" cmpd="sng" algn="ctr">
-                      <a:solidFill>
-                        <a:srgbClr val="E3E8EF"/>
-                      </a:solidFill>
-                      <a:prstDash val="solid"/>
-                      <a:round/>
-                      <a:headEnd type="none" w="med" len="med"/>
-                      <a:tailEnd type="none" w="med" len="med"/>
-                    </a:lnB>
-                    <a:solidFill>
-                      <a:srgbClr val="FFFFFF"/>
-                    </a:solidFill>
-                  </a:tcPr>
-                </a:tc>
-              </a:tr>
-              <a:tr h="548640">
-                <a:tc>
-                  <a:txBody>
-                    <a:bodyPr/>
-                    <a:lstStyle/>
-                    <a:p>
-                      <a:pPr algn="l" indent="0" marL="0">
-                        <a:buNone/>
-                      </a:pPr>
-                      <a:r>
-                        <a:rPr lang="en-US" sz="1100" b="1" dirty="0">
-                          <a:solidFill>
-                            <a:srgbClr val="1F2D3D"/>
-                          </a:solidFill>
-                          <a:latin typeface="Calibri" pitchFamily="34" charset="0"/>
-                          <a:ea typeface="Calibri" pitchFamily="34" charset="-122"/>
-                          <a:cs typeface="Calibri" pitchFamily="34" charset="-120"/>
-                        </a:rPr>
-                        <a:t>Regella Krishna Saketh - CB.SC.U4CSE23649</a:t>
-                      </a:r>
-                      <a:endParaRPr lang="en-US" sz="1100" dirty="0">
-                        <a:latin typeface="Calibri" charset="0"/>
-                        <a:ea typeface="Calibri" charset="0"/>
-                        <a:cs typeface="Calibri" charset="0"/>
-                      </a:endParaRPr>
-                    </a:p>
-                  </a:txBody>
-                  <a:tcPr marL="63500" marR="63500" marT="25400" marB="25400" anchor="ctr">
-                    <a:lnL w="9525" cap="flat" cmpd="sng" algn="ctr">
-                      <a:solidFill>
-                        <a:srgbClr val="E3E8EF"/>
-                      </a:solidFill>
-                      <a:prstDash val="solid"/>
-                      <a:round/>
-                      <a:headEnd type="none" w="med" len="med"/>
-                      <a:tailEnd type="none" w="med" len="med"/>
-                    </a:lnL>
-                    <a:lnR w="9525" cap="flat" cmpd="sng" algn="ctr">
-                      <a:solidFill>
-                        <a:srgbClr val="E3E8EF"/>
-                      </a:solidFill>
-                      <a:prstDash val="solid"/>
-                      <a:round/>
-                      <a:headEnd type="none" w="med" len="med"/>
-                      <a:tailEnd type="none" w="med" len="med"/>
-                    </a:lnR>
-                    <a:lnT w="9525" cap="flat" cmpd="sng" algn="ctr">
-                      <a:solidFill>
-                        <a:srgbClr val="E3E8EF"/>
-                      </a:solidFill>
-                      <a:prstDash val="solid"/>
-                      <a:round/>
-                      <a:headEnd type="none" w="med" len="med"/>
-                      <a:tailEnd type="none" w="med" len="med"/>
-                    </a:lnT>
-                    <a:lnB w="9525" cap="flat" cmpd="sng" algn="ctr">
-                      <a:solidFill>
-                        <a:srgbClr val="E3E8EF"/>
-                      </a:solidFill>
-                      <a:prstDash val="solid"/>
-                      <a:round/>
-                      <a:headEnd type="none" w="med" len="med"/>
-                      <a:tailEnd type="none" w="med" len="med"/>
-                    </a:lnB>
-                    <a:solidFill>
-                      <a:srgbClr val="FBFCFE"/>
-                    </a:solidFill>
-                  </a:tcPr>
-                </a:tc>
-                <a:tc>
-                  <a:txBody>
-                    <a:bodyPr/>
-                    <a:lstStyle/>
-                    <a:p>
-                      <a:pPr algn="ctr" indent="0" marL="0">
-                        <a:buNone/>
-                      </a:pPr>
-                      <a:r>
-                        <a:rPr lang="en-US" sz="1100" dirty="0">
-                          <a:solidFill>
-                            <a:srgbClr val="1F2D3D"/>
-                          </a:solidFill>
-                          <a:latin typeface="Calibri" pitchFamily="34" charset="0"/>
-                          <a:ea typeface="Calibri" pitchFamily="34" charset="-122"/>
-                          <a:cs typeface="Calibri" pitchFamily="34" charset="-120"/>
-                        </a:rPr>
-                        <a:t>2</a:t>
-                      </a:r>
-                      <a:endParaRPr lang="en-US" sz="1100" dirty="0">
-                        <a:latin typeface="Calibri" charset="0"/>
-                        <a:ea typeface="Calibri" charset="0"/>
-                        <a:cs typeface="Calibri" charset="0"/>
-                      </a:endParaRPr>
-                    </a:p>
-                  </a:txBody>
-                  <a:tcPr marL="63500" marR="63500" marT="25400" marB="25400" anchor="ctr">
-                    <a:lnL w="9525" cap="flat" cmpd="sng" algn="ctr">
-                      <a:solidFill>
-                        <a:srgbClr val="E3E8EF"/>
-                      </a:solidFill>
-                      <a:prstDash val="solid"/>
-                      <a:round/>
-                      <a:headEnd type="none" w="med" len="med"/>
-                      <a:tailEnd type="none" w="med" len="med"/>
-                    </a:lnL>
-                    <a:lnR w="9525" cap="flat" cmpd="sng" algn="ctr">
-                      <a:solidFill>
-                        <a:srgbClr val="E3E8EF"/>
-                      </a:solidFill>
-                      <a:prstDash val="solid"/>
-                      <a:round/>
-                      <a:headEnd type="none" w="med" len="med"/>
-                      <a:tailEnd type="none" w="med" len="med"/>
-                    </a:lnR>
-                    <a:lnT w="9525" cap="flat" cmpd="sng" algn="ctr">
-                      <a:solidFill>
-                        <a:srgbClr val="E3E8EF"/>
-                      </a:solidFill>
-                      <a:prstDash val="solid"/>
-                      <a:round/>
-                      <a:headEnd type="none" w="med" len="med"/>
-                      <a:tailEnd type="none" w="med" len="med"/>
-                    </a:lnT>
-                    <a:lnB w="9525" cap="flat" cmpd="sng" algn="ctr">
-                      <a:solidFill>
-                        <a:srgbClr val="E3E8EF"/>
-                      </a:solidFill>
-                      <a:prstDash val="solid"/>
-                      <a:round/>
-                      <a:headEnd type="none" w="med" len="med"/>
-                      <a:tailEnd type="none" w="med" len="med"/>
-                    </a:lnB>
-                    <a:solidFill>
-                      <a:srgbClr val="FBFCFE"/>
-                    </a:solidFill>
-                  </a:tcPr>
-                </a:tc>
-                <a:tc>
-                  <a:txBody>
-                    <a:bodyPr/>
-                    <a:lstStyle/>
-                    <a:p>
-                      <a:pPr algn="l" indent="0" marL="0">
-                        <a:buNone/>
-                      </a:pPr>
-                      <a:r>
-                        <a:rPr lang="en-US" sz="1100" dirty="0">
-                          <a:solidFill>
-                            <a:srgbClr val="1F2D3D"/>
-                          </a:solidFill>
-                          <a:latin typeface="Calibri" pitchFamily="34" charset="0"/>
-                          <a:ea typeface="Calibri" pitchFamily="34" charset="-122"/>
-                          <a:cs typeface="Calibri" pitchFamily="34" charset="-120"/>
-                        </a:rPr>
-                        <a:t>#134 topic modelling and distinctive terms, #136 topic evaluation and interpretation</a:t>
-                      </a:r>
-                      <a:endParaRPr lang="en-US" sz="1100" dirty="0">
-                        <a:latin typeface="Calibri" charset="0"/>
-                        <a:ea typeface="Calibri" charset="0"/>
-                        <a:cs typeface="Calibri" charset="0"/>
-                      </a:endParaRPr>
-                    </a:p>
-                  </a:txBody>
-                  <a:tcPr marL="63500" marR="63500" marT="25400" marB="25400" anchor="ctr">
-                    <a:lnL w="9525" cap="flat" cmpd="sng" algn="ctr">
-                      <a:solidFill>
-                        <a:srgbClr val="E3E8EF"/>
-                      </a:solidFill>
-                      <a:prstDash val="solid"/>
-                      <a:round/>
-                      <a:headEnd type="none" w="med" len="med"/>
-                      <a:tailEnd type="none" w="med" len="med"/>
-                    </a:lnL>
-                    <a:lnR w="9525" cap="flat" cmpd="sng" algn="ctr">
-                      <a:solidFill>
-                        <a:srgbClr val="E3E8EF"/>
-                      </a:solidFill>
-                      <a:prstDash val="solid"/>
-                      <a:round/>
-                      <a:headEnd type="none" w="med" len="med"/>
-                      <a:tailEnd type="none" w="med" len="med"/>
-                    </a:lnR>
-                    <a:lnT w="9525" cap="flat" cmpd="sng" algn="ctr">
-                      <a:solidFill>
-                        <a:srgbClr val="E3E8EF"/>
-                      </a:solidFill>
-                      <a:prstDash val="solid"/>
-                      <a:round/>
-                      <a:headEnd type="none" w="med" len="med"/>
-                      <a:tailEnd type="none" w="med" len="med"/>
-                    </a:lnT>
-                    <a:lnB w="9525" cap="flat" cmpd="sng" algn="ctr">
-                      <a:solidFill>
-                        <a:srgbClr val="E3E8EF"/>
-                      </a:solidFill>
-                      <a:prstDash val="solid"/>
-                      <a:round/>
-                      <a:headEnd type="none" w="med" len="med"/>
-                      <a:tailEnd type="none" w="med" len="med"/>
-                    </a:lnB>
-                    <a:solidFill>
-                      <a:srgbClr val="FBFCFE"/>
-                    </a:solidFill>
-                  </a:tcPr>
-                </a:tc>
-                <a:tc>
-                  <a:txBody>
-                    <a:bodyPr/>
-                    <a:lstStyle/>
-                    <a:p>
-                      <a:pPr algn="l" indent="0" marL="0">
-                        <a:buNone/>
-                      </a:pPr>
-                      <a:r>
-                        <a:rPr lang="en-US" sz="1100" dirty="0">
-                          <a:solidFill>
-                            <a:srgbClr val="1F2D3D"/>
-                          </a:solidFill>
-                          <a:latin typeface="Calibri" pitchFamily="34" charset="0"/>
-                          <a:ea typeface="Calibri" pitchFamily="34" charset="-122"/>
-                          <a:cs typeface="Calibri" pitchFamily="34" charset="-120"/>
-                        </a:rPr>
-                        <a:t>#150, #151 (8 Oct)</a:t>
-                      </a:r>
-                      <a:endParaRPr lang="en-US" sz="1100" dirty="0">
-                        <a:latin typeface="Calibri" charset="0"/>
-                        <a:ea typeface="Calibri" charset="0"/>
-                        <a:cs typeface="Calibri" charset="0"/>
-                      </a:endParaRPr>
-                    </a:p>
-                  </a:txBody>
-                  <a:tcPr marL="63500" marR="63500" marT="25400" marB="25400" anchor="ctr">
-                    <a:lnL w="9525" cap="flat" cmpd="sng" algn="ctr">
-                      <a:solidFill>
-                        <a:srgbClr val="E3E8EF"/>
-                      </a:solidFill>
-                      <a:prstDash val="solid"/>
-                      <a:round/>
-                      <a:headEnd type="none" w="med" len="med"/>
-                      <a:tailEnd type="none" w="med" len="med"/>
-                    </a:lnL>
-                    <a:lnR w="9525" cap="flat" cmpd="sng" algn="ctr">
-                      <a:solidFill>
-                        <a:srgbClr val="E3E8EF"/>
-                      </a:solidFill>
-                      <a:prstDash val="solid"/>
-                      <a:round/>
-                      <a:headEnd type="none" w="med" len="med"/>
-                      <a:tailEnd type="none" w="med" len="med"/>
-                    </a:lnR>
-                    <a:lnT w="9525" cap="flat" cmpd="sng" algn="ctr">
-                      <a:solidFill>
-                        <a:srgbClr val="E3E8EF"/>
-                      </a:solidFill>
-                      <a:prstDash val="solid"/>
-                      <a:round/>
-                      <a:headEnd type="none" w="med" len="med"/>
-                      <a:tailEnd type="none" w="med" len="med"/>
-                    </a:lnT>
-                    <a:lnB w="9525" cap="flat" cmpd="sng" algn="ctr">
-                      <a:solidFill>
-                        <a:srgbClr val="E3E8EF"/>
-                      </a:solidFill>
-                      <a:prstDash val="solid"/>
-                      <a:round/>
-                      <a:headEnd type="none" w="med" len="med"/>
-                      <a:tailEnd type="none" w="med" len="med"/>
-                    </a:lnB>
-                    <a:solidFill>
-                      <a:srgbClr val="FBFCFE"/>
-                    </a:solidFill>
-                  </a:tcPr>
-                </a:tc>
-                <a:tc>
-                  <a:txBody>
-                    <a:bodyPr/>
-                    <a:lstStyle/>
-                    <a:p>
-                      <a:pPr algn="l" indent="0" marL="0">
-                        <a:buNone/>
-                      </a:pPr>
-                      <a:r>
-                        <a:rPr lang="en-US" sz="1100" dirty="0">
-                          <a:solidFill>
-                            <a:srgbClr val="1F2D3D"/>
-                          </a:solidFill>
-                          <a:latin typeface="Calibri" pitchFamily="34" charset="0"/>
-                          <a:ea typeface="Calibri" pitchFamily="34" charset="-122"/>
-                          <a:cs typeface="Calibri" pitchFamily="34" charset="-120"/>
-                        </a:rPr>
-                        <a:t>scripts 17–18, models/textmining/, TEXT_MINING.md §2–3</a:t>
-                      </a:r>
-                      <a:endParaRPr lang="en-US" sz="1100" dirty="0">
-                        <a:latin typeface="Calibri" charset="0"/>
-                        <a:ea typeface="Calibri" charset="0"/>
-                        <a:cs typeface="Calibri" charset="0"/>
-                      </a:endParaRPr>
-                    </a:p>
-                  </a:txBody>
-                  <a:tcPr marL="63500" marR="63500" marT="25400" marB="25400" anchor="ctr">
-                    <a:lnL w="9525" cap="flat" cmpd="sng" algn="ctr">
-                      <a:solidFill>
-                        <a:srgbClr val="E3E8EF"/>
-                      </a:solidFill>
-                      <a:prstDash val="solid"/>
-                      <a:round/>
-                      <a:headEnd type="none" w="med" len="med"/>
-                      <a:tailEnd type="none" w="med" len="med"/>
-                    </a:lnL>
-                    <a:lnR w="9525" cap="flat" cmpd="sng" algn="ctr">
-                      <a:solidFill>
-                        <a:srgbClr val="E3E8EF"/>
-                      </a:solidFill>
-                      <a:prstDash val="solid"/>
-                      <a:round/>
-                      <a:headEnd type="none" w="med" len="med"/>
-                      <a:tailEnd type="none" w="med" len="med"/>
-                    </a:lnR>
-                    <a:lnT w="9525" cap="flat" cmpd="sng" algn="ctr">
-                      <a:solidFill>
-                        <a:srgbClr val="E3E8EF"/>
-                      </a:solidFill>
-                      <a:prstDash val="solid"/>
-                      <a:round/>
-                      <a:headEnd type="none" w="med" len="med"/>
-                      <a:tailEnd type="none" w="med" len="med"/>
-                    </a:lnT>
-                    <a:lnB w="9525" cap="flat" cmpd="sng" algn="ctr">
-                      <a:solidFill>
-                        <a:srgbClr val="E3E8EF"/>
-                      </a:solidFill>
-                      <a:prstDash val="solid"/>
-                      <a:round/>
-                      <a:headEnd type="none" w="med" len="med"/>
-                      <a:tailEnd type="none" w="med" len="med"/>
-                    </a:lnB>
-                    <a:solidFill>
-                      <a:srgbClr val="FBFCFE"/>
-                    </a:solidFill>
-                  </a:tcPr>
-                </a:tc>
-              </a:tr>
-              <a:tr h="621792">
-                <a:tc>
-                  <a:txBody>
-                    <a:bodyPr/>
-                    <a:lstStyle/>
-                    <a:p>
-                      <a:pPr algn="l" indent="0" marL="0">
-                        <a:buNone/>
-                      </a:pPr>
-                      <a:r>
-                        <a:rPr lang="en-US" sz="1100" b="1" dirty="0">
-                          <a:solidFill>
-                            <a:srgbClr val="1F2D3D"/>
-                          </a:solidFill>
-                          <a:latin typeface="Calibri" pitchFamily="34" charset="0"/>
-                          <a:ea typeface="Calibri" pitchFamily="34" charset="-122"/>
-                          <a:cs typeface="Calibri" pitchFamily="34" charset="-120"/>
-                        </a:rPr>
-                        <a:t>Akshay KS - CB.SC.U4CSE23104</a:t>
-                      </a:r>
-                      <a:endParaRPr lang="en-US" sz="1100" dirty="0">
-                        <a:latin typeface="Calibri" charset="0"/>
-                        <a:ea typeface="Calibri" charset="0"/>
-                        <a:cs typeface="Calibri" charset="0"/>
-                      </a:endParaRPr>
-                    </a:p>
-                  </a:txBody>
-                  <a:tcPr marL="63500" marR="63500" marT="25400" marB="25400" anchor="ctr">
-                    <a:lnL w="9525" cap="flat" cmpd="sng" algn="ctr">
-                      <a:solidFill>
-                        <a:srgbClr val="E3E8EF"/>
-                      </a:solidFill>
-                      <a:prstDash val="solid"/>
-                      <a:round/>
-                      <a:headEnd type="none" w="med" len="med"/>
-                      <a:tailEnd type="none" w="med" len="med"/>
-                    </a:lnL>
-                    <a:lnR w="9525" cap="flat" cmpd="sng" algn="ctr">
-                      <a:solidFill>
-                        <a:srgbClr val="E3E8EF"/>
-                      </a:solidFill>
-                      <a:prstDash val="solid"/>
-                      <a:round/>
-                      <a:headEnd type="none" w="med" len="med"/>
-                      <a:tailEnd type="none" w="med" len="med"/>
-                    </a:lnR>
-                    <a:lnT w="9525" cap="flat" cmpd="sng" algn="ctr">
-                      <a:solidFill>
-                        <a:srgbClr val="E3E8EF"/>
-                      </a:solidFill>
-                      <a:prstDash val="solid"/>
-                      <a:round/>
-                      <a:headEnd type="none" w="med" len="med"/>
-                      <a:tailEnd type="none" w="med" len="med"/>
-                    </a:lnT>
-                    <a:lnB w="9525" cap="flat" cmpd="sng" algn="ctr">
-                      <a:solidFill>
-                        <a:srgbClr val="E3E8EF"/>
-                      </a:solidFill>
-                      <a:prstDash val="solid"/>
-                      <a:round/>
-                      <a:headEnd type="none" w="med" len="med"/>
-                      <a:tailEnd type="none" w="med" len="med"/>
-                    </a:lnB>
-                    <a:solidFill>
-                      <a:srgbClr val="FFFFFF"/>
-                    </a:solidFill>
-                  </a:tcPr>
-                </a:tc>
-                <a:tc>
-                  <a:txBody>
-                    <a:bodyPr/>
-                    <a:lstStyle/>
-                    <a:p>
-                      <a:pPr algn="ctr" indent="0" marL="0">
-                        <a:buNone/>
-                      </a:pPr>
-                      <a:r>
-                        <a:rPr lang="en-US" sz="1100" dirty="0">
-                          <a:solidFill>
-                            <a:srgbClr val="1F2D3D"/>
-                          </a:solidFill>
-                          <a:latin typeface="Calibri" pitchFamily="34" charset="0"/>
-                          <a:ea typeface="Calibri" pitchFamily="34" charset="-122"/>
-                          <a:cs typeface="Calibri" pitchFamily="34" charset="-120"/>
-                        </a:rPr>
-                        <a:t>3</a:t>
-                      </a:r>
-                      <a:endParaRPr lang="en-US" sz="1100" dirty="0">
-                        <a:latin typeface="Calibri" charset="0"/>
-                        <a:ea typeface="Calibri" charset="0"/>
-                        <a:cs typeface="Calibri" charset="0"/>
-                      </a:endParaRPr>
-                    </a:p>
-                  </a:txBody>
-                  <a:tcPr marL="63500" marR="63500" marT="25400" marB="25400" anchor="ctr">
-                    <a:lnL w="9525" cap="flat" cmpd="sng" algn="ctr">
-                      <a:solidFill>
-                        <a:srgbClr val="E3E8EF"/>
-                      </a:solidFill>
-                      <a:prstDash val="solid"/>
-                      <a:round/>
-                      <a:headEnd type="none" w="med" len="med"/>
-                      <a:tailEnd type="none" w="med" len="med"/>
-                    </a:lnL>
-                    <a:lnR w="9525" cap="flat" cmpd="sng" algn="ctr">
-                      <a:solidFill>
-                        <a:srgbClr val="E3E8EF"/>
-                      </a:solidFill>
-                      <a:prstDash val="solid"/>
-                      <a:round/>
-                      <a:headEnd type="none" w="med" len="med"/>
-                      <a:tailEnd type="none" w="med" len="med"/>
-                    </a:lnR>
-                    <a:lnT w="9525" cap="flat" cmpd="sng" algn="ctr">
-                      <a:solidFill>
-                        <a:srgbClr val="E3E8EF"/>
-                      </a:solidFill>
-                      <a:prstDash val="solid"/>
-                      <a:round/>
-                      <a:headEnd type="none" w="med" len="med"/>
-                      <a:tailEnd type="none" w="med" len="med"/>
-                    </a:lnT>
-                    <a:lnB w="9525" cap="flat" cmpd="sng" algn="ctr">
-                      <a:solidFill>
-                        <a:srgbClr val="E3E8EF"/>
-                      </a:solidFill>
-                      <a:prstDash val="solid"/>
-                      <a:round/>
-                      <a:headEnd type="none" w="med" len="med"/>
-                      <a:tailEnd type="none" w="med" len="med"/>
-                    </a:lnB>
-                    <a:solidFill>
-                      <a:srgbClr val="FFFFFF"/>
-                    </a:solidFill>
-                  </a:tcPr>
-                </a:tc>
-                <a:tc>
-                  <a:txBody>
-                    <a:bodyPr/>
-                    <a:lstStyle/>
-                    <a:p>
-                      <a:pPr algn="l" indent="0" marL="0">
-                        <a:buNone/>
-                      </a:pPr>
-                      <a:r>
-                        <a:rPr lang="en-US" sz="1100" dirty="0">
-                          <a:solidFill>
-                            <a:srgbClr val="1F2D3D"/>
-                          </a:solidFill>
-                          <a:latin typeface="Calibri" pitchFamily="34" charset="0"/>
-                          <a:ea typeface="Calibri" pitchFamily="34" charset="-122"/>
-                          <a:cs typeface="Calibri" pitchFamily="34" charset="-120"/>
-                        </a:rPr>
-                        <a:t>#135 ARIMA forecasting with rolling backtest, #139 text-mining dashboard page</a:t>
-                      </a:r>
-                      <a:endParaRPr lang="en-US" sz="1100" dirty="0">
-                        <a:latin typeface="Calibri" charset="0"/>
-                        <a:ea typeface="Calibri" charset="0"/>
-                        <a:cs typeface="Calibri" charset="0"/>
-                      </a:endParaRPr>
-                    </a:p>
-                  </a:txBody>
-                  <a:tcPr marL="63500" marR="63500" marT="25400" marB="25400" anchor="ctr">
-                    <a:lnL w="9525" cap="flat" cmpd="sng" algn="ctr">
-                      <a:solidFill>
-                        <a:srgbClr val="E3E8EF"/>
-                      </a:solidFill>
-                      <a:prstDash val="solid"/>
-                      <a:round/>
-                      <a:headEnd type="none" w="med" len="med"/>
-                      <a:tailEnd type="none" w="med" len="med"/>
-                    </a:lnL>
-                    <a:lnR w="9525" cap="flat" cmpd="sng" algn="ctr">
-                      <a:solidFill>
-                        <a:srgbClr val="E3E8EF"/>
-                      </a:solidFill>
-                      <a:prstDash val="solid"/>
-                      <a:round/>
-                      <a:headEnd type="none" w="med" len="med"/>
-                      <a:tailEnd type="none" w="med" len="med"/>
-                    </a:lnR>
-                    <a:lnT w="9525" cap="flat" cmpd="sng" algn="ctr">
-                      <a:solidFill>
-                        <a:srgbClr val="E3E8EF"/>
-                      </a:solidFill>
-                      <a:prstDash val="solid"/>
-                      <a:round/>
-                      <a:headEnd type="none" w="med" len="med"/>
-                      <a:tailEnd type="none" w="med" len="med"/>
-                    </a:lnT>
-                    <a:lnB w="9525" cap="flat" cmpd="sng" algn="ctr">
-                      <a:solidFill>
-                        <a:srgbClr val="E3E8EF"/>
-                      </a:solidFill>
-                      <a:prstDash val="solid"/>
-                      <a:round/>
-                      <a:headEnd type="none" w="med" len="med"/>
-                      <a:tailEnd type="none" w="med" len="med"/>
-                    </a:lnB>
-                    <a:solidFill>
-                      <a:srgbClr val="FFFFFF"/>
-                    </a:solidFill>
-                  </a:tcPr>
-                </a:tc>
-                <a:tc>
-                  <a:txBody>
-                    <a:bodyPr/>
-                    <a:lstStyle/>
-                    <a:p>
-                      <a:pPr algn="l" indent="0" marL="0">
-                        <a:buNone/>
-                      </a:pPr>
-                      <a:r>
-                        <a:rPr lang="en-US" sz="1100" dirty="0">
-                          <a:solidFill>
-                            <a:srgbClr val="1F2D3D"/>
-                          </a:solidFill>
-                          <a:latin typeface="Calibri" pitchFamily="34" charset="0"/>
-                          <a:ea typeface="Calibri" pitchFamily="34" charset="-122"/>
-                          <a:cs typeface="Calibri" pitchFamily="34" charset="-120"/>
-                        </a:rPr>
-                        <a:t>#152, #153 (9 Oct)</a:t>
-                      </a:r>
-                      <a:endParaRPr lang="en-US" sz="1100" dirty="0">
-                        <a:latin typeface="Calibri" charset="0"/>
-                        <a:ea typeface="Calibri" charset="0"/>
-                        <a:cs typeface="Calibri" charset="0"/>
-                      </a:endParaRPr>
-                    </a:p>
-                  </a:txBody>
-                  <a:tcPr marL="63500" marR="63500" marT="25400" marB="25400" anchor="ctr">
-                    <a:lnL w="9525" cap="flat" cmpd="sng" algn="ctr">
-                      <a:solidFill>
-                        <a:srgbClr val="E3E8EF"/>
-                      </a:solidFill>
-                      <a:prstDash val="solid"/>
-                      <a:round/>
-                      <a:headEnd type="none" w="med" len="med"/>
-                      <a:tailEnd type="none" w="med" len="med"/>
-                    </a:lnL>
-                    <a:lnR w="9525" cap="flat" cmpd="sng" algn="ctr">
-                      <a:solidFill>
-                        <a:srgbClr val="E3E8EF"/>
-                      </a:solidFill>
-                      <a:prstDash val="solid"/>
-                      <a:round/>
-                      <a:headEnd type="none" w="med" len="med"/>
-                      <a:tailEnd type="none" w="med" len="med"/>
-                    </a:lnR>
-                    <a:lnT w="9525" cap="flat" cmpd="sng" algn="ctr">
-                      <a:solidFill>
-                        <a:srgbClr val="E3E8EF"/>
-                      </a:solidFill>
-                      <a:prstDash val="solid"/>
-                      <a:round/>
-                      <a:headEnd type="none" w="med" len="med"/>
-                      <a:tailEnd type="none" w="med" len="med"/>
-                    </a:lnT>
-                    <a:lnB w="9525" cap="flat" cmpd="sng" algn="ctr">
-                      <a:solidFill>
-                        <a:srgbClr val="E3E8EF"/>
-                      </a:solidFill>
-                      <a:prstDash val="solid"/>
-                      <a:round/>
-                      <a:headEnd type="none" w="med" len="med"/>
-                      <a:tailEnd type="none" w="med" len="med"/>
-                    </a:lnB>
-                    <a:solidFill>
-                      <a:srgbClr val="FFFFFF"/>
-                    </a:solidFill>
-                  </a:tcPr>
-                </a:tc>
-                <a:tc>
-                  <a:txBody>
-                    <a:bodyPr/>
-                    <a:lstStyle/>
-                    <a:p>
-                      <a:pPr algn="l" indent="0" marL="0">
-                        <a:buNone/>
-                      </a:pPr>
-                      <a:r>
-                        <a:rPr lang="en-US" sz="1100" dirty="0">
-                          <a:solidFill>
-                            <a:srgbClr val="1F2D3D"/>
-                          </a:solidFill>
-                          <a:latin typeface="Calibri" pitchFamily="34" charset="0"/>
-                          <a:ea typeface="Calibri" pitchFamily="34" charset="-122"/>
-                          <a:cs typeface="Calibri" pitchFamily="34" charset="-120"/>
-                        </a:rPr>
-                        <a:t>scripts/19_forecasting.py, 20_topic_examples.py, TIME_SERIES.md §2, text_mining.py</a:t>
-                      </a:r>
-                      <a:endParaRPr lang="en-US" sz="1100" dirty="0">
-                        <a:latin typeface="Calibri" charset="0"/>
-                        <a:ea typeface="Calibri" charset="0"/>
-                        <a:cs typeface="Calibri" charset="0"/>
-                      </a:endParaRPr>
-                    </a:p>
-                  </a:txBody>
-                  <a:tcPr marL="63500" marR="63500" marT="25400" marB="25400" anchor="ctr">
-                    <a:lnL w="9525" cap="flat" cmpd="sng" algn="ctr">
-                      <a:solidFill>
-                        <a:srgbClr val="E3E8EF"/>
-                      </a:solidFill>
-                      <a:prstDash val="solid"/>
-                      <a:round/>
-                      <a:headEnd type="none" w="med" len="med"/>
-                      <a:tailEnd type="none" w="med" len="med"/>
-                    </a:lnL>
-                    <a:lnR w="9525" cap="flat" cmpd="sng" algn="ctr">
-                      <a:solidFill>
-                        <a:srgbClr val="E3E8EF"/>
-                      </a:solidFill>
-                      <a:prstDash val="solid"/>
-                      <a:round/>
-                      <a:headEnd type="none" w="med" len="med"/>
-                      <a:tailEnd type="none" w="med" len="med"/>
-                    </a:lnR>
-                    <a:lnT w="9525" cap="flat" cmpd="sng" algn="ctr">
-                      <a:solidFill>
-                        <a:srgbClr val="E3E8EF"/>
-                      </a:solidFill>
-                      <a:prstDash val="solid"/>
-                      <a:round/>
-                      <a:headEnd type="none" w="med" len="med"/>
-                      <a:tailEnd type="none" w="med" len="med"/>
-                    </a:lnT>
-                    <a:lnB w="9525" cap="flat" cmpd="sng" algn="ctr">
-                      <a:solidFill>
-                        <a:srgbClr val="E3E8EF"/>
-                      </a:solidFill>
-                      <a:prstDash val="solid"/>
-                      <a:round/>
-                      <a:headEnd type="none" w="med" len="med"/>
-                      <a:tailEnd type="none" w="med" len="med"/>
-                    </a:lnB>
-                    <a:solidFill>
-                      <a:srgbClr val="FFFFFF"/>
-                    </a:solidFill>
-                  </a:tcPr>
-                </a:tc>
-              </a:tr>
-              <a:tr h="548640">
-                <a:tc>
-                  <a:txBody>
-                    <a:bodyPr/>
-                    <a:lstStyle/>
-                    <a:p>
-                      <a:pPr algn="l" indent="0" marL="0">
-                        <a:buNone/>
-                      </a:pPr>
-                      <a:r>
-                        <a:rPr lang="en-US" sz="1100" b="1" dirty="0">
-                          <a:solidFill>
-                            <a:srgbClr val="1F2D3D"/>
-                          </a:solidFill>
-                          <a:latin typeface="Calibri" pitchFamily="34" charset="0"/>
-                          <a:ea typeface="Calibri" pitchFamily="34" charset="-122"/>
-                          <a:cs typeface="Calibri" pitchFamily="34" charset="-120"/>
-                        </a:rPr>
-                        <a:t>Harshini Vennela - CB.SC.U4CSE23455</a:t>
-                      </a:r>
-                      <a:endParaRPr lang="en-US" sz="1100" dirty="0">
-                        <a:latin typeface="Calibri" charset="0"/>
-                        <a:ea typeface="Calibri" charset="0"/>
-                        <a:cs typeface="Calibri" charset="0"/>
-                      </a:endParaRPr>
-                    </a:p>
-                  </a:txBody>
-                  <a:tcPr marL="63500" marR="63500" marT="25400" marB="25400" anchor="ctr">
-                    <a:lnL w="9525" cap="flat" cmpd="sng" algn="ctr">
-                      <a:solidFill>
-                        <a:srgbClr val="E3E8EF"/>
-                      </a:solidFill>
-                      <a:prstDash val="solid"/>
-                      <a:round/>
-                      <a:headEnd type="none" w="med" len="med"/>
-                      <a:tailEnd type="none" w="med" len="med"/>
-                    </a:lnL>
-                    <a:lnR w="9525" cap="flat" cmpd="sng" algn="ctr">
-                      <a:solidFill>
-                        <a:srgbClr val="E3E8EF"/>
-                      </a:solidFill>
-                      <a:prstDash val="solid"/>
-                      <a:round/>
-                      <a:headEnd type="none" w="med" len="med"/>
-                      <a:tailEnd type="none" w="med" len="med"/>
-                    </a:lnR>
-                    <a:lnT w="9525" cap="flat" cmpd="sng" algn="ctr">
-                      <a:solidFill>
-                        <a:srgbClr val="E3E8EF"/>
-                      </a:solidFill>
-                      <a:prstDash val="solid"/>
-                      <a:round/>
-                      <a:headEnd type="none" w="med" len="med"/>
-                      <a:tailEnd type="none" w="med" len="med"/>
-                    </a:lnT>
-                    <a:lnB w="9525" cap="flat" cmpd="sng" algn="ctr">
-                      <a:solidFill>
-                        <a:srgbClr val="E3E8EF"/>
-                      </a:solidFill>
-                      <a:prstDash val="solid"/>
-                      <a:round/>
-                      <a:headEnd type="none" w="med" len="med"/>
-                      <a:tailEnd type="none" w="med" len="med"/>
-                    </a:lnB>
-                    <a:solidFill>
-                      <a:srgbClr val="FBFCFE"/>
-                    </a:solidFill>
-                  </a:tcPr>
-                </a:tc>
-                <a:tc>
-                  <a:txBody>
-                    <a:bodyPr/>
-                    <a:lstStyle/>
-                    <a:p>
-                      <a:pPr algn="ctr" indent="0" marL="0">
-                        <a:buNone/>
-                      </a:pPr>
-                      <a:r>
-                        <a:rPr lang="en-US" sz="1100" dirty="0">
-                          <a:solidFill>
-                            <a:srgbClr val="1F2D3D"/>
-                          </a:solidFill>
-                          <a:latin typeface="Calibri" pitchFamily="34" charset="0"/>
-                          <a:ea typeface="Calibri" pitchFamily="34" charset="-122"/>
-                          <a:cs typeface="Calibri" pitchFamily="34" charset="-120"/>
-                        </a:rPr>
-                        <a:t>4</a:t>
-                      </a:r>
-                      <a:endParaRPr lang="en-US" sz="1100" dirty="0">
-                        <a:latin typeface="Calibri" charset="0"/>
-                        <a:ea typeface="Calibri" charset="0"/>
-                        <a:cs typeface="Calibri" charset="0"/>
-                      </a:endParaRPr>
-                    </a:p>
-                  </a:txBody>
-                  <a:tcPr marL="63500" marR="63500" marT="25400" marB="25400" anchor="ctr">
-                    <a:lnL w="9525" cap="flat" cmpd="sng" algn="ctr">
-                      <a:solidFill>
-                        <a:srgbClr val="E3E8EF"/>
-                      </a:solidFill>
-                      <a:prstDash val="solid"/>
-                      <a:round/>
-                      <a:headEnd type="none" w="med" len="med"/>
-                      <a:tailEnd type="none" w="med" len="med"/>
-                    </a:lnL>
-                    <a:lnR w="9525" cap="flat" cmpd="sng" algn="ctr">
-                      <a:solidFill>
-                        <a:srgbClr val="E3E8EF"/>
-                      </a:solidFill>
-                      <a:prstDash val="solid"/>
-                      <a:round/>
-                      <a:headEnd type="none" w="med" len="med"/>
-                      <a:tailEnd type="none" w="med" len="med"/>
-                    </a:lnR>
-                    <a:lnT w="9525" cap="flat" cmpd="sng" algn="ctr">
-                      <a:solidFill>
-                        <a:srgbClr val="E3E8EF"/>
-                      </a:solidFill>
-                      <a:prstDash val="solid"/>
-                      <a:round/>
-                      <a:headEnd type="none" w="med" len="med"/>
-                      <a:tailEnd type="none" w="med" len="med"/>
-                    </a:lnT>
-                    <a:lnB w="9525" cap="flat" cmpd="sng" algn="ctr">
-                      <a:solidFill>
-                        <a:srgbClr val="E3E8EF"/>
-                      </a:solidFill>
-                      <a:prstDash val="solid"/>
-                      <a:round/>
-                      <a:headEnd type="none" w="med" len="med"/>
-                      <a:tailEnd type="none" w="med" len="med"/>
-                    </a:lnB>
-                    <a:solidFill>
-                      <a:srgbClr val="FBFCFE"/>
-                    </a:solidFill>
-                  </a:tcPr>
-                </a:tc>
-                <a:tc>
-                  <a:txBody>
-                    <a:bodyPr/>
-                    <a:lstStyle/>
-                    <a:p>
-                      <a:pPr algn="l" indent="0" marL="0">
-                        <a:buNone/>
-                      </a:pPr>
-                      <a:r>
-                        <a:rPr lang="en-US" sz="1100" dirty="0">
-                          <a:solidFill>
-                            <a:srgbClr val="1F2D3D"/>
-                          </a:solidFill>
-                          <a:latin typeface="Calibri" pitchFamily="34" charset="0"/>
-                          <a:ea typeface="Calibri" pitchFamily="34" charset="-122"/>
-                          <a:cs typeface="Calibri" pitchFamily="34" charset="-120"/>
-                        </a:rPr>
-                        <a:t>#137 forecast evaluation and alerts, #142 forecast write-up, #146 check-a-review page</a:t>
-                      </a:r>
-                      <a:endParaRPr lang="en-US" sz="1100" dirty="0">
-                        <a:latin typeface="Calibri" charset="0"/>
-                        <a:ea typeface="Calibri" charset="0"/>
-                        <a:cs typeface="Calibri" charset="0"/>
-                      </a:endParaRPr>
-                    </a:p>
-                  </a:txBody>
-                  <a:tcPr marL="63500" marR="63500" marT="25400" marB="25400" anchor="ctr">
-                    <a:lnL w="9525" cap="flat" cmpd="sng" algn="ctr">
-                      <a:solidFill>
-                        <a:srgbClr val="E3E8EF"/>
-                      </a:solidFill>
-                      <a:prstDash val="solid"/>
-                      <a:round/>
-                      <a:headEnd type="none" w="med" len="med"/>
-                      <a:tailEnd type="none" w="med" len="med"/>
-                    </a:lnL>
-                    <a:lnR w="9525" cap="flat" cmpd="sng" algn="ctr">
-                      <a:solidFill>
-                        <a:srgbClr val="E3E8EF"/>
-                      </a:solidFill>
-                      <a:prstDash val="solid"/>
-                      <a:round/>
-                      <a:headEnd type="none" w="med" len="med"/>
-                      <a:tailEnd type="none" w="med" len="med"/>
-                    </a:lnR>
-                    <a:lnT w="9525" cap="flat" cmpd="sng" algn="ctr">
-                      <a:solidFill>
-                        <a:srgbClr val="E3E8EF"/>
-                      </a:solidFill>
-                      <a:prstDash val="solid"/>
-                      <a:round/>
-                      <a:headEnd type="none" w="med" len="med"/>
-                      <a:tailEnd type="none" w="med" len="med"/>
-                    </a:lnT>
-                    <a:lnB w="9525" cap="flat" cmpd="sng" algn="ctr">
-                      <a:solidFill>
-                        <a:srgbClr val="E3E8EF"/>
-                      </a:solidFill>
-                      <a:prstDash val="solid"/>
-                      <a:round/>
-                      <a:headEnd type="none" w="med" len="med"/>
-                      <a:tailEnd type="none" w="med" len="med"/>
-                    </a:lnB>
-                    <a:solidFill>
-                      <a:srgbClr val="FBFCFE"/>
-                    </a:solidFill>
-                  </a:tcPr>
-                </a:tc>
-                <a:tc>
-                  <a:txBody>
-                    <a:bodyPr/>
-                    <a:lstStyle/>
-                    <a:p>
-                      <a:pPr algn="l" indent="0" marL="0">
-                        <a:buNone/>
-                      </a:pPr>
-                      <a:r>
-                        <a:rPr lang="en-US" sz="1100" dirty="0">
-                          <a:solidFill>
-                            <a:srgbClr val="1F2D3D"/>
-                          </a:solidFill>
-                          <a:latin typeface="Calibri" pitchFamily="34" charset="0"/>
-                          <a:ea typeface="Calibri" pitchFamily="34" charset="-122"/>
-                          <a:cs typeface="Calibri" pitchFamily="34" charset="-120"/>
-                        </a:rPr>
-                        <a:t>#154, #155, #156 (10 Oct)</a:t>
-                      </a:r>
-                      <a:endParaRPr lang="en-US" sz="1100" dirty="0">
-                        <a:latin typeface="Calibri" charset="0"/>
-                        <a:ea typeface="Calibri" charset="0"/>
-                        <a:cs typeface="Calibri" charset="0"/>
-                      </a:endParaRPr>
-                    </a:p>
-                  </a:txBody>
-                  <a:tcPr marL="63500" marR="63500" marT="25400" marB="25400" anchor="ctr">
-                    <a:lnL w="9525" cap="flat" cmpd="sng" algn="ctr">
-                      <a:solidFill>
-                        <a:srgbClr val="E3E8EF"/>
-                      </a:solidFill>
-                      <a:prstDash val="solid"/>
-                      <a:round/>
-                      <a:headEnd type="none" w="med" len="med"/>
-                      <a:tailEnd type="none" w="med" len="med"/>
-                    </a:lnL>
-                    <a:lnR w="9525" cap="flat" cmpd="sng" algn="ctr">
-                      <a:solidFill>
-                        <a:srgbClr val="E3E8EF"/>
-                      </a:solidFill>
-                      <a:prstDash val="solid"/>
-                      <a:round/>
-                      <a:headEnd type="none" w="med" len="med"/>
-                      <a:tailEnd type="none" w="med" len="med"/>
-                    </a:lnR>
-                    <a:lnT w="9525" cap="flat" cmpd="sng" algn="ctr">
-                      <a:solidFill>
-                        <a:srgbClr val="E3E8EF"/>
-                      </a:solidFill>
-                      <a:prstDash val="solid"/>
-                      <a:round/>
-                      <a:headEnd type="none" w="med" len="med"/>
-                      <a:tailEnd type="none" w="med" len="med"/>
-                    </a:lnT>
-                    <a:lnB w="9525" cap="flat" cmpd="sng" algn="ctr">
-                      <a:solidFill>
-                        <a:srgbClr val="E3E8EF"/>
-                      </a:solidFill>
-                      <a:prstDash val="solid"/>
-                      <a:round/>
-                      <a:headEnd type="none" w="med" len="med"/>
-                      <a:tailEnd type="none" w="med" len="med"/>
-                    </a:lnB>
-                    <a:solidFill>
-                      <a:srgbClr val="FBFCFE"/>
-                    </a:solidFill>
-                  </a:tcPr>
-                </a:tc>
-                <a:tc>
-                  <a:txBody>
-                    <a:bodyPr/>
-                    <a:lstStyle/>
-                    <a:p>
-                      <a:pPr algn="l" indent="0" marL="0">
-                        <a:buNone/>
-                      </a:pPr>
-                      <a:r>
-                        <a:rPr lang="en-US" sz="1100" dirty="0">
-                          <a:solidFill>
-                            <a:srgbClr val="1F2D3D"/>
-                          </a:solidFill>
-                          <a:latin typeface="Calibri" pitchFamily="34" charset="0"/>
-                          <a:ea typeface="Calibri" pitchFamily="34" charset="-122"/>
-                          <a:cs typeface="Calibri" pitchFamily="34" charset="-120"/>
-                        </a:rPr>
-                        <a:t>scripts/20_forecast_evaluation.py, TIME_SERIES.md §2.5, check_review.py</a:t>
-                      </a:r>
-                      <a:endParaRPr lang="en-US" sz="1100" dirty="0">
-                        <a:latin typeface="Calibri" charset="0"/>
-                        <a:ea typeface="Calibri" charset="0"/>
-                        <a:cs typeface="Calibri" charset="0"/>
-                      </a:endParaRPr>
-                    </a:p>
-                  </a:txBody>
-                  <a:tcPr marL="63500" marR="63500" marT="25400" marB="25400" anchor="ctr">
-                    <a:lnL w="9525" cap="flat" cmpd="sng" algn="ctr">
-                      <a:solidFill>
-                        <a:srgbClr val="E3E8EF"/>
-                      </a:solidFill>
-                      <a:prstDash val="solid"/>
-                      <a:round/>
-                      <a:headEnd type="none" w="med" len="med"/>
-                      <a:tailEnd type="none" w="med" len="med"/>
-                    </a:lnL>
-                    <a:lnR w="9525" cap="flat" cmpd="sng" algn="ctr">
-                      <a:solidFill>
-                        <a:srgbClr val="E3E8EF"/>
-                      </a:solidFill>
-                      <a:prstDash val="solid"/>
-                      <a:round/>
-                      <a:headEnd type="none" w="med" len="med"/>
-                      <a:tailEnd type="none" w="med" len="med"/>
-                    </a:lnR>
-                    <a:lnT w="9525" cap="flat" cmpd="sng" algn="ctr">
-                      <a:solidFill>
-                        <a:srgbClr val="E3E8EF"/>
-                      </a:solidFill>
-                      <a:prstDash val="solid"/>
-                      <a:round/>
-                      <a:headEnd type="none" w="med" len="med"/>
-                      <a:tailEnd type="none" w="med" len="med"/>
-                    </a:lnT>
-                    <a:lnB w="9525" cap="flat" cmpd="sng" algn="ctr">
-                      <a:solidFill>
-                        <a:srgbClr val="E3E8EF"/>
-                      </a:solidFill>
-                      <a:prstDash val="solid"/>
-                      <a:round/>
-                      <a:headEnd type="none" w="med" len="med"/>
-                      <a:tailEnd type="none" w="med" len="med"/>
-                    </a:lnB>
-                    <a:solidFill>
-                      <a:srgbClr val="FBFCFE"/>
-                    </a:solidFill>
-                  </a:tcPr>
-                </a:tc>
-              </a:tr>
-              <a:tr h="548640">
-                <a:tc>
-                  <a:txBody>
-                    <a:bodyPr/>
-                    <a:lstStyle/>
-                    <a:p>
-                      <a:pPr algn="l" indent="0" marL="0">
-                        <a:buNone/>
-                      </a:pPr>
-                      <a:r>
-                        <a:rPr lang="en-US" sz="1100" b="1" dirty="0">
-                          <a:solidFill>
-                            <a:srgbClr val="1F2D3D"/>
-                          </a:solidFill>
-                          <a:latin typeface="Calibri" pitchFamily="34" charset="0"/>
-                          <a:ea typeface="Calibri" pitchFamily="34" charset="-122"/>
-                          <a:cs typeface="Calibri" pitchFamily="34" charset="-120"/>
-                        </a:rPr>
-                        <a:t>Kanishka D - CB.SC.U4CSE23155</a:t>
-                      </a:r>
-                      <a:endParaRPr lang="en-US" sz="1100" dirty="0">
-                        <a:latin typeface="Calibri" charset="0"/>
-                        <a:ea typeface="Calibri" charset="0"/>
-                        <a:cs typeface="Calibri" charset="0"/>
-                      </a:endParaRPr>
-                    </a:p>
-                  </a:txBody>
-                  <a:tcPr marL="63500" marR="63500" marT="25400" marB="25400" anchor="ctr">
-                    <a:lnL w="9525" cap="flat" cmpd="sng" algn="ctr">
-                      <a:solidFill>
-                        <a:srgbClr val="E3E8EF"/>
-                      </a:solidFill>
-                      <a:prstDash val="solid"/>
-                      <a:round/>
-                      <a:headEnd type="none" w="med" len="med"/>
-                      <a:tailEnd type="none" w="med" len="med"/>
-                    </a:lnL>
-                    <a:lnR w="9525" cap="flat" cmpd="sng" algn="ctr">
-                      <a:solidFill>
-                        <a:srgbClr val="E3E8EF"/>
-                      </a:solidFill>
-                      <a:prstDash val="solid"/>
-                      <a:round/>
-                      <a:headEnd type="none" w="med" len="med"/>
-                      <a:tailEnd type="none" w="med" len="med"/>
-                    </a:lnR>
-                    <a:lnT w="9525" cap="flat" cmpd="sng" algn="ctr">
-                      <a:solidFill>
-                        <a:srgbClr val="E3E8EF"/>
-                      </a:solidFill>
-                      <a:prstDash val="solid"/>
-                      <a:round/>
-                      <a:headEnd type="none" w="med" len="med"/>
-                      <a:tailEnd type="none" w="med" len="med"/>
-                    </a:lnT>
-                    <a:lnB w="9525" cap="flat" cmpd="sng" algn="ctr">
-                      <a:solidFill>
-                        <a:srgbClr val="E3E8EF"/>
-                      </a:solidFill>
-                      <a:prstDash val="solid"/>
-                      <a:round/>
-                      <a:headEnd type="none" w="med" len="med"/>
-                      <a:tailEnd type="none" w="med" len="med"/>
-                    </a:lnB>
-                    <a:solidFill>
-                      <a:srgbClr val="FFFFFF"/>
-                    </a:solidFill>
-                  </a:tcPr>
-                </a:tc>
-                <a:tc>
-                  <a:txBody>
-                    <a:bodyPr/>
-                    <a:lstStyle/>
-                    <a:p>
-                      <a:pPr algn="ctr" indent="0" marL="0">
-                        <a:buNone/>
-                      </a:pPr>
-                      <a:r>
-                        <a:rPr lang="en-US" sz="1100" dirty="0">
-                          <a:solidFill>
-                            <a:srgbClr val="1F2D3D"/>
-                          </a:solidFill>
-                          <a:latin typeface="Calibri" pitchFamily="34" charset="0"/>
-                          <a:ea typeface="Calibri" pitchFamily="34" charset="-122"/>
-                          <a:cs typeface="Calibri" pitchFamily="34" charset="-120"/>
-                        </a:rPr>
-                        <a:t>5</a:t>
-                      </a:r>
-                      <a:endParaRPr lang="en-US" sz="1100" dirty="0">
-                        <a:latin typeface="Calibri" charset="0"/>
-                        <a:ea typeface="Calibri" charset="0"/>
-                        <a:cs typeface="Calibri" charset="0"/>
-                      </a:endParaRPr>
-                    </a:p>
-                  </a:txBody>
-                  <a:tcPr marL="63500" marR="63500" marT="25400" marB="25400" anchor="ctr">
-                    <a:lnL w="9525" cap="flat" cmpd="sng" algn="ctr">
-                      <a:solidFill>
-                        <a:srgbClr val="E3E8EF"/>
-                      </a:solidFill>
-                      <a:prstDash val="solid"/>
-                      <a:round/>
-                      <a:headEnd type="none" w="med" len="med"/>
-                      <a:tailEnd type="none" w="med" len="med"/>
-                    </a:lnL>
-                    <a:lnR w="9525" cap="flat" cmpd="sng" algn="ctr">
-                      <a:solidFill>
-                        <a:srgbClr val="E3E8EF"/>
-                      </a:solidFill>
-                      <a:prstDash val="solid"/>
-                      <a:round/>
-                      <a:headEnd type="none" w="med" len="med"/>
-                      <a:tailEnd type="none" w="med" len="med"/>
-                    </a:lnR>
-                    <a:lnT w="9525" cap="flat" cmpd="sng" algn="ctr">
-                      <a:solidFill>
-                        <a:srgbClr val="E3E8EF"/>
-                      </a:solidFill>
-                      <a:prstDash val="solid"/>
-                      <a:round/>
-                      <a:headEnd type="none" w="med" len="med"/>
-                      <a:tailEnd type="none" w="med" len="med"/>
-                    </a:lnT>
-                    <a:lnB w="9525" cap="flat" cmpd="sng" algn="ctr">
-                      <a:solidFill>
-                        <a:srgbClr val="E3E8EF"/>
-                      </a:solidFill>
-                      <a:prstDash val="solid"/>
-                      <a:round/>
-                      <a:headEnd type="none" w="med" len="med"/>
-                      <a:tailEnd type="none" w="med" len="med"/>
-                    </a:lnB>
-                    <a:solidFill>
-                      <a:srgbClr val="FFFFFF"/>
-                    </a:solidFill>
-                  </a:tcPr>
-                </a:tc>
-                <a:tc>
-                  <a:txBody>
-                    <a:bodyPr/>
-                    <a:lstStyle/>
-                    <a:p>
-                      <a:pPr algn="l" indent="0" marL="0">
-                        <a:buNone/>
-                      </a:pPr>
-                      <a:r>
-                        <a:rPr lang="en-US" sz="1100" dirty="0">
-                          <a:solidFill>
-                            <a:srgbClr val="1F2D3D"/>
-                          </a:solidFill>
-                          <a:latin typeface="Calibri" pitchFamily="34" charset="0"/>
-                          <a:ea typeface="Calibri" pitchFamily="34" charset="-122"/>
-                          <a:cs typeface="Calibri" pitchFamily="34" charset="-120"/>
-                        </a:rPr>
-                        <a:t>#138 update impact, #141 combined insights, #140 three dashboard pages, #143 final notebook</a:t>
-                      </a:r>
-                      <a:endParaRPr lang="en-US" sz="1100" dirty="0">
-                        <a:latin typeface="Calibri" charset="0"/>
-                        <a:ea typeface="Calibri" charset="0"/>
-                        <a:cs typeface="Calibri" charset="0"/>
-                      </a:endParaRPr>
-                    </a:p>
-                  </a:txBody>
-                  <a:tcPr marL="63500" marR="63500" marT="25400" marB="25400" anchor="ctr">
-                    <a:lnL w="9525" cap="flat" cmpd="sng" algn="ctr">
-                      <a:solidFill>
-                        <a:srgbClr val="E3E8EF"/>
-                      </a:solidFill>
-                      <a:prstDash val="solid"/>
-                      <a:round/>
-                      <a:headEnd type="none" w="med" len="med"/>
-                      <a:tailEnd type="none" w="med" len="med"/>
-                    </a:lnL>
-                    <a:lnR w="9525" cap="flat" cmpd="sng" algn="ctr">
-                      <a:solidFill>
-                        <a:srgbClr val="E3E8EF"/>
-                      </a:solidFill>
-                      <a:prstDash val="solid"/>
-                      <a:round/>
-                      <a:headEnd type="none" w="med" len="med"/>
-                      <a:tailEnd type="none" w="med" len="med"/>
-                    </a:lnR>
-                    <a:lnT w="9525" cap="flat" cmpd="sng" algn="ctr">
-                      <a:solidFill>
-                        <a:srgbClr val="E3E8EF"/>
-                      </a:solidFill>
-                      <a:prstDash val="solid"/>
-                      <a:round/>
-                      <a:headEnd type="none" w="med" len="med"/>
-                      <a:tailEnd type="none" w="med" len="med"/>
-                    </a:lnT>
-                    <a:lnB w="9525" cap="flat" cmpd="sng" algn="ctr">
-                      <a:solidFill>
-                        <a:srgbClr val="E3E8EF"/>
-                      </a:solidFill>
-                      <a:prstDash val="solid"/>
-                      <a:round/>
-                      <a:headEnd type="none" w="med" len="med"/>
-                      <a:tailEnd type="none" w="med" len="med"/>
-                    </a:lnB>
-                    <a:solidFill>
-                      <a:srgbClr val="FFFFFF"/>
-                    </a:solidFill>
-                  </a:tcPr>
-                </a:tc>
-                <a:tc>
-                  <a:txBody>
-                    <a:bodyPr/>
-                    <a:lstStyle/>
-                    <a:p>
-                      <a:pPr algn="l" indent="0" marL="0">
-                        <a:buNone/>
-                      </a:pPr>
-                      <a:r>
-                        <a:rPr lang="en-US" sz="1100" dirty="0">
-                          <a:solidFill>
-                            <a:srgbClr val="1F2D3D"/>
-                          </a:solidFill>
-                          <a:latin typeface="Calibri" pitchFamily="34" charset="0"/>
-                          <a:ea typeface="Calibri" pitchFamily="34" charset="-122"/>
-                          <a:cs typeface="Calibri" pitchFamily="34" charset="-120"/>
-                        </a:rPr>
-                        <a:t>#157, #158 (11 Oct)</a:t>
-                      </a:r>
-                      <a:endParaRPr lang="en-US" sz="1100" dirty="0">
-                        <a:latin typeface="Calibri" charset="0"/>
-                        <a:ea typeface="Calibri" charset="0"/>
-                        <a:cs typeface="Calibri" charset="0"/>
-                      </a:endParaRPr>
-                    </a:p>
-                  </a:txBody>
-                  <a:tcPr marL="63500" marR="63500" marT="25400" marB="25400" anchor="ctr">
-                    <a:lnL w="9525" cap="flat" cmpd="sng" algn="ctr">
-                      <a:solidFill>
-                        <a:srgbClr val="E3E8EF"/>
-                      </a:solidFill>
-                      <a:prstDash val="solid"/>
-                      <a:round/>
-                      <a:headEnd type="none" w="med" len="med"/>
-                      <a:tailEnd type="none" w="med" len="med"/>
-                    </a:lnL>
-                    <a:lnR w="9525" cap="flat" cmpd="sng" algn="ctr">
-                      <a:solidFill>
-                        <a:srgbClr val="E3E8EF"/>
-                      </a:solidFill>
-                      <a:prstDash val="solid"/>
-                      <a:round/>
-                      <a:headEnd type="none" w="med" len="med"/>
-                      <a:tailEnd type="none" w="med" len="med"/>
-                    </a:lnR>
-                    <a:lnT w="9525" cap="flat" cmpd="sng" algn="ctr">
-                      <a:solidFill>
-                        <a:srgbClr val="E3E8EF"/>
-                      </a:solidFill>
-                      <a:prstDash val="solid"/>
-                      <a:round/>
-                      <a:headEnd type="none" w="med" len="med"/>
-                      <a:tailEnd type="none" w="med" len="med"/>
-                    </a:lnT>
-                    <a:lnB w="9525" cap="flat" cmpd="sng" algn="ctr">
-                      <a:solidFill>
-                        <a:srgbClr val="E3E8EF"/>
-                      </a:solidFill>
-                      <a:prstDash val="solid"/>
-                      <a:round/>
-                      <a:headEnd type="none" w="med" len="med"/>
-                      <a:tailEnd type="none" w="med" len="med"/>
-                    </a:lnB>
-                    <a:solidFill>
-                      <a:srgbClr val="FFFFFF"/>
-                    </a:solidFill>
-                  </a:tcPr>
-                </a:tc>
-                <a:tc>
-                  <a:txBody>
-                    <a:bodyPr/>
-                    <a:lstStyle/>
-                    <a:p>
-                      <a:pPr algn="l" indent="0" marL="0">
-                        <a:buNone/>
-                      </a:pPr>
-                      <a:r>
-                        <a:rPr lang="en-US" sz="1100" dirty="0">
-                          <a:solidFill>
-                            <a:srgbClr val="1F2D3D"/>
-                          </a:solidFill>
-                          <a:latin typeface="Calibri" pitchFamily="34" charset="0"/>
-                          <a:ea typeface="Calibri" pitchFamily="34" charset="-122"/>
-                          <a:cs typeface="Calibri" pitchFamily="34" charset="-120"/>
-                        </a:rPr>
-                        <a:t>scripts 21–22, COMBINED_INSIGHTS.md, notebooks/Review_2.ipynb</a:t>
-                      </a:r>
-                      <a:endParaRPr lang="en-US" sz="1100" dirty="0">
-                        <a:latin typeface="Calibri" charset="0"/>
-                        <a:ea typeface="Calibri" charset="0"/>
-                        <a:cs typeface="Calibri" charset="0"/>
-                      </a:endParaRPr>
-                    </a:p>
-                  </a:txBody>
-                  <a:tcPr marL="63500" marR="63500" marT="25400" marB="25400" anchor="ctr">
-                    <a:lnL w="9525" cap="flat" cmpd="sng" algn="ctr">
-                      <a:solidFill>
-                        <a:srgbClr val="E3E8EF"/>
-                      </a:solidFill>
-                      <a:prstDash val="solid"/>
-                      <a:round/>
-                      <a:headEnd type="none" w="med" len="med"/>
-                      <a:tailEnd type="none" w="med" len="med"/>
-                    </a:lnL>
-                    <a:lnR w="9525" cap="flat" cmpd="sng" algn="ctr">
-                      <a:solidFill>
-                        <a:srgbClr val="E3E8EF"/>
-                      </a:solidFill>
-                      <a:prstDash val="solid"/>
-                      <a:round/>
-                      <a:headEnd type="none" w="med" len="med"/>
-                      <a:tailEnd type="none" w="med" len="med"/>
-                    </a:lnR>
-                    <a:lnT w="9525" cap="flat" cmpd="sng" algn="ctr">
-                      <a:solidFill>
-                        <a:srgbClr val="E3E8EF"/>
-                      </a:solidFill>
-                      <a:prstDash val="solid"/>
-                      <a:round/>
-                      <a:headEnd type="none" w="med" len="med"/>
-                      <a:tailEnd type="none" w="med" len="med"/>
-                    </a:lnT>
-                    <a:lnB w="9525" cap="flat" cmpd="sng" algn="ctr">
-                      <a:solidFill>
-                        <a:srgbClr val="E3E8EF"/>
-                      </a:solidFill>
-                      <a:prstDash val="solid"/>
-                      <a:round/>
-                      <a:headEnd type="none" w="med" len="med"/>
-                      <a:tailEnd type="none" w="med" len="med"/>
-                    </a:lnB>
-                    <a:solidFill>
-                      <a:srgbClr val="FFFFFF"/>
-                    </a:solidFill>
-                  </a:tcPr>
-                </a:tc>
-              </a:tr>
-            </a:tbl>
-          </a:graphicData>
-        </a:graphic>
-      </p:graphicFrame>
-      <p:sp>
-        <p:nvSpPr>
-          <p:cNvPr id="16" name="Text 13"/>
+      <p:sp>
+        <p:nvSpPr>
+          <p:cNvPr id="15" name="Text 13"/>
           <p:cNvSpPr txBox="1"/>
           <p:nvPr/>
         </p:nvSpPr>
         <p:spPr>
           <a:xfrm>
-            <a:off x="640080" y="5760720"/>
-            <a:ext cx="10911535" cy="548640"/>
+            <a:off x="640080" y="2212848"/>
+            <a:ext cx="10911535" cy="274320"/>
           </a:xfrm>
           <a:prstGeom prst="rect">
             <a:avLst/>
@@ -25033,49 +23038,48 @@
           <a:ln/>
         </p:spPr>
         <p:txBody>
-          <a:bodyPr wrap="square" lIns="0" tIns="0" rIns="0" bIns="0" rtlCol="0" anchor="t">
-            <a:normAutofit/>
-          </a:bodyPr>
+          <a:bodyPr wrap="square" lIns="0" tIns="0" rIns="0" bIns="0" rtlCol="0" anchor="ctr"/>
           <a:lstStyle/>
           <a:p>
             <a:pPr indent="0" marL="0">
-              <a:lnSpc>
-                <a:spcPct val="100000"/>
-              </a:lnSpc>
-              <a:spcAft>
-                <a:spcPts val="600"/>
-              </a:spcAft>
               <a:buNone/>
             </a:pPr>
             <a:r>
-              <a:rPr lang="en-US" sz="1150" b="1" dirty="0">
+              <a:rPr lang="en-US" sz="1200" b="1" dirty="0">
                 <a:solidFill>
-                  <a:schemeClr val="tx1"/>
+                  <a:schemeClr val="tx2"/>
                 </a:solidFill>
               </a:rPr>
-              <a:t>Activity history: </a:t>
+              <a:t>Evidence and activity history:</a:t>
             </a:r>
-            <a:pPr indent="0" marL="0">
-              <a:lnSpc>
-                <a:spcPct val="100000"/>
-              </a:lnSpc>
-              <a:spcAft>
-                <a:spcPts val="600"/>
-              </a:spcAft>
-              <a:buNone/>
-            </a:pPr>
-            <a:r>
-              <a:rPr lang="en-US" sz="1150" dirty="0">
-                <a:solidFill>
-                  <a:schemeClr val="tx1"/>
-                </a:solidFill>
-              </a:rPr>
-              <a:t>one stage after another, each merged before the next began (Stages 1–2 on 8 Oct, Stage 3 on 9 Oct, Stage 4 on 10 Oct, Stage 5 on 11 Oct). Each task is linked to a merged pull request, and every card is in Completed.</a:t>
-            </a:r>
-            <a:endParaRPr lang="en-US" sz="1150" dirty="0"/>
+            <a:endParaRPr lang="en-US" sz="1200" dirty="0"/>
           </a:p>
         </p:txBody>
       </p:sp>
+      <p:pic>
+        <p:nvPicPr>
+          <p:cNvPr id="16" name="Image 0" descr="Project board, table view of the 14 Review 2 tasks: all Completed, each with assignee, linked pull request and due date 11 Oct 2026">    </p:cNvPr>
+          <p:cNvPicPr>
+            <a:picLocks noChangeAspect="1"/>
+          </p:cNvPicPr>
+          <p:nvPr/>
+        </p:nvPicPr>
+        <p:blipFill>
+          <a:blip r:embed="rId3"/>
+          <a:stretch>
+            <a:fillRect/>
+          </a:stretch>
+        </p:blipFill>
+        <p:spPr>
+          <a:xfrm>
+            <a:off x="954837" y="2560320"/>
+            <a:ext cx="10282021" cy="3749040"/>
+          </a:xfrm>
+          <a:prstGeom prst="rect">
+            <a:avLst/>
+          </a:prstGeom>
+        </p:spPr>
+      </p:pic>
       <p:sp>
         <p:nvSpPr>
           <p:cNvPr id="25" name="Slide Number Placeholder 0"/>
@@ -25178,7 +23182,2302 @@
                   <a:schemeClr val="accent6"/>
                 </a:solidFill>
               </a:rPr>
-              <a:t>14  |  CONCLUSION AND SUBMISSION</a:t>
+              <a:t>14  |  INDIVIDUAL CONTRIBUTIONS</a:t>
+            </a:r>
+            <a:endParaRPr lang="en-US" sz="1100" dirty="0"/>
+          </a:p>
+        </p:txBody>
+      </p:sp>
+      <p:sp>
+        <p:nvSpPr>
+          <p:cNvPr id="3" name="Text 1"/>
+          <p:cNvSpPr/>
+          <p:nvPr>
+            <p:ph idx="102" type="title" hasCustomPrompt="1"/>
+          </p:nvPr>
+        </p:nvSpPr>
+        <p:spPr>
+          <a:xfrm>
+            <a:off x="640080" y="566928"/>
+            <a:ext cx="10911535" cy="685800"/>
+          </a:xfrm>
+          <a:prstGeom prst="rect">
+            <a:avLst/>
+          </a:prstGeom>
+          <a:noFill/>
+          <a:ln/>
+        </p:spPr>
+        <p:txBody>
+          <a:bodyPr wrap="square" lIns="0" tIns="0" rIns="0" bIns="0" rtlCol="0" anchor="ctr"/>
+          <a:lstStyle/>
+          <a:p>
+            <a:pPr algn="l" indent="0" marL="0">
+              <a:buNone/>
+            </a:pPr>
+            <a:r>
+              <a:rPr lang="en-US" sz="2800" b="1" dirty="0">
+                <a:solidFill>
+                  <a:schemeClr val="tx2"/>
+                </a:solidFill>
+                <a:latin typeface="Cambria" pitchFamily="34" charset="0"/>
+                <a:ea typeface="Cambria" pitchFamily="34" charset="-122"/>
+                <a:cs typeface="Cambria" pitchFamily="34" charset="-120"/>
+              </a:rPr>
+              <a:t>Individual Contributions</a:t>
+            </a:r>
+            <a:endParaRPr lang="en-US" sz="2800" dirty="0"/>
+          </a:p>
+        </p:txBody>
+      </p:sp>
+      <p:graphicFrame>
+        <p:nvGraphicFramePr>
+          <p:cNvPr id="22" name="Table 0"/>
+          <p:cNvGraphicFramePr>
+            <a:graphicFrameLocks noGrp="1"/>
+          </p:cNvGraphicFramePr>
+          <p:nvPr>
+            <p:extLst>
+              <p:ext uri="{D42A27DB-BD31-4B8C-83A1-F6EECF244321}">
+                <p14:modId xmlns:p14="http://schemas.microsoft.com/office/powerpoint/2010/main" val="1579011935"/>
+              </p:ext>
+            </p:extLst>
+          </p:nvPr>
+        </p:nvGraphicFramePr>
+        <p:xfrm>
+          <a:off x="640080" y="1463040"/>
+          <a:ext cx="10911535" cy="914400"/>
+        </p:xfrm>
+        <a:graphic>
+          <a:graphicData uri="http://schemas.openxmlformats.org/drawingml/2006/table">
+            <a:tbl>
+              <a:tblPr/>
+              <a:tblGrid>
+                <a:gridCol w="2240280"/>
+                <a:gridCol w="685800"/>
+                <a:gridCol w="3931920"/>
+                <a:gridCol w="1600200"/>
+                <a:gridCol w="2453335"/>
+              </a:tblGrid>
+              <a:tr h="384048">
+                <a:tc>
+                  <a:txBody>
+                    <a:bodyPr/>
+                    <a:lstStyle/>
+                    <a:p>
+                      <a:pPr algn="l" indent="0" marL="0">
+                        <a:buNone/>
+                      </a:pPr>
+                      <a:r>
+                        <a:rPr lang="en-US" sz="1250" b="1" dirty="0">
+                          <a:solidFill>
+                            <a:srgbClr val="FFFFFF"/>
+                          </a:solidFill>
+                          <a:latin typeface="Calibri" pitchFamily="34" charset="0"/>
+                          <a:ea typeface="Calibri" pitchFamily="34" charset="-122"/>
+                          <a:cs typeface="Calibri" pitchFamily="34" charset="-120"/>
+                        </a:rPr>
+                        <a:t>Member</a:t>
+                      </a:r>
+                      <a:endParaRPr lang="en-US" sz="1250" dirty="0">
+                        <a:latin typeface="Calibri" charset="0"/>
+                        <a:ea typeface="Calibri" charset="0"/>
+                        <a:cs typeface="Calibri" charset="0"/>
+                      </a:endParaRPr>
+                    </a:p>
+                  </a:txBody>
+                  <a:tcPr marL="63500" marR="63500" marT="25400" marB="25400" anchor="ctr">
+                    <a:lnL w="9525" cap="flat" cmpd="sng" algn="ctr">
+                      <a:solidFill>
+                        <a:srgbClr val="E3E8EF"/>
+                      </a:solidFill>
+                      <a:prstDash val="solid"/>
+                      <a:round/>
+                      <a:headEnd type="none" w="med" len="med"/>
+                      <a:tailEnd type="none" w="med" len="med"/>
+                    </a:lnL>
+                    <a:lnR w="9525" cap="flat" cmpd="sng" algn="ctr">
+                      <a:solidFill>
+                        <a:srgbClr val="E3E8EF"/>
+                      </a:solidFill>
+                      <a:prstDash val="solid"/>
+                      <a:round/>
+                      <a:headEnd type="none" w="med" len="med"/>
+                      <a:tailEnd type="none" w="med" len="med"/>
+                    </a:lnR>
+                    <a:lnT w="9525" cap="flat" cmpd="sng" algn="ctr">
+                      <a:solidFill>
+                        <a:srgbClr val="E3E8EF"/>
+                      </a:solidFill>
+                      <a:prstDash val="solid"/>
+                      <a:round/>
+                      <a:headEnd type="none" w="med" len="med"/>
+                      <a:tailEnd type="none" w="med" len="med"/>
+                    </a:lnT>
+                    <a:lnB w="9525" cap="flat" cmpd="sng" algn="ctr">
+                      <a:solidFill>
+                        <a:srgbClr val="E3E8EF"/>
+                      </a:solidFill>
+                      <a:prstDash val="solid"/>
+                      <a:round/>
+                      <a:headEnd type="none" w="med" len="med"/>
+                      <a:tailEnd type="none" w="med" len="med"/>
+                    </a:lnB>
+                    <a:solidFill>
+                      <a:srgbClr val="132C43"/>
+                    </a:solidFill>
+                  </a:tcPr>
+                </a:tc>
+                <a:tc>
+                  <a:txBody>
+                    <a:bodyPr/>
+                    <a:lstStyle/>
+                    <a:p>
+                      <a:pPr algn="ctr" indent="0" marL="0">
+                        <a:buNone/>
+                      </a:pPr>
+                      <a:r>
+                        <a:rPr lang="en-US" sz="1250" b="1" dirty="0">
+                          <a:solidFill>
+                            <a:srgbClr val="FFFFFF"/>
+                          </a:solidFill>
+                          <a:latin typeface="Calibri" pitchFamily="34" charset="0"/>
+                          <a:ea typeface="Calibri" pitchFamily="34" charset="-122"/>
+                          <a:cs typeface="Calibri" pitchFamily="34" charset="-120"/>
+                        </a:rPr>
+                        <a:t>Stage</a:t>
+                      </a:r>
+                      <a:endParaRPr lang="en-US" sz="1250" dirty="0">
+                        <a:latin typeface="Calibri" charset="0"/>
+                        <a:ea typeface="Calibri" charset="0"/>
+                        <a:cs typeface="Calibri" charset="0"/>
+                      </a:endParaRPr>
+                    </a:p>
+                  </a:txBody>
+                  <a:tcPr marL="63500" marR="63500" marT="25400" marB="25400" anchor="ctr">
+                    <a:lnL w="9525" cap="flat" cmpd="sng" algn="ctr">
+                      <a:solidFill>
+                        <a:srgbClr val="E3E8EF"/>
+                      </a:solidFill>
+                      <a:prstDash val="solid"/>
+                      <a:round/>
+                      <a:headEnd type="none" w="med" len="med"/>
+                      <a:tailEnd type="none" w="med" len="med"/>
+                    </a:lnL>
+                    <a:lnR w="9525" cap="flat" cmpd="sng" algn="ctr">
+                      <a:solidFill>
+                        <a:srgbClr val="E3E8EF"/>
+                      </a:solidFill>
+                      <a:prstDash val="solid"/>
+                      <a:round/>
+                      <a:headEnd type="none" w="med" len="med"/>
+                      <a:tailEnd type="none" w="med" len="med"/>
+                    </a:lnR>
+                    <a:lnT w="9525" cap="flat" cmpd="sng" algn="ctr">
+                      <a:solidFill>
+                        <a:srgbClr val="E3E8EF"/>
+                      </a:solidFill>
+                      <a:prstDash val="solid"/>
+                      <a:round/>
+                      <a:headEnd type="none" w="med" len="med"/>
+                      <a:tailEnd type="none" w="med" len="med"/>
+                    </a:lnT>
+                    <a:lnB w="9525" cap="flat" cmpd="sng" algn="ctr">
+                      <a:solidFill>
+                        <a:srgbClr val="E3E8EF"/>
+                      </a:solidFill>
+                      <a:prstDash val="solid"/>
+                      <a:round/>
+                      <a:headEnd type="none" w="med" len="med"/>
+                      <a:tailEnd type="none" w="med" len="med"/>
+                    </a:lnB>
+                    <a:solidFill>
+                      <a:srgbClr val="132C43"/>
+                    </a:solidFill>
+                  </a:tcPr>
+                </a:tc>
+                <a:tc>
+                  <a:txBody>
+                    <a:bodyPr/>
+                    <a:lstStyle/>
+                    <a:p>
+                      <a:pPr algn="l" indent="0" marL="0">
+                        <a:buNone/>
+                      </a:pPr>
+                      <a:r>
+                        <a:rPr lang="en-US" sz="1250" b="1" dirty="0">
+                          <a:solidFill>
+                            <a:srgbClr val="FFFFFF"/>
+                          </a:solidFill>
+                          <a:latin typeface="Calibri" pitchFamily="34" charset="0"/>
+                          <a:ea typeface="Calibri" pitchFamily="34" charset="-122"/>
+                          <a:cs typeface="Calibri" pitchFamily="34" charset="-120"/>
+                        </a:rPr>
+                        <a:t>Board tasks (all due 11 Oct, all Completed)</a:t>
+                      </a:r>
+                      <a:endParaRPr lang="en-US" sz="1250" dirty="0">
+                        <a:latin typeface="Calibri" charset="0"/>
+                        <a:ea typeface="Calibri" charset="0"/>
+                        <a:cs typeface="Calibri" charset="0"/>
+                      </a:endParaRPr>
+                    </a:p>
+                  </a:txBody>
+                  <a:tcPr marL="63500" marR="63500" marT="25400" marB="25400" anchor="ctr">
+                    <a:lnL w="9525" cap="flat" cmpd="sng" algn="ctr">
+                      <a:solidFill>
+                        <a:srgbClr val="E3E8EF"/>
+                      </a:solidFill>
+                      <a:prstDash val="solid"/>
+                      <a:round/>
+                      <a:headEnd type="none" w="med" len="med"/>
+                      <a:tailEnd type="none" w="med" len="med"/>
+                    </a:lnL>
+                    <a:lnR w="9525" cap="flat" cmpd="sng" algn="ctr">
+                      <a:solidFill>
+                        <a:srgbClr val="E3E8EF"/>
+                      </a:solidFill>
+                      <a:prstDash val="solid"/>
+                      <a:round/>
+                      <a:headEnd type="none" w="med" len="med"/>
+                      <a:tailEnd type="none" w="med" len="med"/>
+                    </a:lnR>
+                    <a:lnT w="9525" cap="flat" cmpd="sng" algn="ctr">
+                      <a:solidFill>
+                        <a:srgbClr val="E3E8EF"/>
+                      </a:solidFill>
+                      <a:prstDash val="solid"/>
+                      <a:round/>
+                      <a:headEnd type="none" w="med" len="med"/>
+                      <a:tailEnd type="none" w="med" len="med"/>
+                    </a:lnT>
+                    <a:lnB w="9525" cap="flat" cmpd="sng" algn="ctr">
+                      <a:solidFill>
+                        <a:srgbClr val="E3E8EF"/>
+                      </a:solidFill>
+                      <a:prstDash val="solid"/>
+                      <a:round/>
+                      <a:headEnd type="none" w="med" len="med"/>
+                      <a:tailEnd type="none" w="med" len="med"/>
+                    </a:lnB>
+                    <a:solidFill>
+                      <a:srgbClr val="132C43"/>
+                    </a:solidFill>
+                  </a:tcPr>
+                </a:tc>
+                <a:tc>
+                  <a:txBody>
+                    <a:bodyPr/>
+                    <a:lstStyle/>
+                    <a:p>
+                      <a:pPr algn="l" indent="0" marL="0">
+                        <a:buNone/>
+                      </a:pPr>
+                      <a:r>
+                        <a:rPr lang="en-US" sz="1250" b="1" dirty="0">
+                          <a:solidFill>
+                            <a:srgbClr val="FFFFFF"/>
+                          </a:solidFill>
+                          <a:latin typeface="Calibri" pitchFamily="34" charset="0"/>
+                          <a:ea typeface="Calibri" pitchFamily="34" charset="-122"/>
+                          <a:cs typeface="Calibri" pitchFamily="34" charset="-120"/>
+                        </a:rPr>
+                        <a:t>Pull requests (merged)</a:t>
+                      </a:r>
+                      <a:endParaRPr lang="en-US" sz="1250" dirty="0">
+                        <a:latin typeface="Calibri" charset="0"/>
+                        <a:ea typeface="Calibri" charset="0"/>
+                        <a:cs typeface="Calibri" charset="0"/>
+                      </a:endParaRPr>
+                    </a:p>
+                  </a:txBody>
+                  <a:tcPr marL="63500" marR="63500" marT="25400" marB="25400" anchor="ctr">
+                    <a:lnL w="9525" cap="flat" cmpd="sng" algn="ctr">
+                      <a:solidFill>
+                        <a:srgbClr val="E3E8EF"/>
+                      </a:solidFill>
+                      <a:prstDash val="solid"/>
+                      <a:round/>
+                      <a:headEnd type="none" w="med" len="med"/>
+                      <a:tailEnd type="none" w="med" len="med"/>
+                    </a:lnL>
+                    <a:lnR w="9525" cap="flat" cmpd="sng" algn="ctr">
+                      <a:solidFill>
+                        <a:srgbClr val="E3E8EF"/>
+                      </a:solidFill>
+                      <a:prstDash val="solid"/>
+                      <a:round/>
+                      <a:headEnd type="none" w="med" len="med"/>
+                      <a:tailEnd type="none" w="med" len="med"/>
+                    </a:lnR>
+                    <a:lnT w="9525" cap="flat" cmpd="sng" algn="ctr">
+                      <a:solidFill>
+                        <a:srgbClr val="E3E8EF"/>
+                      </a:solidFill>
+                      <a:prstDash val="solid"/>
+                      <a:round/>
+                      <a:headEnd type="none" w="med" len="med"/>
+                      <a:tailEnd type="none" w="med" len="med"/>
+                    </a:lnT>
+                    <a:lnB w="9525" cap="flat" cmpd="sng" algn="ctr">
+                      <a:solidFill>
+                        <a:srgbClr val="E3E8EF"/>
+                      </a:solidFill>
+                      <a:prstDash val="solid"/>
+                      <a:round/>
+                      <a:headEnd type="none" w="med" len="med"/>
+                      <a:tailEnd type="none" w="med" len="med"/>
+                    </a:lnB>
+                    <a:solidFill>
+                      <a:srgbClr val="132C43"/>
+                    </a:solidFill>
+                  </a:tcPr>
+                </a:tc>
+                <a:tc>
+                  <a:txBody>
+                    <a:bodyPr/>
+                    <a:lstStyle/>
+                    <a:p>
+                      <a:pPr algn="l" indent="0" marL="0">
+                        <a:buNone/>
+                      </a:pPr>
+                      <a:r>
+                        <a:rPr lang="en-US" sz="1250" b="1" dirty="0">
+                          <a:solidFill>
+                            <a:srgbClr val="FFFFFF"/>
+                          </a:solidFill>
+                          <a:latin typeface="Calibri" pitchFamily="34" charset="0"/>
+                          <a:ea typeface="Calibri" pitchFamily="34" charset="-122"/>
+                          <a:cs typeface="Calibri" pitchFamily="34" charset="-120"/>
+                        </a:rPr>
+                        <a:t>Evidence</a:t>
+                      </a:r>
+                      <a:endParaRPr lang="en-US" sz="1250" dirty="0">
+                        <a:latin typeface="Calibri" charset="0"/>
+                        <a:ea typeface="Calibri" charset="0"/>
+                        <a:cs typeface="Calibri" charset="0"/>
+                      </a:endParaRPr>
+                    </a:p>
+                  </a:txBody>
+                  <a:tcPr marL="63500" marR="63500" marT="25400" marB="25400" anchor="ctr">
+                    <a:lnL w="9525" cap="flat" cmpd="sng" algn="ctr">
+                      <a:solidFill>
+                        <a:srgbClr val="E3E8EF"/>
+                      </a:solidFill>
+                      <a:prstDash val="solid"/>
+                      <a:round/>
+                      <a:headEnd type="none" w="med" len="med"/>
+                      <a:tailEnd type="none" w="med" len="med"/>
+                    </a:lnL>
+                    <a:lnR w="9525" cap="flat" cmpd="sng" algn="ctr">
+                      <a:solidFill>
+                        <a:srgbClr val="E3E8EF"/>
+                      </a:solidFill>
+                      <a:prstDash val="solid"/>
+                      <a:round/>
+                      <a:headEnd type="none" w="med" len="med"/>
+                      <a:tailEnd type="none" w="med" len="med"/>
+                    </a:lnR>
+                    <a:lnT w="9525" cap="flat" cmpd="sng" algn="ctr">
+                      <a:solidFill>
+                        <a:srgbClr val="E3E8EF"/>
+                      </a:solidFill>
+                      <a:prstDash val="solid"/>
+                      <a:round/>
+                      <a:headEnd type="none" w="med" len="med"/>
+                      <a:tailEnd type="none" w="med" len="med"/>
+                    </a:lnT>
+                    <a:lnB w="9525" cap="flat" cmpd="sng" algn="ctr">
+                      <a:solidFill>
+                        <a:srgbClr val="E3E8EF"/>
+                      </a:solidFill>
+                      <a:prstDash val="solid"/>
+                      <a:round/>
+                      <a:headEnd type="none" w="med" len="med"/>
+                      <a:tailEnd type="none" w="med" len="med"/>
+                    </a:lnB>
+                    <a:solidFill>
+                      <a:srgbClr val="132C43"/>
+                    </a:solidFill>
+                  </a:tcPr>
+                </a:tc>
+              </a:tr>
+              <a:tr h="777240">
+                <a:tc>
+                  <a:txBody>
+                    <a:bodyPr/>
+                    <a:lstStyle/>
+                    <a:p>
+                      <a:pPr algn="l" indent="0" marL="0">
+                        <a:buNone/>
+                      </a:pPr>
+                      <a:r>
+                        <a:rPr lang="en-US" sz="1250" b="1" dirty="0">
+                          <a:solidFill>
+                            <a:srgbClr val="1F2D3D"/>
+                          </a:solidFill>
+                          <a:latin typeface="Calibri" pitchFamily="34" charset="0"/>
+                          <a:ea typeface="Calibri" pitchFamily="34" charset="-122"/>
+                          <a:cs typeface="Calibri" pitchFamily="34" charset="-120"/>
+                        </a:rPr>
+                        <a:t>Aditya Monish Kumar K - CB.SC.U4CSE23103</a:t>
+                      </a:r>
+                      <a:endParaRPr lang="en-US" sz="1250" dirty="0">
+                        <a:latin typeface="Calibri" charset="0"/>
+                        <a:ea typeface="Calibri" charset="0"/>
+                        <a:cs typeface="Calibri" charset="0"/>
+                      </a:endParaRPr>
+                    </a:p>
+                  </a:txBody>
+                  <a:tcPr marL="63500" marR="63500" marT="25400" marB="25400" anchor="ctr">
+                    <a:lnL w="9525" cap="flat" cmpd="sng" algn="ctr">
+                      <a:solidFill>
+                        <a:srgbClr val="E3E8EF"/>
+                      </a:solidFill>
+                      <a:prstDash val="solid"/>
+                      <a:round/>
+                      <a:headEnd type="none" w="med" len="med"/>
+                      <a:tailEnd type="none" w="med" len="med"/>
+                    </a:lnL>
+                    <a:lnR w="9525" cap="flat" cmpd="sng" algn="ctr">
+                      <a:solidFill>
+                        <a:srgbClr val="E3E8EF"/>
+                      </a:solidFill>
+                      <a:prstDash val="solid"/>
+                      <a:round/>
+                      <a:headEnd type="none" w="med" len="med"/>
+                      <a:tailEnd type="none" w="med" len="med"/>
+                    </a:lnR>
+                    <a:lnT w="9525" cap="flat" cmpd="sng" algn="ctr">
+                      <a:solidFill>
+                        <a:srgbClr val="E3E8EF"/>
+                      </a:solidFill>
+                      <a:prstDash val="solid"/>
+                      <a:round/>
+                      <a:headEnd type="none" w="med" len="med"/>
+                      <a:tailEnd type="none" w="med" len="med"/>
+                    </a:lnT>
+                    <a:lnB w="9525" cap="flat" cmpd="sng" algn="ctr">
+                      <a:solidFill>
+                        <a:srgbClr val="E3E8EF"/>
+                      </a:solidFill>
+                      <a:prstDash val="solid"/>
+                      <a:round/>
+                      <a:headEnd type="none" w="med" len="med"/>
+                      <a:tailEnd type="none" w="med" len="med"/>
+                    </a:lnB>
+                    <a:solidFill>
+                      <a:srgbClr val="FFFFFF"/>
+                    </a:solidFill>
+                  </a:tcPr>
+                </a:tc>
+                <a:tc>
+                  <a:txBody>
+                    <a:bodyPr/>
+                    <a:lstStyle/>
+                    <a:p>
+                      <a:pPr algn="ctr" indent="0" marL="0">
+                        <a:buNone/>
+                      </a:pPr>
+                      <a:r>
+                        <a:rPr lang="en-US" sz="1250" dirty="0">
+                          <a:solidFill>
+                            <a:srgbClr val="1F2D3D"/>
+                          </a:solidFill>
+                          <a:latin typeface="Calibri" pitchFamily="34" charset="0"/>
+                          <a:ea typeface="Calibri" pitchFamily="34" charset="-122"/>
+                          <a:cs typeface="Calibri" pitchFamily="34" charset="-120"/>
+                        </a:rPr>
+                        <a:t>1 and 6</a:t>
+                      </a:r>
+                      <a:endParaRPr lang="en-US" sz="1250" dirty="0">
+                        <a:latin typeface="Calibri" charset="0"/>
+                        <a:ea typeface="Calibri" charset="0"/>
+                        <a:cs typeface="Calibri" charset="0"/>
+                      </a:endParaRPr>
+                    </a:p>
+                  </a:txBody>
+                  <a:tcPr marL="63500" marR="63500" marT="25400" marB="25400" anchor="ctr">
+                    <a:lnL w="9525" cap="flat" cmpd="sng" algn="ctr">
+                      <a:solidFill>
+                        <a:srgbClr val="E3E8EF"/>
+                      </a:solidFill>
+                      <a:prstDash val="solid"/>
+                      <a:round/>
+                      <a:headEnd type="none" w="med" len="med"/>
+                      <a:tailEnd type="none" w="med" len="med"/>
+                    </a:lnL>
+                    <a:lnR w="9525" cap="flat" cmpd="sng" algn="ctr">
+                      <a:solidFill>
+                        <a:srgbClr val="E3E8EF"/>
+                      </a:solidFill>
+                      <a:prstDash val="solid"/>
+                      <a:round/>
+                      <a:headEnd type="none" w="med" len="med"/>
+                      <a:tailEnd type="none" w="med" len="med"/>
+                    </a:lnR>
+                    <a:lnT w="9525" cap="flat" cmpd="sng" algn="ctr">
+                      <a:solidFill>
+                        <a:srgbClr val="E3E8EF"/>
+                      </a:solidFill>
+                      <a:prstDash val="solid"/>
+                      <a:round/>
+                      <a:headEnd type="none" w="med" len="med"/>
+                      <a:tailEnd type="none" w="med" len="med"/>
+                    </a:lnT>
+                    <a:lnB w="9525" cap="flat" cmpd="sng" algn="ctr">
+                      <a:solidFill>
+                        <a:srgbClr val="E3E8EF"/>
+                      </a:solidFill>
+                      <a:prstDash val="solid"/>
+                      <a:round/>
+                      <a:headEnd type="none" w="med" len="med"/>
+                      <a:tailEnd type="none" w="med" len="med"/>
+                    </a:lnB>
+                    <a:solidFill>
+                      <a:srgbClr val="FFFFFF"/>
+                    </a:solidFill>
+                  </a:tcPr>
+                </a:tc>
+                <a:tc>
+                  <a:txBody>
+                    <a:bodyPr/>
+                    <a:lstStyle/>
+                    <a:p>
+                      <a:pPr algn="l" indent="0" marL="0">
+                        <a:buNone/>
+                      </a:pPr>
+                      <a:r>
+                        <a:rPr lang="en-US" sz="1250" dirty="0">
+                          <a:solidFill>
+                            <a:srgbClr val="1F2D3D"/>
+                          </a:solidFill>
+                          <a:latin typeface="Calibri" pitchFamily="34" charset="0"/>
+                          <a:ea typeface="Calibri" pitchFamily="34" charset="-122"/>
+                          <a:cs typeface="Calibri" pitchFamily="34" charset="-120"/>
+                        </a:rPr>
+                        <a:t>#131 time series and patterns, #132 text preprocessing, #133 dashboard skeleton and overview; Stage 6: deck, final report, contribution summary</a:t>
+                      </a:r>
+                      <a:endParaRPr lang="en-US" sz="1250" dirty="0">
+                        <a:latin typeface="Calibri" charset="0"/>
+                        <a:ea typeface="Calibri" charset="0"/>
+                        <a:cs typeface="Calibri" charset="0"/>
+                      </a:endParaRPr>
+                    </a:p>
+                  </a:txBody>
+                  <a:tcPr marL="63500" marR="63500" marT="25400" marB="25400" anchor="ctr">
+                    <a:lnL w="9525" cap="flat" cmpd="sng" algn="ctr">
+                      <a:solidFill>
+                        <a:srgbClr val="E3E8EF"/>
+                      </a:solidFill>
+                      <a:prstDash val="solid"/>
+                      <a:round/>
+                      <a:headEnd type="none" w="med" len="med"/>
+                      <a:tailEnd type="none" w="med" len="med"/>
+                    </a:lnL>
+                    <a:lnR w="9525" cap="flat" cmpd="sng" algn="ctr">
+                      <a:solidFill>
+                        <a:srgbClr val="E3E8EF"/>
+                      </a:solidFill>
+                      <a:prstDash val="solid"/>
+                      <a:round/>
+                      <a:headEnd type="none" w="med" len="med"/>
+                      <a:tailEnd type="none" w="med" len="med"/>
+                    </a:lnR>
+                    <a:lnT w="9525" cap="flat" cmpd="sng" algn="ctr">
+                      <a:solidFill>
+                        <a:srgbClr val="E3E8EF"/>
+                      </a:solidFill>
+                      <a:prstDash val="solid"/>
+                      <a:round/>
+                      <a:headEnd type="none" w="med" len="med"/>
+                      <a:tailEnd type="none" w="med" len="med"/>
+                    </a:lnT>
+                    <a:lnB w="9525" cap="flat" cmpd="sng" algn="ctr">
+                      <a:solidFill>
+                        <a:srgbClr val="E3E8EF"/>
+                      </a:solidFill>
+                      <a:prstDash val="solid"/>
+                      <a:round/>
+                      <a:headEnd type="none" w="med" len="med"/>
+                      <a:tailEnd type="none" w="med" len="med"/>
+                    </a:lnB>
+                    <a:solidFill>
+                      <a:srgbClr val="FFFFFF"/>
+                    </a:solidFill>
+                  </a:tcPr>
+                </a:tc>
+                <a:tc>
+                  <a:txBody>
+                    <a:bodyPr/>
+                    <a:lstStyle/>
+                    <a:p>
+                      <a:pPr algn="l" indent="0" marL="0">
+                        <a:buNone/>
+                      </a:pPr>
+                      <a:r>
+                        <a:rPr lang="en-US" sz="1250" dirty="0">
+                          <a:solidFill>
+                            <a:srgbClr val="1F2D3D"/>
+                          </a:solidFill>
+                          <a:latin typeface="Calibri" pitchFamily="34" charset="0"/>
+                          <a:ea typeface="Calibri" pitchFamily="34" charset="-122"/>
+                          <a:cs typeface="Calibri" pitchFamily="34" charset="-120"/>
+                        </a:rPr>
+                        <a:t>#147, #148, #149 (8 Oct)</a:t>
+                      </a:r>
+                      <a:endParaRPr lang="en-US" sz="1250" dirty="0">
+                        <a:latin typeface="Calibri" charset="0"/>
+                        <a:ea typeface="Calibri" charset="0"/>
+                        <a:cs typeface="Calibri" charset="0"/>
+                      </a:endParaRPr>
+                    </a:p>
+                  </a:txBody>
+                  <a:tcPr marL="63500" marR="63500" marT="25400" marB="25400" anchor="ctr">
+                    <a:lnL w="9525" cap="flat" cmpd="sng" algn="ctr">
+                      <a:solidFill>
+                        <a:srgbClr val="E3E8EF"/>
+                      </a:solidFill>
+                      <a:prstDash val="solid"/>
+                      <a:round/>
+                      <a:headEnd type="none" w="med" len="med"/>
+                      <a:tailEnd type="none" w="med" len="med"/>
+                    </a:lnL>
+                    <a:lnR w="9525" cap="flat" cmpd="sng" algn="ctr">
+                      <a:solidFill>
+                        <a:srgbClr val="E3E8EF"/>
+                      </a:solidFill>
+                      <a:prstDash val="solid"/>
+                      <a:round/>
+                      <a:headEnd type="none" w="med" len="med"/>
+                      <a:tailEnd type="none" w="med" len="med"/>
+                    </a:lnR>
+                    <a:lnT w="9525" cap="flat" cmpd="sng" algn="ctr">
+                      <a:solidFill>
+                        <a:srgbClr val="E3E8EF"/>
+                      </a:solidFill>
+                      <a:prstDash val="solid"/>
+                      <a:round/>
+                      <a:headEnd type="none" w="med" len="med"/>
+                      <a:tailEnd type="none" w="med" len="med"/>
+                    </a:lnT>
+                    <a:lnB w="9525" cap="flat" cmpd="sng" algn="ctr">
+                      <a:solidFill>
+                        <a:srgbClr val="E3E8EF"/>
+                      </a:solidFill>
+                      <a:prstDash val="solid"/>
+                      <a:round/>
+                      <a:headEnd type="none" w="med" len="med"/>
+                      <a:tailEnd type="none" w="med" len="med"/>
+                    </a:lnB>
+                    <a:solidFill>
+                      <a:srgbClr val="FFFFFF"/>
+                    </a:solidFill>
+                  </a:tcPr>
+                </a:tc>
+                <a:tc>
+                  <a:txBody>
+                    <a:bodyPr/>
+                    <a:lstStyle/>
+                    <a:p>
+                      <a:pPr algn="l" indent="0" marL="0">
+                        <a:buNone/>
+                      </a:pPr>
+                      <a:r>
+                        <a:rPr lang="en-US" sz="1250" dirty="0">
+                          <a:solidFill>
+                            <a:srgbClr val="1F2D3D"/>
+                          </a:solidFill>
+                          <a:latin typeface="Calibri" pitchFamily="34" charset="0"/>
+                          <a:ea typeface="Calibri" pitchFamily="34" charset="-122"/>
+                          <a:cs typeface="Calibri" pitchFamily="34" charset="-120"/>
+                        </a:rPr>
+                        <a:t>scripts 15–16, dashboard/, FINAL_REPORT.md</a:t>
+                      </a:r>
+                      <a:endParaRPr lang="en-US" sz="1250" dirty="0">
+                        <a:latin typeface="Calibri" charset="0"/>
+                        <a:ea typeface="Calibri" charset="0"/>
+                        <a:cs typeface="Calibri" charset="0"/>
+                      </a:endParaRPr>
+                    </a:p>
+                  </a:txBody>
+                  <a:tcPr marL="63500" marR="63500" marT="25400" marB="25400" anchor="ctr">
+                    <a:lnL w="9525" cap="flat" cmpd="sng" algn="ctr">
+                      <a:solidFill>
+                        <a:srgbClr val="E3E8EF"/>
+                      </a:solidFill>
+                      <a:prstDash val="solid"/>
+                      <a:round/>
+                      <a:headEnd type="none" w="med" len="med"/>
+                      <a:tailEnd type="none" w="med" len="med"/>
+                    </a:lnL>
+                    <a:lnR w="9525" cap="flat" cmpd="sng" algn="ctr">
+                      <a:solidFill>
+                        <a:srgbClr val="E3E8EF"/>
+                      </a:solidFill>
+                      <a:prstDash val="solid"/>
+                      <a:round/>
+                      <a:headEnd type="none" w="med" len="med"/>
+                      <a:tailEnd type="none" w="med" len="med"/>
+                    </a:lnR>
+                    <a:lnT w="9525" cap="flat" cmpd="sng" algn="ctr">
+                      <a:solidFill>
+                        <a:srgbClr val="E3E8EF"/>
+                      </a:solidFill>
+                      <a:prstDash val="solid"/>
+                      <a:round/>
+                      <a:headEnd type="none" w="med" len="med"/>
+                      <a:tailEnd type="none" w="med" len="med"/>
+                    </a:lnT>
+                    <a:lnB w="9525" cap="flat" cmpd="sng" algn="ctr">
+                      <a:solidFill>
+                        <a:srgbClr val="E3E8EF"/>
+                      </a:solidFill>
+                      <a:prstDash val="solid"/>
+                      <a:round/>
+                      <a:headEnd type="none" w="med" len="med"/>
+                      <a:tailEnd type="none" w="med" len="med"/>
+                    </a:lnB>
+                    <a:solidFill>
+                      <a:srgbClr val="FFFFFF"/>
+                    </a:solidFill>
+                  </a:tcPr>
+                </a:tc>
+              </a:tr>
+              <a:tr h="685800">
+                <a:tc>
+                  <a:txBody>
+                    <a:bodyPr/>
+                    <a:lstStyle/>
+                    <a:p>
+                      <a:pPr algn="l" indent="0" marL="0">
+                        <a:buNone/>
+                      </a:pPr>
+                      <a:r>
+                        <a:rPr lang="en-US" sz="1250" b="1" dirty="0">
+                          <a:solidFill>
+                            <a:srgbClr val="1F2D3D"/>
+                          </a:solidFill>
+                          <a:latin typeface="Calibri" pitchFamily="34" charset="0"/>
+                          <a:ea typeface="Calibri" pitchFamily="34" charset="-122"/>
+                          <a:cs typeface="Calibri" pitchFamily="34" charset="-120"/>
+                        </a:rPr>
+                        <a:t>Regella Krishna Saketh - CB.SC.U4CSE23649</a:t>
+                      </a:r>
+                      <a:endParaRPr lang="en-US" sz="1250" dirty="0">
+                        <a:latin typeface="Calibri" charset="0"/>
+                        <a:ea typeface="Calibri" charset="0"/>
+                        <a:cs typeface="Calibri" charset="0"/>
+                      </a:endParaRPr>
+                    </a:p>
+                  </a:txBody>
+                  <a:tcPr marL="63500" marR="63500" marT="25400" marB="25400" anchor="ctr">
+                    <a:lnL w="9525" cap="flat" cmpd="sng" algn="ctr">
+                      <a:solidFill>
+                        <a:srgbClr val="E3E8EF"/>
+                      </a:solidFill>
+                      <a:prstDash val="solid"/>
+                      <a:round/>
+                      <a:headEnd type="none" w="med" len="med"/>
+                      <a:tailEnd type="none" w="med" len="med"/>
+                    </a:lnL>
+                    <a:lnR w="9525" cap="flat" cmpd="sng" algn="ctr">
+                      <a:solidFill>
+                        <a:srgbClr val="E3E8EF"/>
+                      </a:solidFill>
+                      <a:prstDash val="solid"/>
+                      <a:round/>
+                      <a:headEnd type="none" w="med" len="med"/>
+                      <a:tailEnd type="none" w="med" len="med"/>
+                    </a:lnR>
+                    <a:lnT w="9525" cap="flat" cmpd="sng" algn="ctr">
+                      <a:solidFill>
+                        <a:srgbClr val="E3E8EF"/>
+                      </a:solidFill>
+                      <a:prstDash val="solid"/>
+                      <a:round/>
+                      <a:headEnd type="none" w="med" len="med"/>
+                      <a:tailEnd type="none" w="med" len="med"/>
+                    </a:lnT>
+                    <a:lnB w="9525" cap="flat" cmpd="sng" algn="ctr">
+                      <a:solidFill>
+                        <a:srgbClr val="E3E8EF"/>
+                      </a:solidFill>
+                      <a:prstDash val="solid"/>
+                      <a:round/>
+                      <a:headEnd type="none" w="med" len="med"/>
+                      <a:tailEnd type="none" w="med" len="med"/>
+                    </a:lnB>
+                    <a:solidFill>
+                      <a:srgbClr val="FBFCFE"/>
+                    </a:solidFill>
+                  </a:tcPr>
+                </a:tc>
+                <a:tc>
+                  <a:txBody>
+                    <a:bodyPr/>
+                    <a:lstStyle/>
+                    <a:p>
+                      <a:pPr algn="ctr" indent="0" marL="0">
+                        <a:buNone/>
+                      </a:pPr>
+                      <a:r>
+                        <a:rPr lang="en-US" sz="1250" dirty="0">
+                          <a:solidFill>
+                            <a:srgbClr val="1F2D3D"/>
+                          </a:solidFill>
+                          <a:latin typeface="Calibri" pitchFamily="34" charset="0"/>
+                          <a:ea typeface="Calibri" pitchFamily="34" charset="-122"/>
+                          <a:cs typeface="Calibri" pitchFamily="34" charset="-120"/>
+                        </a:rPr>
+                        <a:t>2</a:t>
+                      </a:r>
+                      <a:endParaRPr lang="en-US" sz="1250" dirty="0">
+                        <a:latin typeface="Calibri" charset="0"/>
+                        <a:ea typeface="Calibri" charset="0"/>
+                        <a:cs typeface="Calibri" charset="0"/>
+                      </a:endParaRPr>
+                    </a:p>
+                  </a:txBody>
+                  <a:tcPr marL="63500" marR="63500" marT="25400" marB="25400" anchor="ctr">
+                    <a:lnL w="9525" cap="flat" cmpd="sng" algn="ctr">
+                      <a:solidFill>
+                        <a:srgbClr val="E3E8EF"/>
+                      </a:solidFill>
+                      <a:prstDash val="solid"/>
+                      <a:round/>
+                      <a:headEnd type="none" w="med" len="med"/>
+                      <a:tailEnd type="none" w="med" len="med"/>
+                    </a:lnL>
+                    <a:lnR w="9525" cap="flat" cmpd="sng" algn="ctr">
+                      <a:solidFill>
+                        <a:srgbClr val="E3E8EF"/>
+                      </a:solidFill>
+                      <a:prstDash val="solid"/>
+                      <a:round/>
+                      <a:headEnd type="none" w="med" len="med"/>
+                      <a:tailEnd type="none" w="med" len="med"/>
+                    </a:lnR>
+                    <a:lnT w="9525" cap="flat" cmpd="sng" algn="ctr">
+                      <a:solidFill>
+                        <a:srgbClr val="E3E8EF"/>
+                      </a:solidFill>
+                      <a:prstDash val="solid"/>
+                      <a:round/>
+                      <a:headEnd type="none" w="med" len="med"/>
+                      <a:tailEnd type="none" w="med" len="med"/>
+                    </a:lnT>
+                    <a:lnB w="9525" cap="flat" cmpd="sng" algn="ctr">
+                      <a:solidFill>
+                        <a:srgbClr val="E3E8EF"/>
+                      </a:solidFill>
+                      <a:prstDash val="solid"/>
+                      <a:round/>
+                      <a:headEnd type="none" w="med" len="med"/>
+                      <a:tailEnd type="none" w="med" len="med"/>
+                    </a:lnB>
+                    <a:solidFill>
+                      <a:srgbClr val="FBFCFE"/>
+                    </a:solidFill>
+                  </a:tcPr>
+                </a:tc>
+                <a:tc>
+                  <a:txBody>
+                    <a:bodyPr/>
+                    <a:lstStyle/>
+                    <a:p>
+                      <a:pPr algn="l" indent="0" marL="0">
+                        <a:buNone/>
+                      </a:pPr>
+                      <a:r>
+                        <a:rPr lang="en-US" sz="1250" dirty="0">
+                          <a:solidFill>
+                            <a:srgbClr val="1F2D3D"/>
+                          </a:solidFill>
+                          <a:latin typeface="Calibri" pitchFamily="34" charset="0"/>
+                          <a:ea typeface="Calibri" pitchFamily="34" charset="-122"/>
+                          <a:cs typeface="Calibri" pitchFamily="34" charset="-120"/>
+                        </a:rPr>
+                        <a:t>#134 topic modelling and distinctive terms, #136 topic evaluation and interpretation</a:t>
+                      </a:r>
+                      <a:endParaRPr lang="en-US" sz="1250" dirty="0">
+                        <a:latin typeface="Calibri" charset="0"/>
+                        <a:ea typeface="Calibri" charset="0"/>
+                        <a:cs typeface="Calibri" charset="0"/>
+                      </a:endParaRPr>
+                    </a:p>
+                  </a:txBody>
+                  <a:tcPr marL="63500" marR="63500" marT="25400" marB="25400" anchor="ctr">
+                    <a:lnL w="9525" cap="flat" cmpd="sng" algn="ctr">
+                      <a:solidFill>
+                        <a:srgbClr val="E3E8EF"/>
+                      </a:solidFill>
+                      <a:prstDash val="solid"/>
+                      <a:round/>
+                      <a:headEnd type="none" w="med" len="med"/>
+                      <a:tailEnd type="none" w="med" len="med"/>
+                    </a:lnL>
+                    <a:lnR w="9525" cap="flat" cmpd="sng" algn="ctr">
+                      <a:solidFill>
+                        <a:srgbClr val="E3E8EF"/>
+                      </a:solidFill>
+                      <a:prstDash val="solid"/>
+                      <a:round/>
+                      <a:headEnd type="none" w="med" len="med"/>
+                      <a:tailEnd type="none" w="med" len="med"/>
+                    </a:lnR>
+                    <a:lnT w="9525" cap="flat" cmpd="sng" algn="ctr">
+                      <a:solidFill>
+                        <a:srgbClr val="E3E8EF"/>
+                      </a:solidFill>
+                      <a:prstDash val="solid"/>
+                      <a:round/>
+                      <a:headEnd type="none" w="med" len="med"/>
+                      <a:tailEnd type="none" w="med" len="med"/>
+                    </a:lnT>
+                    <a:lnB w="9525" cap="flat" cmpd="sng" algn="ctr">
+                      <a:solidFill>
+                        <a:srgbClr val="E3E8EF"/>
+                      </a:solidFill>
+                      <a:prstDash val="solid"/>
+                      <a:round/>
+                      <a:headEnd type="none" w="med" len="med"/>
+                      <a:tailEnd type="none" w="med" len="med"/>
+                    </a:lnB>
+                    <a:solidFill>
+                      <a:srgbClr val="FBFCFE"/>
+                    </a:solidFill>
+                  </a:tcPr>
+                </a:tc>
+                <a:tc>
+                  <a:txBody>
+                    <a:bodyPr/>
+                    <a:lstStyle/>
+                    <a:p>
+                      <a:pPr algn="l" indent="0" marL="0">
+                        <a:buNone/>
+                      </a:pPr>
+                      <a:r>
+                        <a:rPr lang="en-US" sz="1250" dirty="0">
+                          <a:solidFill>
+                            <a:srgbClr val="1F2D3D"/>
+                          </a:solidFill>
+                          <a:latin typeface="Calibri" pitchFamily="34" charset="0"/>
+                          <a:ea typeface="Calibri" pitchFamily="34" charset="-122"/>
+                          <a:cs typeface="Calibri" pitchFamily="34" charset="-120"/>
+                        </a:rPr>
+                        <a:t>#150, #151 (8 Oct)</a:t>
+                      </a:r>
+                      <a:endParaRPr lang="en-US" sz="1250" dirty="0">
+                        <a:latin typeface="Calibri" charset="0"/>
+                        <a:ea typeface="Calibri" charset="0"/>
+                        <a:cs typeface="Calibri" charset="0"/>
+                      </a:endParaRPr>
+                    </a:p>
+                  </a:txBody>
+                  <a:tcPr marL="63500" marR="63500" marT="25400" marB="25400" anchor="ctr">
+                    <a:lnL w="9525" cap="flat" cmpd="sng" algn="ctr">
+                      <a:solidFill>
+                        <a:srgbClr val="E3E8EF"/>
+                      </a:solidFill>
+                      <a:prstDash val="solid"/>
+                      <a:round/>
+                      <a:headEnd type="none" w="med" len="med"/>
+                      <a:tailEnd type="none" w="med" len="med"/>
+                    </a:lnL>
+                    <a:lnR w="9525" cap="flat" cmpd="sng" algn="ctr">
+                      <a:solidFill>
+                        <a:srgbClr val="E3E8EF"/>
+                      </a:solidFill>
+                      <a:prstDash val="solid"/>
+                      <a:round/>
+                      <a:headEnd type="none" w="med" len="med"/>
+                      <a:tailEnd type="none" w="med" len="med"/>
+                    </a:lnR>
+                    <a:lnT w="9525" cap="flat" cmpd="sng" algn="ctr">
+                      <a:solidFill>
+                        <a:srgbClr val="E3E8EF"/>
+                      </a:solidFill>
+                      <a:prstDash val="solid"/>
+                      <a:round/>
+                      <a:headEnd type="none" w="med" len="med"/>
+                      <a:tailEnd type="none" w="med" len="med"/>
+                    </a:lnT>
+                    <a:lnB w="9525" cap="flat" cmpd="sng" algn="ctr">
+                      <a:solidFill>
+                        <a:srgbClr val="E3E8EF"/>
+                      </a:solidFill>
+                      <a:prstDash val="solid"/>
+                      <a:round/>
+                      <a:headEnd type="none" w="med" len="med"/>
+                      <a:tailEnd type="none" w="med" len="med"/>
+                    </a:lnB>
+                    <a:solidFill>
+                      <a:srgbClr val="FBFCFE"/>
+                    </a:solidFill>
+                  </a:tcPr>
+                </a:tc>
+                <a:tc>
+                  <a:txBody>
+                    <a:bodyPr/>
+                    <a:lstStyle/>
+                    <a:p>
+                      <a:pPr algn="l" indent="0" marL="0">
+                        <a:buNone/>
+                      </a:pPr>
+                      <a:r>
+                        <a:rPr lang="en-US" sz="1250" dirty="0">
+                          <a:solidFill>
+                            <a:srgbClr val="1F2D3D"/>
+                          </a:solidFill>
+                          <a:latin typeface="Calibri" pitchFamily="34" charset="0"/>
+                          <a:ea typeface="Calibri" pitchFamily="34" charset="-122"/>
+                          <a:cs typeface="Calibri" pitchFamily="34" charset="-120"/>
+                        </a:rPr>
+                        <a:t>scripts 17–18, models/textmining/, TEXT_MINING.md §2–3</a:t>
+                      </a:r>
+                      <a:endParaRPr lang="en-US" sz="1250" dirty="0">
+                        <a:latin typeface="Calibri" charset="0"/>
+                        <a:ea typeface="Calibri" charset="0"/>
+                        <a:cs typeface="Calibri" charset="0"/>
+                      </a:endParaRPr>
+                    </a:p>
+                  </a:txBody>
+                  <a:tcPr marL="63500" marR="63500" marT="25400" marB="25400" anchor="ctr">
+                    <a:lnL w="9525" cap="flat" cmpd="sng" algn="ctr">
+                      <a:solidFill>
+                        <a:srgbClr val="E3E8EF"/>
+                      </a:solidFill>
+                      <a:prstDash val="solid"/>
+                      <a:round/>
+                      <a:headEnd type="none" w="med" len="med"/>
+                      <a:tailEnd type="none" w="med" len="med"/>
+                    </a:lnL>
+                    <a:lnR w="9525" cap="flat" cmpd="sng" algn="ctr">
+                      <a:solidFill>
+                        <a:srgbClr val="E3E8EF"/>
+                      </a:solidFill>
+                      <a:prstDash val="solid"/>
+                      <a:round/>
+                      <a:headEnd type="none" w="med" len="med"/>
+                      <a:tailEnd type="none" w="med" len="med"/>
+                    </a:lnR>
+                    <a:lnT w="9525" cap="flat" cmpd="sng" algn="ctr">
+                      <a:solidFill>
+                        <a:srgbClr val="E3E8EF"/>
+                      </a:solidFill>
+                      <a:prstDash val="solid"/>
+                      <a:round/>
+                      <a:headEnd type="none" w="med" len="med"/>
+                      <a:tailEnd type="none" w="med" len="med"/>
+                    </a:lnT>
+                    <a:lnB w="9525" cap="flat" cmpd="sng" algn="ctr">
+                      <a:solidFill>
+                        <a:srgbClr val="E3E8EF"/>
+                      </a:solidFill>
+                      <a:prstDash val="solid"/>
+                      <a:round/>
+                      <a:headEnd type="none" w="med" len="med"/>
+                      <a:tailEnd type="none" w="med" len="med"/>
+                    </a:lnB>
+                    <a:solidFill>
+                      <a:srgbClr val="FBFCFE"/>
+                    </a:solidFill>
+                  </a:tcPr>
+                </a:tc>
+              </a:tr>
+              <a:tr h="777240">
+                <a:tc>
+                  <a:txBody>
+                    <a:bodyPr/>
+                    <a:lstStyle/>
+                    <a:p>
+                      <a:pPr algn="l" indent="0" marL="0">
+                        <a:buNone/>
+                      </a:pPr>
+                      <a:r>
+                        <a:rPr lang="en-US" sz="1250" b="1" dirty="0">
+                          <a:solidFill>
+                            <a:srgbClr val="1F2D3D"/>
+                          </a:solidFill>
+                          <a:latin typeface="Calibri" pitchFamily="34" charset="0"/>
+                          <a:ea typeface="Calibri" pitchFamily="34" charset="-122"/>
+                          <a:cs typeface="Calibri" pitchFamily="34" charset="-120"/>
+                        </a:rPr>
+                        <a:t>Akshay KS - CB.SC.U4CSE23104</a:t>
+                      </a:r>
+                      <a:endParaRPr lang="en-US" sz="1250" dirty="0">
+                        <a:latin typeface="Calibri" charset="0"/>
+                        <a:ea typeface="Calibri" charset="0"/>
+                        <a:cs typeface="Calibri" charset="0"/>
+                      </a:endParaRPr>
+                    </a:p>
+                  </a:txBody>
+                  <a:tcPr marL="63500" marR="63500" marT="25400" marB="25400" anchor="ctr">
+                    <a:lnL w="9525" cap="flat" cmpd="sng" algn="ctr">
+                      <a:solidFill>
+                        <a:srgbClr val="E3E8EF"/>
+                      </a:solidFill>
+                      <a:prstDash val="solid"/>
+                      <a:round/>
+                      <a:headEnd type="none" w="med" len="med"/>
+                      <a:tailEnd type="none" w="med" len="med"/>
+                    </a:lnL>
+                    <a:lnR w="9525" cap="flat" cmpd="sng" algn="ctr">
+                      <a:solidFill>
+                        <a:srgbClr val="E3E8EF"/>
+                      </a:solidFill>
+                      <a:prstDash val="solid"/>
+                      <a:round/>
+                      <a:headEnd type="none" w="med" len="med"/>
+                      <a:tailEnd type="none" w="med" len="med"/>
+                    </a:lnR>
+                    <a:lnT w="9525" cap="flat" cmpd="sng" algn="ctr">
+                      <a:solidFill>
+                        <a:srgbClr val="E3E8EF"/>
+                      </a:solidFill>
+                      <a:prstDash val="solid"/>
+                      <a:round/>
+                      <a:headEnd type="none" w="med" len="med"/>
+                      <a:tailEnd type="none" w="med" len="med"/>
+                    </a:lnT>
+                    <a:lnB w="9525" cap="flat" cmpd="sng" algn="ctr">
+                      <a:solidFill>
+                        <a:srgbClr val="E3E8EF"/>
+                      </a:solidFill>
+                      <a:prstDash val="solid"/>
+                      <a:round/>
+                      <a:headEnd type="none" w="med" len="med"/>
+                      <a:tailEnd type="none" w="med" len="med"/>
+                    </a:lnB>
+                    <a:solidFill>
+                      <a:srgbClr val="FFFFFF"/>
+                    </a:solidFill>
+                  </a:tcPr>
+                </a:tc>
+                <a:tc>
+                  <a:txBody>
+                    <a:bodyPr/>
+                    <a:lstStyle/>
+                    <a:p>
+                      <a:pPr algn="ctr" indent="0" marL="0">
+                        <a:buNone/>
+                      </a:pPr>
+                      <a:r>
+                        <a:rPr lang="en-US" sz="1250" dirty="0">
+                          <a:solidFill>
+                            <a:srgbClr val="1F2D3D"/>
+                          </a:solidFill>
+                          <a:latin typeface="Calibri" pitchFamily="34" charset="0"/>
+                          <a:ea typeface="Calibri" pitchFamily="34" charset="-122"/>
+                          <a:cs typeface="Calibri" pitchFamily="34" charset="-120"/>
+                        </a:rPr>
+                        <a:t>3</a:t>
+                      </a:r>
+                      <a:endParaRPr lang="en-US" sz="1250" dirty="0">
+                        <a:latin typeface="Calibri" charset="0"/>
+                        <a:ea typeface="Calibri" charset="0"/>
+                        <a:cs typeface="Calibri" charset="0"/>
+                      </a:endParaRPr>
+                    </a:p>
+                  </a:txBody>
+                  <a:tcPr marL="63500" marR="63500" marT="25400" marB="25400" anchor="ctr">
+                    <a:lnL w="9525" cap="flat" cmpd="sng" algn="ctr">
+                      <a:solidFill>
+                        <a:srgbClr val="E3E8EF"/>
+                      </a:solidFill>
+                      <a:prstDash val="solid"/>
+                      <a:round/>
+                      <a:headEnd type="none" w="med" len="med"/>
+                      <a:tailEnd type="none" w="med" len="med"/>
+                    </a:lnL>
+                    <a:lnR w="9525" cap="flat" cmpd="sng" algn="ctr">
+                      <a:solidFill>
+                        <a:srgbClr val="E3E8EF"/>
+                      </a:solidFill>
+                      <a:prstDash val="solid"/>
+                      <a:round/>
+                      <a:headEnd type="none" w="med" len="med"/>
+                      <a:tailEnd type="none" w="med" len="med"/>
+                    </a:lnR>
+                    <a:lnT w="9525" cap="flat" cmpd="sng" algn="ctr">
+                      <a:solidFill>
+                        <a:srgbClr val="E3E8EF"/>
+                      </a:solidFill>
+                      <a:prstDash val="solid"/>
+                      <a:round/>
+                      <a:headEnd type="none" w="med" len="med"/>
+                      <a:tailEnd type="none" w="med" len="med"/>
+                    </a:lnT>
+                    <a:lnB w="9525" cap="flat" cmpd="sng" algn="ctr">
+                      <a:solidFill>
+                        <a:srgbClr val="E3E8EF"/>
+                      </a:solidFill>
+                      <a:prstDash val="solid"/>
+                      <a:round/>
+                      <a:headEnd type="none" w="med" len="med"/>
+                      <a:tailEnd type="none" w="med" len="med"/>
+                    </a:lnB>
+                    <a:solidFill>
+                      <a:srgbClr val="FFFFFF"/>
+                    </a:solidFill>
+                  </a:tcPr>
+                </a:tc>
+                <a:tc>
+                  <a:txBody>
+                    <a:bodyPr/>
+                    <a:lstStyle/>
+                    <a:p>
+                      <a:pPr algn="l" indent="0" marL="0">
+                        <a:buNone/>
+                      </a:pPr>
+                      <a:r>
+                        <a:rPr lang="en-US" sz="1250" dirty="0">
+                          <a:solidFill>
+                            <a:srgbClr val="1F2D3D"/>
+                          </a:solidFill>
+                          <a:latin typeface="Calibri" pitchFamily="34" charset="0"/>
+                          <a:ea typeface="Calibri" pitchFamily="34" charset="-122"/>
+                          <a:cs typeface="Calibri" pitchFamily="34" charset="-120"/>
+                        </a:rPr>
+                        <a:t>#135 ARIMA forecasting with rolling backtest, #139 text-mining dashboard page</a:t>
+                      </a:r>
+                      <a:endParaRPr lang="en-US" sz="1250" dirty="0">
+                        <a:latin typeface="Calibri" charset="0"/>
+                        <a:ea typeface="Calibri" charset="0"/>
+                        <a:cs typeface="Calibri" charset="0"/>
+                      </a:endParaRPr>
+                    </a:p>
+                  </a:txBody>
+                  <a:tcPr marL="63500" marR="63500" marT="25400" marB="25400" anchor="ctr">
+                    <a:lnL w="9525" cap="flat" cmpd="sng" algn="ctr">
+                      <a:solidFill>
+                        <a:srgbClr val="E3E8EF"/>
+                      </a:solidFill>
+                      <a:prstDash val="solid"/>
+                      <a:round/>
+                      <a:headEnd type="none" w="med" len="med"/>
+                      <a:tailEnd type="none" w="med" len="med"/>
+                    </a:lnL>
+                    <a:lnR w="9525" cap="flat" cmpd="sng" algn="ctr">
+                      <a:solidFill>
+                        <a:srgbClr val="E3E8EF"/>
+                      </a:solidFill>
+                      <a:prstDash val="solid"/>
+                      <a:round/>
+                      <a:headEnd type="none" w="med" len="med"/>
+                      <a:tailEnd type="none" w="med" len="med"/>
+                    </a:lnR>
+                    <a:lnT w="9525" cap="flat" cmpd="sng" algn="ctr">
+                      <a:solidFill>
+                        <a:srgbClr val="E3E8EF"/>
+                      </a:solidFill>
+                      <a:prstDash val="solid"/>
+                      <a:round/>
+                      <a:headEnd type="none" w="med" len="med"/>
+                      <a:tailEnd type="none" w="med" len="med"/>
+                    </a:lnT>
+                    <a:lnB w="9525" cap="flat" cmpd="sng" algn="ctr">
+                      <a:solidFill>
+                        <a:srgbClr val="E3E8EF"/>
+                      </a:solidFill>
+                      <a:prstDash val="solid"/>
+                      <a:round/>
+                      <a:headEnd type="none" w="med" len="med"/>
+                      <a:tailEnd type="none" w="med" len="med"/>
+                    </a:lnB>
+                    <a:solidFill>
+                      <a:srgbClr val="FFFFFF"/>
+                    </a:solidFill>
+                  </a:tcPr>
+                </a:tc>
+                <a:tc>
+                  <a:txBody>
+                    <a:bodyPr/>
+                    <a:lstStyle/>
+                    <a:p>
+                      <a:pPr algn="l" indent="0" marL="0">
+                        <a:buNone/>
+                      </a:pPr>
+                      <a:r>
+                        <a:rPr lang="en-US" sz="1250" dirty="0">
+                          <a:solidFill>
+                            <a:srgbClr val="1F2D3D"/>
+                          </a:solidFill>
+                          <a:latin typeface="Calibri" pitchFamily="34" charset="0"/>
+                          <a:ea typeface="Calibri" pitchFamily="34" charset="-122"/>
+                          <a:cs typeface="Calibri" pitchFamily="34" charset="-120"/>
+                        </a:rPr>
+                        <a:t>#152, #153 (9 Oct)</a:t>
+                      </a:r>
+                      <a:endParaRPr lang="en-US" sz="1250" dirty="0">
+                        <a:latin typeface="Calibri" charset="0"/>
+                        <a:ea typeface="Calibri" charset="0"/>
+                        <a:cs typeface="Calibri" charset="0"/>
+                      </a:endParaRPr>
+                    </a:p>
+                  </a:txBody>
+                  <a:tcPr marL="63500" marR="63500" marT="25400" marB="25400" anchor="ctr">
+                    <a:lnL w="9525" cap="flat" cmpd="sng" algn="ctr">
+                      <a:solidFill>
+                        <a:srgbClr val="E3E8EF"/>
+                      </a:solidFill>
+                      <a:prstDash val="solid"/>
+                      <a:round/>
+                      <a:headEnd type="none" w="med" len="med"/>
+                      <a:tailEnd type="none" w="med" len="med"/>
+                    </a:lnL>
+                    <a:lnR w="9525" cap="flat" cmpd="sng" algn="ctr">
+                      <a:solidFill>
+                        <a:srgbClr val="E3E8EF"/>
+                      </a:solidFill>
+                      <a:prstDash val="solid"/>
+                      <a:round/>
+                      <a:headEnd type="none" w="med" len="med"/>
+                      <a:tailEnd type="none" w="med" len="med"/>
+                    </a:lnR>
+                    <a:lnT w="9525" cap="flat" cmpd="sng" algn="ctr">
+                      <a:solidFill>
+                        <a:srgbClr val="E3E8EF"/>
+                      </a:solidFill>
+                      <a:prstDash val="solid"/>
+                      <a:round/>
+                      <a:headEnd type="none" w="med" len="med"/>
+                      <a:tailEnd type="none" w="med" len="med"/>
+                    </a:lnT>
+                    <a:lnB w="9525" cap="flat" cmpd="sng" algn="ctr">
+                      <a:solidFill>
+                        <a:srgbClr val="E3E8EF"/>
+                      </a:solidFill>
+                      <a:prstDash val="solid"/>
+                      <a:round/>
+                      <a:headEnd type="none" w="med" len="med"/>
+                      <a:tailEnd type="none" w="med" len="med"/>
+                    </a:lnB>
+                    <a:solidFill>
+                      <a:srgbClr val="FFFFFF"/>
+                    </a:solidFill>
+                  </a:tcPr>
+                </a:tc>
+                <a:tc>
+                  <a:txBody>
+                    <a:bodyPr/>
+                    <a:lstStyle/>
+                    <a:p>
+                      <a:pPr algn="l" indent="0" marL="0">
+                        <a:buNone/>
+                      </a:pPr>
+                      <a:r>
+                        <a:rPr lang="en-US" sz="1250" dirty="0">
+                          <a:solidFill>
+                            <a:srgbClr val="1F2D3D"/>
+                          </a:solidFill>
+                          <a:latin typeface="Calibri" pitchFamily="34" charset="0"/>
+                          <a:ea typeface="Calibri" pitchFamily="34" charset="-122"/>
+                          <a:cs typeface="Calibri" pitchFamily="34" charset="-120"/>
+                        </a:rPr>
+                        <a:t>scripts/19_forecasting.py, 20_topic_examples.py, TIME_SERIES.md §2, text_mining.py</a:t>
+                      </a:r>
+                      <a:endParaRPr lang="en-US" sz="1250" dirty="0">
+                        <a:latin typeface="Calibri" charset="0"/>
+                        <a:ea typeface="Calibri" charset="0"/>
+                        <a:cs typeface="Calibri" charset="0"/>
+                      </a:endParaRPr>
+                    </a:p>
+                  </a:txBody>
+                  <a:tcPr marL="63500" marR="63500" marT="25400" marB="25400" anchor="ctr">
+                    <a:lnL w="9525" cap="flat" cmpd="sng" algn="ctr">
+                      <a:solidFill>
+                        <a:srgbClr val="E3E8EF"/>
+                      </a:solidFill>
+                      <a:prstDash val="solid"/>
+                      <a:round/>
+                      <a:headEnd type="none" w="med" len="med"/>
+                      <a:tailEnd type="none" w="med" len="med"/>
+                    </a:lnL>
+                    <a:lnR w="9525" cap="flat" cmpd="sng" algn="ctr">
+                      <a:solidFill>
+                        <a:srgbClr val="E3E8EF"/>
+                      </a:solidFill>
+                      <a:prstDash val="solid"/>
+                      <a:round/>
+                      <a:headEnd type="none" w="med" len="med"/>
+                      <a:tailEnd type="none" w="med" len="med"/>
+                    </a:lnR>
+                    <a:lnT w="9525" cap="flat" cmpd="sng" algn="ctr">
+                      <a:solidFill>
+                        <a:srgbClr val="E3E8EF"/>
+                      </a:solidFill>
+                      <a:prstDash val="solid"/>
+                      <a:round/>
+                      <a:headEnd type="none" w="med" len="med"/>
+                      <a:tailEnd type="none" w="med" len="med"/>
+                    </a:lnT>
+                    <a:lnB w="9525" cap="flat" cmpd="sng" algn="ctr">
+                      <a:solidFill>
+                        <a:srgbClr val="E3E8EF"/>
+                      </a:solidFill>
+                      <a:prstDash val="solid"/>
+                      <a:round/>
+                      <a:headEnd type="none" w="med" len="med"/>
+                      <a:tailEnd type="none" w="med" len="med"/>
+                    </a:lnB>
+                    <a:solidFill>
+                      <a:srgbClr val="FFFFFF"/>
+                    </a:solidFill>
+                  </a:tcPr>
+                </a:tc>
+              </a:tr>
+              <a:tr h="685800">
+                <a:tc>
+                  <a:txBody>
+                    <a:bodyPr/>
+                    <a:lstStyle/>
+                    <a:p>
+                      <a:pPr algn="l" indent="0" marL="0">
+                        <a:buNone/>
+                      </a:pPr>
+                      <a:r>
+                        <a:rPr lang="en-US" sz="1250" b="1" dirty="0">
+                          <a:solidFill>
+                            <a:srgbClr val="1F2D3D"/>
+                          </a:solidFill>
+                          <a:latin typeface="Calibri" pitchFamily="34" charset="0"/>
+                          <a:ea typeface="Calibri" pitchFamily="34" charset="-122"/>
+                          <a:cs typeface="Calibri" pitchFamily="34" charset="-120"/>
+                        </a:rPr>
+                        <a:t>Harshini Vennela - CB.SC.U4CSE23455</a:t>
+                      </a:r>
+                      <a:endParaRPr lang="en-US" sz="1250" dirty="0">
+                        <a:latin typeface="Calibri" charset="0"/>
+                        <a:ea typeface="Calibri" charset="0"/>
+                        <a:cs typeface="Calibri" charset="0"/>
+                      </a:endParaRPr>
+                    </a:p>
+                  </a:txBody>
+                  <a:tcPr marL="63500" marR="63500" marT="25400" marB="25400" anchor="ctr">
+                    <a:lnL w="9525" cap="flat" cmpd="sng" algn="ctr">
+                      <a:solidFill>
+                        <a:srgbClr val="E3E8EF"/>
+                      </a:solidFill>
+                      <a:prstDash val="solid"/>
+                      <a:round/>
+                      <a:headEnd type="none" w="med" len="med"/>
+                      <a:tailEnd type="none" w="med" len="med"/>
+                    </a:lnL>
+                    <a:lnR w="9525" cap="flat" cmpd="sng" algn="ctr">
+                      <a:solidFill>
+                        <a:srgbClr val="E3E8EF"/>
+                      </a:solidFill>
+                      <a:prstDash val="solid"/>
+                      <a:round/>
+                      <a:headEnd type="none" w="med" len="med"/>
+                      <a:tailEnd type="none" w="med" len="med"/>
+                    </a:lnR>
+                    <a:lnT w="9525" cap="flat" cmpd="sng" algn="ctr">
+                      <a:solidFill>
+                        <a:srgbClr val="E3E8EF"/>
+                      </a:solidFill>
+                      <a:prstDash val="solid"/>
+                      <a:round/>
+                      <a:headEnd type="none" w="med" len="med"/>
+                      <a:tailEnd type="none" w="med" len="med"/>
+                    </a:lnT>
+                    <a:lnB w="9525" cap="flat" cmpd="sng" algn="ctr">
+                      <a:solidFill>
+                        <a:srgbClr val="E3E8EF"/>
+                      </a:solidFill>
+                      <a:prstDash val="solid"/>
+                      <a:round/>
+                      <a:headEnd type="none" w="med" len="med"/>
+                      <a:tailEnd type="none" w="med" len="med"/>
+                    </a:lnB>
+                    <a:solidFill>
+                      <a:srgbClr val="FBFCFE"/>
+                    </a:solidFill>
+                  </a:tcPr>
+                </a:tc>
+                <a:tc>
+                  <a:txBody>
+                    <a:bodyPr/>
+                    <a:lstStyle/>
+                    <a:p>
+                      <a:pPr algn="ctr" indent="0" marL="0">
+                        <a:buNone/>
+                      </a:pPr>
+                      <a:r>
+                        <a:rPr lang="en-US" sz="1250" dirty="0">
+                          <a:solidFill>
+                            <a:srgbClr val="1F2D3D"/>
+                          </a:solidFill>
+                          <a:latin typeface="Calibri" pitchFamily="34" charset="0"/>
+                          <a:ea typeface="Calibri" pitchFamily="34" charset="-122"/>
+                          <a:cs typeface="Calibri" pitchFamily="34" charset="-120"/>
+                        </a:rPr>
+                        <a:t>4</a:t>
+                      </a:r>
+                      <a:endParaRPr lang="en-US" sz="1250" dirty="0">
+                        <a:latin typeface="Calibri" charset="0"/>
+                        <a:ea typeface="Calibri" charset="0"/>
+                        <a:cs typeface="Calibri" charset="0"/>
+                      </a:endParaRPr>
+                    </a:p>
+                  </a:txBody>
+                  <a:tcPr marL="63500" marR="63500" marT="25400" marB="25400" anchor="ctr">
+                    <a:lnL w="9525" cap="flat" cmpd="sng" algn="ctr">
+                      <a:solidFill>
+                        <a:srgbClr val="E3E8EF"/>
+                      </a:solidFill>
+                      <a:prstDash val="solid"/>
+                      <a:round/>
+                      <a:headEnd type="none" w="med" len="med"/>
+                      <a:tailEnd type="none" w="med" len="med"/>
+                    </a:lnL>
+                    <a:lnR w="9525" cap="flat" cmpd="sng" algn="ctr">
+                      <a:solidFill>
+                        <a:srgbClr val="E3E8EF"/>
+                      </a:solidFill>
+                      <a:prstDash val="solid"/>
+                      <a:round/>
+                      <a:headEnd type="none" w="med" len="med"/>
+                      <a:tailEnd type="none" w="med" len="med"/>
+                    </a:lnR>
+                    <a:lnT w="9525" cap="flat" cmpd="sng" algn="ctr">
+                      <a:solidFill>
+                        <a:srgbClr val="E3E8EF"/>
+                      </a:solidFill>
+                      <a:prstDash val="solid"/>
+                      <a:round/>
+                      <a:headEnd type="none" w="med" len="med"/>
+                      <a:tailEnd type="none" w="med" len="med"/>
+                    </a:lnT>
+                    <a:lnB w="9525" cap="flat" cmpd="sng" algn="ctr">
+                      <a:solidFill>
+                        <a:srgbClr val="E3E8EF"/>
+                      </a:solidFill>
+                      <a:prstDash val="solid"/>
+                      <a:round/>
+                      <a:headEnd type="none" w="med" len="med"/>
+                      <a:tailEnd type="none" w="med" len="med"/>
+                    </a:lnB>
+                    <a:solidFill>
+                      <a:srgbClr val="FBFCFE"/>
+                    </a:solidFill>
+                  </a:tcPr>
+                </a:tc>
+                <a:tc>
+                  <a:txBody>
+                    <a:bodyPr/>
+                    <a:lstStyle/>
+                    <a:p>
+                      <a:pPr algn="l" indent="0" marL="0">
+                        <a:buNone/>
+                      </a:pPr>
+                      <a:r>
+                        <a:rPr lang="en-US" sz="1250" dirty="0">
+                          <a:solidFill>
+                            <a:srgbClr val="1F2D3D"/>
+                          </a:solidFill>
+                          <a:latin typeface="Calibri" pitchFamily="34" charset="0"/>
+                          <a:ea typeface="Calibri" pitchFamily="34" charset="-122"/>
+                          <a:cs typeface="Calibri" pitchFamily="34" charset="-120"/>
+                        </a:rPr>
+                        <a:t>#137 forecast evaluation and alerts, #142 forecast write-up, #146 check-a-review page</a:t>
+                      </a:r>
+                      <a:endParaRPr lang="en-US" sz="1250" dirty="0">
+                        <a:latin typeface="Calibri" charset="0"/>
+                        <a:ea typeface="Calibri" charset="0"/>
+                        <a:cs typeface="Calibri" charset="0"/>
+                      </a:endParaRPr>
+                    </a:p>
+                  </a:txBody>
+                  <a:tcPr marL="63500" marR="63500" marT="25400" marB="25400" anchor="ctr">
+                    <a:lnL w="9525" cap="flat" cmpd="sng" algn="ctr">
+                      <a:solidFill>
+                        <a:srgbClr val="E3E8EF"/>
+                      </a:solidFill>
+                      <a:prstDash val="solid"/>
+                      <a:round/>
+                      <a:headEnd type="none" w="med" len="med"/>
+                      <a:tailEnd type="none" w="med" len="med"/>
+                    </a:lnL>
+                    <a:lnR w="9525" cap="flat" cmpd="sng" algn="ctr">
+                      <a:solidFill>
+                        <a:srgbClr val="E3E8EF"/>
+                      </a:solidFill>
+                      <a:prstDash val="solid"/>
+                      <a:round/>
+                      <a:headEnd type="none" w="med" len="med"/>
+                      <a:tailEnd type="none" w="med" len="med"/>
+                    </a:lnR>
+                    <a:lnT w="9525" cap="flat" cmpd="sng" algn="ctr">
+                      <a:solidFill>
+                        <a:srgbClr val="E3E8EF"/>
+                      </a:solidFill>
+                      <a:prstDash val="solid"/>
+                      <a:round/>
+                      <a:headEnd type="none" w="med" len="med"/>
+                      <a:tailEnd type="none" w="med" len="med"/>
+                    </a:lnT>
+                    <a:lnB w="9525" cap="flat" cmpd="sng" algn="ctr">
+                      <a:solidFill>
+                        <a:srgbClr val="E3E8EF"/>
+                      </a:solidFill>
+                      <a:prstDash val="solid"/>
+                      <a:round/>
+                      <a:headEnd type="none" w="med" len="med"/>
+                      <a:tailEnd type="none" w="med" len="med"/>
+                    </a:lnB>
+                    <a:solidFill>
+                      <a:srgbClr val="FBFCFE"/>
+                    </a:solidFill>
+                  </a:tcPr>
+                </a:tc>
+                <a:tc>
+                  <a:txBody>
+                    <a:bodyPr/>
+                    <a:lstStyle/>
+                    <a:p>
+                      <a:pPr algn="l" indent="0" marL="0">
+                        <a:buNone/>
+                      </a:pPr>
+                      <a:r>
+                        <a:rPr lang="en-US" sz="1250" dirty="0">
+                          <a:solidFill>
+                            <a:srgbClr val="1F2D3D"/>
+                          </a:solidFill>
+                          <a:latin typeface="Calibri" pitchFamily="34" charset="0"/>
+                          <a:ea typeface="Calibri" pitchFamily="34" charset="-122"/>
+                          <a:cs typeface="Calibri" pitchFamily="34" charset="-120"/>
+                        </a:rPr>
+                        <a:t>#154, #155, #156 (10 Oct)</a:t>
+                      </a:r>
+                      <a:endParaRPr lang="en-US" sz="1250" dirty="0">
+                        <a:latin typeface="Calibri" charset="0"/>
+                        <a:ea typeface="Calibri" charset="0"/>
+                        <a:cs typeface="Calibri" charset="0"/>
+                      </a:endParaRPr>
+                    </a:p>
+                  </a:txBody>
+                  <a:tcPr marL="63500" marR="63500" marT="25400" marB="25400" anchor="ctr">
+                    <a:lnL w="9525" cap="flat" cmpd="sng" algn="ctr">
+                      <a:solidFill>
+                        <a:srgbClr val="E3E8EF"/>
+                      </a:solidFill>
+                      <a:prstDash val="solid"/>
+                      <a:round/>
+                      <a:headEnd type="none" w="med" len="med"/>
+                      <a:tailEnd type="none" w="med" len="med"/>
+                    </a:lnL>
+                    <a:lnR w="9525" cap="flat" cmpd="sng" algn="ctr">
+                      <a:solidFill>
+                        <a:srgbClr val="E3E8EF"/>
+                      </a:solidFill>
+                      <a:prstDash val="solid"/>
+                      <a:round/>
+                      <a:headEnd type="none" w="med" len="med"/>
+                      <a:tailEnd type="none" w="med" len="med"/>
+                    </a:lnR>
+                    <a:lnT w="9525" cap="flat" cmpd="sng" algn="ctr">
+                      <a:solidFill>
+                        <a:srgbClr val="E3E8EF"/>
+                      </a:solidFill>
+                      <a:prstDash val="solid"/>
+                      <a:round/>
+                      <a:headEnd type="none" w="med" len="med"/>
+                      <a:tailEnd type="none" w="med" len="med"/>
+                    </a:lnT>
+                    <a:lnB w="9525" cap="flat" cmpd="sng" algn="ctr">
+                      <a:solidFill>
+                        <a:srgbClr val="E3E8EF"/>
+                      </a:solidFill>
+                      <a:prstDash val="solid"/>
+                      <a:round/>
+                      <a:headEnd type="none" w="med" len="med"/>
+                      <a:tailEnd type="none" w="med" len="med"/>
+                    </a:lnB>
+                    <a:solidFill>
+                      <a:srgbClr val="FBFCFE"/>
+                    </a:solidFill>
+                  </a:tcPr>
+                </a:tc>
+                <a:tc>
+                  <a:txBody>
+                    <a:bodyPr/>
+                    <a:lstStyle/>
+                    <a:p>
+                      <a:pPr algn="l" indent="0" marL="0">
+                        <a:buNone/>
+                      </a:pPr>
+                      <a:r>
+                        <a:rPr lang="en-US" sz="1250" dirty="0">
+                          <a:solidFill>
+                            <a:srgbClr val="1F2D3D"/>
+                          </a:solidFill>
+                          <a:latin typeface="Calibri" pitchFamily="34" charset="0"/>
+                          <a:ea typeface="Calibri" pitchFamily="34" charset="-122"/>
+                          <a:cs typeface="Calibri" pitchFamily="34" charset="-120"/>
+                        </a:rPr>
+                        <a:t>scripts/20_forecast_evaluation.py, TIME_SERIES.md §2.5, check_review.py</a:t>
+                      </a:r>
+                      <a:endParaRPr lang="en-US" sz="1250" dirty="0">
+                        <a:latin typeface="Calibri" charset="0"/>
+                        <a:ea typeface="Calibri" charset="0"/>
+                        <a:cs typeface="Calibri" charset="0"/>
+                      </a:endParaRPr>
+                    </a:p>
+                  </a:txBody>
+                  <a:tcPr marL="63500" marR="63500" marT="25400" marB="25400" anchor="ctr">
+                    <a:lnL w="9525" cap="flat" cmpd="sng" algn="ctr">
+                      <a:solidFill>
+                        <a:srgbClr val="E3E8EF"/>
+                      </a:solidFill>
+                      <a:prstDash val="solid"/>
+                      <a:round/>
+                      <a:headEnd type="none" w="med" len="med"/>
+                      <a:tailEnd type="none" w="med" len="med"/>
+                    </a:lnL>
+                    <a:lnR w="9525" cap="flat" cmpd="sng" algn="ctr">
+                      <a:solidFill>
+                        <a:srgbClr val="E3E8EF"/>
+                      </a:solidFill>
+                      <a:prstDash val="solid"/>
+                      <a:round/>
+                      <a:headEnd type="none" w="med" len="med"/>
+                      <a:tailEnd type="none" w="med" len="med"/>
+                    </a:lnR>
+                    <a:lnT w="9525" cap="flat" cmpd="sng" algn="ctr">
+                      <a:solidFill>
+                        <a:srgbClr val="E3E8EF"/>
+                      </a:solidFill>
+                      <a:prstDash val="solid"/>
+                      <a:round/>
+                      <a:headEnd type="none" w="med" len="med"/>
+                      <a:tailEnd type="none" w="med" len="med"/>
+                    </a:lnT>
+                    <a:lnB w="9525" cap="flat" cmpd="sng" algn="ctr">
+                      <a:solidFill>
+                        <a:srgbClr val="E3E8EF"/>
+                      </a:solidFill>
+                      <a:prstDash val="solid"/>
+                      <a:round/>
+                      <a:headEnd type="none" w="med" len="med"/>
+                      <a:tailEnd type="none" w="med" len="med"/>
+                    </a:lnB>
+                    <a:solidFill>
+                      <a:srgbClr val="FBFCFE"/>
+                    </a:solidFill>
+                  </a:tcPr>
+                </a:tc>
+              </a:tr>
+              <a:tr h="685800">
+                <a:tc>
+                  <a:txBody>
+                    <a:bodyPr/>
+                    <a:lstStyle/>
+                    <a:p>
+                      <a:pPr algn="l" indent="0" marL="0">
+                        <a:buNone/>
+                      </a:pPr>
+                      <a:r>
+                        <a:rPr lang="en-US" sz="1250" b="1" dirty="0">
+                          <a:solidFill>
+                            <a:srgbClr val="1F2D3D"/>
+                          </a:solidFill>
+                          <a:latin typeface="Calibri" pitchFamily="34" charset="0"/>
+                          <a:ea typeface="Calibri" pitchFamily="34" charset="-122"/>
+                          <a:cs typeface="Calibri" pitchFamily="34" charset="-120"/>
+                        </a:rPr>
+                        <a:t>Kanishka D - CB.SC.U4CSE23155</a:t>
+                      </a:r>
+                      <a:endParaRPr lang="en-US" sz="1250" dirty="0">
+                        <a:latin typeface="Calibri" charset="0"/>
+                        <a:ea typeface="Calibri" charset="0"/>
+                        <a:cs typeface="Calibri" charset="0"/>
+                      </a:endParaRPr>
+                    </a:p>
+                  </a:txBody>
+                  <a:tcPr marL="63500" marR="63500" marT="25400" marB="25400" anchor="ctr">
+                    <a:lnL w="9525" cap="flat" cmpd="sng" algn="ctr">
+                      <a:solidFill>
+                        <a:srgbClr val="E3E8EF"/>
+                      </a:solidFill>
+                      <a:prstDash val="solid"/>
+                      <a:round/>
+                      <a:headEnd type="none" w="med" len="med"/>
+                      <a:tailEnd type="none" w="med" len="med"/>
+                    </a:lnL>
+                    <a:lnR w="9525" cap="flat" cmpd="sng" algn="ctr">
+                      <a:solidFill>
+                        <a:srgbClr val="E3E8EF"/>
+                      </a:solidFill>
+                      <a:prstDash val="solid"/>
+                      <a:round/>
+                      <a:headEnd type="none" w="med" len="med"/>
+                      <a:tailEnd type="none" w="med" len="med"/>
+                    </a:lnR>
+                    <a:lnT w="9525" cap="flat" cmpd="sng" algn="ctr">
+                      <a:solidFill>
+                        <a:srgbClr val="E3E8EF"/>
+                      </a:solidFill>
+                      <a:prstDash val="solid"/>
+                      <a:round/>
+                      <a:headEnd type="none" w="med" len="med"/>
+                      <a:tailEnd type="none" w="med" len="med"/>
+                    </a:lnT>
+                    <a:lnB w="9525" cap="flat" cmpd="sng" algn="ctr">
+                      <a:solidFill>
+                        <a:srgbClr val="E3E8EF"/>
+                      </a:solidFill>
+                      <a:prstDash val="solid"/>
+                      <a:round/>
+                      <a:headEnd type="none" w="med" len="med"/>
+                      <a:tailEnd type="none" w="med" len="med"/>
+                    </a:lnB>
+                    <a:solidFill>
+                      <a:srgbClr val="FFFFFF"/>
+                    </a:solidFill>
+                  </a:tcPr>
+                </a:tc>
+                <a:tc>
+                  <a:txBody>
+                    <a:bodyPr/>
+                    <a:lstStyle/>
+                    <a:p>
+                      <a:pPr algn="ctr" indent="0" marL="0">
+                        <a:buNone/>
+                      </a:pPr>
+                      <a:r>
+                        <a:rPr lang="en-US" sz="1250" dirty="0">
+                          <a:solidFill>
+                            <a:srgbClr val="1F2D3D"/>
+                          </a:solidFill>
+                          <a:latin typeface="Calibri" pitchFamily="34" charset="0"/>
+                          <a:ea typeface="Calibri" pitchFamily="34" charset="-122"/>
+                          <a:cs typeface="Calibri" pitchFamily="34" charset="-120"/>
+                        </a:rPr>
+                        <a:t>5</a:t>
+                      </a:r>
+                      <a:endParaRPr lang="en-US" sz="1250" dirty="0">
+                        <a:latin typeface="Calibri" charset="0"/>
+                        <a:ea typeface="Calibri" charset="0"/>
+                        <a:cs typeface="Calibri" charset="0"/>
+                      </a:endParaRPr>
+                    </a:p>
+                  </a:txBody>
+                  <a:tcPr marL="63500" marR="63500" marT="25400" marB="25400" anchor="ctr">
+                    <a:lnL w="9525" cap="flat" cmpd="sng" algn="ctr">
+                      <a:solidFill>
+                        <a:srgbClr val="E3E8EF"/>
+                      </a:solidFill>
+                      <a:prstDash val="solid"/>
+                      <a:round/>
+                      <a:headEnd type="none" w="med" len="med"/>
+                      <a:tailEnd type="none" w="med" len="med"/>
+                    </a:lnL>
+                    <a:lnR w="9525" cap="flat" cmpd="sng" algn="ctr">
+                      <a:solidFill>
+                        <a:srgbClr val="E3E8EF"/>
+                      </a:solidFill>
+                      <a:prstDash val="solid"/>
+                      <a:round/>
+                      <a:headEnd type="none" w="med" len="med"/>
+                      <a:tailEnd type="none" w="med" len="med"/>
+                    </a:lnR>
+                    <a:lnT w="9525" cap="flat" cmpd="sng" algn="ctr">
+                      <a:solidFill>
+                        <a:srgbClr val="E3E8EF"/>
+                      </a:solidFill>
+                      <a:prstDash val="solid"/>
+                      <a:round/>
+                      <a:headEnd type="none" w="med" len="med"/>
+                      <a:tailEnd type="none" w="med" len="med"/>
+                    </a:lnT>
+                    <a:lnB w="9525" cap="flat" cmpd="sng" algn="ctr">
+                      <a:solidFill>
+                        <a:srgbClr val="E3E8EF"/>
+                      </a:solidFill>
+                      <a:prstDash val="solid"/>
+                      <a:round/>
+                      <a:headEnd type="none" w="med" len="med"/>
+                      <a:tailEnd type="none" w="med" len="med"/>
+                    </a:lnB>
+                    <a:solidFill>
+                      <a:srgbClr val="FFFFFF"/>
+                    </a:solidFill>
+                  </a:tcPr>
+                </a:tc>
+                <a:tc>
+                  <a:txBody>
+                    <a:bodyPr/>
+                    <a:lstStyle/>
+                    <a:p>
+                      <a:pPr algn="l" indent="0" marL="0">
+                        <a:buNone/>
+                      </a:pPr>
+                      <a:r>
+                        <a:rPr lang="en-US" sz="1250" dirty="0">
+                          <a:solidFill>
+                            <a:srgbClr val="1F2D3D"/>
+                          </a:solidFill>
+                          <a:latin typeface="Calibri" pitchFamily="34" charset="0"/>
+                          <a:ea typeface="Calibri" pitchFamily="34" charset="-122"/>
+                          <a:cs typeface="Calibri" pitchFamily="34" charset="-120"/>
+                        </a:rPr>
+                        <a:t>#138 update impact, #141 combined insights, #140 three dashboard pages, #143 final notebook</a:t>
+                      </a:r>
+                      <a:endParaRPr lang="en-US" sz="1250" dirty="0">
+                        <a:latin typeface="Calibri" charset="0"/>
+                        <a:ea typeface="Calibri" charset="0"/>
+                        <a:cs typeface="Calibri" charset="0"/>
+                      </a:endParaRPr>
+                    </a:p>
+                  </a:txBody>
+                  <a:tcPr marL="63500" marR="63500" marT="25400" marB="25400" anchor="ctr">
+                    <a:lnL w="9525" cap="flat" cmpd="sng" algn="ctr">
+                      <a:solidFill>
+                        <a:srgbClr val="E3E8EF"/>
+                      </a:solidFill>
+                      <a:prstDash val="solid"/>
+                      <a:round/>
+                      <a:headEnd type="none" w="med" len="med"/>
+                      <a:tailEnd type="none" w="med" len="med"/>
+                    </a:lnL>
+                    <a:lnR w="9525" cap="flat" cmpd="sng" algn="ctr">
+                      <a:solidFill>
+                        <a:srgbClr val="E3E8EF"/>
+                      </a:solidFill>
+                      <a:prstDash val="solid"/>
+                      <a:round/>
+                      <a:headEnd type="none" w="med" len="med"/>
+                      <a:tailEnd type="none" w="med" len="med"/>
+                    </a:lnR>
+                    <a:lnT w="9525" cap="flat" cmpd="sng" algn="ctr">
+                      <a:solidFill>
+                        <a:srgbClr val="E3E8EF"/>
+                      </a:solidFill>
+                      <a:prstDash val="solid"/>
+                      <a:round/>
+                      <a:headEnd type="none" w="med" len="med"/>
+                      <a:tailEnd type="none" w="med" len="med"/>
+                    </a:lnT>
+                    <a:lnB w="9525" cap="flat" cmpd="sng" algn="ctr">
+                      <a:solidFill>
+                        <a:srgbClr val="E3E8EF"/>
+                      </a:solidFill>
+                      <a:prstDash val="solid"/>
+                      <a:round/>
+                      <a:headEnd type="none" w="med" len="med"/>
+                      <a:tailEnd type="none" w="med" len="med"/>
+                    </a:lnB>
+                    <a:solidFill>
+                      <a:srgbClr val="FFFFFF"/>
+                    </a:solidFill>
+                  </a:tcPr>
+                </a:tc>
+                <a:tc>
+                  <a:txBody>
+                    <a:bodyPr/>
+                    <a:lstStyle/>
+                    <a:p>
+                      <a:pPr algn="l" indent="0" marL="0">
+                        <a:buNone/>
+                      </a:pPr>
+                      <a:r>
+                        <a:rPr lang="en-US" sz="1250" dirty="0">
+                          <a:solidFill>
+                            <a:srgbClr val="1F2D3D"/>
+                          </a:solidFill>
+                          <a:latin typeface="Calibri" pitchFamily="34" charset="0"/>
+                          <a:ea typeface="Calibri" pitchFamily="34" charset="-122"/>
+                          <a:cs typeface="Calibri" pitchFamily="34" charset="-120"/>
+                        </a:rPr>
+                        <a:t>#157, #158 (11 Oct)</a:t>
+                      </a:r>
+                      <a:endParaRPr lang="en-US" sz="1250" dirty="0">
+                        <a:latin typeface="Calibri" charset="0"/>
+                        <a:ea typeface="Calibri" charset="0"/>
+                        <a:cs typeface="Calibri" charset="0"/>
+                      </a:endParaRPr>
+                    </a:p>
+                  </a:txBody>
+                  <a:tcPr marL="63500" marR="63500" marT="25400" marB="25400" anchor="ctr">
+                    <a:lnL w="9525" cap="flat" cmpd="sng" algn="ctr">
+                      <a:solidFill>
+                        <a:srgbClr val="E3E8EF"/>
+                      </a:solidFill>
+                      <a:prstDash val="solid"/>
+                      <a:round/>
+                      <a:headEnd type="none" w="med" len="med"/>
+                      <a:tailEnd type="none" w="med" len="med"/>
+                    </a:lnL>
+                    <a:lnR w="9525" cap="flat" cmpd="sng" algn="ctr">
+                      <a:solidFill>
+                        <a:srgbClr val="E3E8EF"/>
+                      </a:solidFill>
+                      <a:prstDash val="solid"/>
+                      <a:round/>
+                      <a:headEnd type="none" w="med" len="med"/>
+                      <a:tailEnd type="none" w="med" len="med"/>
+                    </a:lnR>
+                    <a:lnT w="9525" cap="flat" cmpd="sng" algn="ctr">
+                      <a:solidFill>
+                        <a:srgbClr val="E3E8EF"/>
+                      </a:solidFill>
+                      <a:prstDash val="solid"/>
+                      <a:round/>
+                      <a:headEnd type="none" w="med" len="med"/>
+                      <a:tailEnd type="none" w="med" len="med"/>
+                    </a:lnT>
+                    <a:lnB w="9525" cap="flat" cmpd="sng" algn="ctr">
+                      <a:solidFill>
+                        <a:srgbClr val="E3E8EF"/>
+                      </a:solidFill>
+                      <a:prstDash val="solid"/>
+                      <a:round/>
+                      <a:headEnd type="none" w="med" len="med"/>
+                      <a:tailEnd type="none" w="med" len="med"/>
+                    </a:lnB>
+                    <a:solidFill>
+                      <a:srgbClr val="FFFFFF"/>
+                    </a:solidFill>
+                  </a:tcPr>
+                </a:tc>
+                <a:tc>
+                  <a:txBody>
+                    <a:bodyPr/>
+                    <a:lstStyle/>
+                    <a:p>
+                      <a:pPr algn="l" indent="0" marL="0">
+                        <a:buNone/>
+                      </a:pPr>
+                      <a:r>
+                        <a:rPr lang="en-US" sz="1250" dirty="0">
+                          <a:solidFill>
+                            <a:srgbClr val="1F2D3D"/>
+                          </a:solidFill>
+                          <a:latin typeface="Calibri" pitchFamily="34" charset="0"/>
+                          <a:ea typeface="Calibri" pitchFamily="34" charset="-122"/>
+                          <a:cs typeface="Calibri" pitchFamily="34" charset="-120"/>
+                        </a:rPr>
+                        <a:t>scripts 21–22, COMBINED_INSIGHTS.md, notebooks/Review_2.ipynb</a:t>
+                      </a:r>
+                      <a:endParaRPr lang="en-US" sz="1250" dirty="0">
+                        <a:latin typeface="Calibri" charset="0"/>
+                        <a:ea typeface="Calibri" charset="0"/>
+                        <a:cs typeface="Calibri" charset="0"/>
+                      </a:endParaRPr>
+                    </a:p>
+                  </a:txBody>
+                  <a:tcPr marL="63500" marR="63500" marT="25400" marB="25400" anchor="ctr">
+                    <a:lnL w="9525" cap="flat" cmpd="sng" algn="ctr">
+                      <a:solidFill>
+                        <a:srgbClr val="E3E8EF"/>
+                      </a:solidFill>
+                      <a:prstDash val="solid"/>
+                      <a:round/>
+                      <a:headEnd type="none" w="med" len="med"/>
+                      <a:tailEnd type="none" w="med" len="med"/>
+                    </a:lnL>
+                    <a:lnR w="9525" cap="flat" cmpd="sng" algn="ctr">
+                      <a:solidFill>
+                        <a:srgbClr val="E3E8EF"/>
+                      </a:solidFill>
+                      <a:prstDash val="solid"/>
+                      <a:round/>
+                      <a:headEnd type="none" w="med" len="med"/>
+                      <a:tailEnd type="none" w="med" len="med"/>
+                    </a:lnR>
+                    <a:lnT w="9525" cap="flat" cmpd="sng" algn="ctr">
+                      <a:solidFill>
+                        <a:srgbClr val="E3E8EF"/>
+                      </a:solidFill>
+                      <a:prstDash val="solid"/>
+                      <a:round/>
+                      <a:headEnd type="none" w="med" len="med"/>
+                      <a:tailEnd type="none" w="med" len="med"/>
+                    </a:lnT>
+                    <a:lnB w="9525" cap="flat" cmpd="sng" algn="ctr">
+                      <a:solidFill>
+                        <a:srgbClr val="E3E8EF"/>
+                      </a:solidFill>
+                      <a:prstDash val="solid"/>
+                      <a:round/>
+                      <a:headEnd type="none" w="med" len="med"/>
+                      <a:tailEnd type="none" w="med" len="med"/>
+                    </a:lnB>
+                    <a:solidFill>
+                      <a:srgbClr val="FFFFFF"/>
+                    </a:solidFill>
+                  </a:tcPr>
+                </a:tc>
+              </a:tr>
+            </a:tbl>
+          </a:graphicData>
+        </a:graphic>
+      </p:graphicFrame>
+      <p:sp>
+        <p:nvSpPr>
+          <p:cNvPr id="5" name="Text 2"/>
+          <p:cNvSpPr txBox="1"/>
+          <p:nvPr/>
+        </p:nvSpPr>
+        <p:spPr>
+          <a:xfrm>
+            <a:off x="640080" y="5623560"/>
+            <a:ext cx="10911535" cy="685800"/>
+          </a:xfrm>
+          <a:prstGeom prst="rect">
+            <a:avLst/>
+          </a:prstGeom>
+          <a:noFill/>
+          <a:ln/>
+        </p:spPr>
+        <p:txBody>
+          <a:bodyPr wrap="square" lIns="0" tIns="0" rIns="0" bIns="0" rtlCol="0" anchor="t">
+            <a:normAutofit/>
+          </a:bodyPr>
+          <a:lstStyle/>
+          <a:p>
+            <a:pPr indent="0" marL="0">
+              <a:lnSpc>
+                <a:spcPct val="100000"/>
+              </a:lnSpc>
+              <a:spcAft>
+                <a:spcPts val="600"/>
+              </a:spcAft>
+              <a:buNone/>
+            </a:pPr>
+            <a:r>
+              <a:rPr lang="en-US" sz="1250" b="1" dirty="0">
+                <a:solidFill>
+                  <a:schemeClr val="tx1"/>
+                </a:solidFill>
+              </a:rPr>
+              <a:t>Activity history: </a:t>
+            </a:r>
+            <a:pPr indent="0" marL="0">
+              <a:lnSpc>
+                <a:spcPct val="100000"/>
+              </a:lnSpc>
+              <a:spcAft>
+                <a:spcPts val="600"/>
+              </a:spcAft>
+              <a:buNone/>
+            </a:pPr>
+            <a:r>
+              <a:rPr lang="en-US" sz="1250" dirty="0">
+                <a:solidFill>
+                  <a:schemeClr val="tx1"/>
+                </a:solidFill>
+              </a:rPr>
+              <a:t>one stage after another, each merged before the next began (Stages 1–2 on 8 Oct, Stage 3 on 9 Oct, Stage 4 on 10 Oct, Stage 5 on 11 Oct). Each task is linked to a merged pull request, and every card is in Completed.</a:t>
+            </a:r>
+            <a:endParaRPr lang="en-US" sz="1250" dirty="0"/>
+          </a:p>
+        </p:txBody>
+      </p:sp>
+      <p:sp>
+        <p:nvSpPr>
+          <p:cNvPr id="25" name="Slide Number Placeholder 0"/>
+          <p:cNvSpPr>
+            <a:spLocks noGrp="1"/>
+          </p:cNvSpPr>
+          <p:nvPr>
+            <p:ph type="sldNum" sz="quarter" idx="4294967295"/>
+          </p:nvPr>
+        </p:nvSpPr>
+        <p:spPr>
+          <a:xfrm>
+            <a:off x="11091672" y="6446520"/>
+            <a:ext cx="457200" cy="256032"/>
+          </a:xfrm>
+          <a:prstGeom prst="rect">
+            <a:avLst/>
+          </a:prstGeom>
+          <a:extLst>
+            <a:ext uri="{C572A759-6A51-4108-AA02-DFA0A04FC94B}">
+              <ma14:wrappingTextBoxFlag xmlns:ma14="http://schemas.microsoft.com/office/mac/drawingml/2011/main" val="0"/>
+            </a:ext>
+          </a:extLst>
+        </p:spPr>
+        <p:txBody>
+          <a:bodyPr/>
+          <a:lstStyle>
+            <a:lvl1pPr>
+              <a:defRPr sz="1000">
+                <a:solidFill>
+                  <a:schemeClr val="accent6"/>
+                </a:solidFill>
+              </a:defRPr>
+            </a:lvl1pPr>
+          </a:lstStyle>
+          <a:p>
+            <a:pPr algn="r"/>
+            <a:fld id="{F7021451-1387-4CA6-816F-3879F97B5CBC}" type="slidenum">
+              <a:rPr b="0" lang="en-US"/>
+              <a:t>21</a:t>
+            </a:fld>
+            <a:endParaRPr lang="en-US"/>
+          </a:p>
+        </p:txBody>
+      </p:sp>
+    </p:spTree>
+  </p:cSld>
+  <p:clrMapOvr>
+    <a:masterClrMapping/>
+  </p:clrMapOvr>
+</p:sld>
+</file>
+
+<file path=ppt/slides/slide22.xml><?xml version="1.0" encoding="utf-8"?>
+<p:sld xmlns:a="http://schemas.openxmlformats.org/drawingml/2006/main" xmlns:r="http://schemas.openxmlformats.org/officeDocument/2006/relationships" xmlns:p="http://schemas.openxmlformats.org/presentationml/2006/main">
+  <p:cSld name="Slide 22">
+    <p:spTree>
+      <p:nvGrpSpPr>
+        <p:cNvPr id="1" name=""/>
+        <p:cNvGrpSpPr/>
+        <p:nvPr/>
+      </p:nvGrpSpPr>
+      <p:grpSpPr>
+        <a:xfrm>
+          <a:off x="0" y="0"/>
+          <a:ext cx="0" cy="0"/>
+          <a:chOff x="0" y="0"/>
+          <a:chExt cx="0" cy="0"/>
+        </a:xfrm>
+      </p:grpSpPr>
+      <p:sp>
+        <p:nvSpPr>
+          <p:cNvPr id="2" name="Text 1"/>
+          <p:cNvSpPr/>
+          <p:nvPr>
+            <p:ph idx="101" type="body" hasCustomPrompt="1"/>
+          </p:nvPr>
+        </p:nvSpPr>
+        <p:spPr>
+          <a:xfrm>
+            <a:off x="640080" y="292608"/>
+            <a:ext cx="10911535" cy="274320"/>
+          </a:xfrm>
+          <a:prstGeom prst="rect">
+            <a:avLst/>
+          </a:prstGeom>
+          <a:noFill/>
+          <a:ln/>
+        </p:spPr>
+        <p:txBody>
+          <a:bodyPr wrap="square" lIns="0" tIns="0" rIns="0" bIns="0" rtlCol="0" anchor="ctr"/>
+          <a:lstStyle/>
+          <a:p>
+            <a:pPr algn="l" indent="0" marL="0">
+              <a:buNone/>
+            </a:pPr>
+            <a:r>
+              <a:rPr lang="en-US" sz="1100" b="1" spc="200" kern="0" dirty="0">
+                <a:solidFill>
+                  <a:schemeClr val="accent6"/>
+                </a:solidFill>
+              </a:rPr>
+              <a:t>15  |  CONCLUSION AND SUBMISSION</a:t>
             </a:r>
             <a:endParaRPr lang="en-US" sz="1100" dirty="0"/>
           </a:p>
@@ -26080,7 +26379,7 @@
             <a:pPr algn="r"/>
             <a:fld id="{F7021451-1387-4CA6-816F-3879F97B5CBC}" type="slidenum">
               <a:rPr b="0" lang="en-US"/>
-              <a:t>21</a:t>
+              <a:t>22</a:t>
             </a:fld>
             <a:endParaRPr lang="en-US"/>
           </a:p>

</xml_diff>

<commit_message>
docs(review2): list one team member per line on the title slide
Co-Authored-By: Claude Opus 5.5 <noreply@anthropic.com>
Claude-Session: https://claude.ai/code/session_01MEcVduUgaTNAcJqjrZDy2D
</commit_message>
<xml_diff>
--- a/docs/Review_2_Presentation.pptx
+++ b/docs/Review_2_Presentation.pptx
@@ -4353,7 +4353,7 @@
         </p:nvSpPr>
         <p:spPr>
           <a:xfrm xmlns:a="http://schemas.openxmlformats.org/drawingml/2006/main">
-            <a:off x="685800" y="2428875"/>
+            <a:off x="685800" y="2148840"/>
             <a:ext cx="10477500" cy="666750"/>
           </a:xfrm>
           <a:prstGeom xmlns:a="http://schemas.openxmlformats.org/drawingml/2006/main" prst="rect">
@@ -4420,8 +4420,8 @@
         </p:nvSpPr>
         <p:spPr>
           <a:xfrm xmlns:a="http://schemas.openxmlformats.org/drawingml/2006/main">
-            <a:off x="685800" y="3246120"/>
-            <a:ext cx="10477500" cy="1600200"/>
+            <a:off x="685800" y="2926080"/>
+            <a:ext cx="10477500" cy="2011680"/>
           </a:xfrm>
           <a:prstGeom xmlns:a="http://schemas.openxmlformats.org/drawingml/2006/main" prst="rect">
             <a:avLst/>
@@ -4449,7 +4449,7 @@
           <ns2:p xmlns:ns2="http://schemas.openxmlformats.org/drawingml/2006/main">
             <ns2:pPr>
               <ns2:spcAft>
-                <ns2:spcPts val="400"/>
+                <ns2:spcPts val="300"/>
               </ns2:spcAft>
               <ns2:defRPr sz="1875" b="0">
                 <ns2:solidFill>
@@ -4475,7 +4475,7 @@
           <ns3:p xmlns:ns3="http://schemas.openxmlformats.org/drawingml/2006/main">
             <ns3:pPr>
               <ns3:spcAft>
-                <ns3:spcPts val="400"/>
+                <ns3:spcPts val="300"/>
               </ns3:spcAft>
               <ns3:defRPr sz="1875" b="0">
                 <ns3:solidFill>
@@ -4485,6 +4485,9 @@
                 <ns3:ea typeface="Arial"/>
                 <ns3:cs typeface="Arial"/>
               </ns3:defRPr>
+              <ns3:tabLst>
+                <ns3:tab pos="3291840" algn="l"/>
+              </ns3:tabLst>
             </ns3:pPr>
             <ns3:r>
               <ns3:rPr sz="1600" b="0">
@@ -4495,13 +4498,13 @@
                 <ns3:ea typeface="Arial"/>
                 <ns3:cs typeface="Arial"/>
               </ns3:rPr>
-              <ns3:t>Aditya Monish Kumar K (CB.SC.U4CSE23103)  ·  Regella Krishna Saketh (CB.SC.U4CSE23649)</ns3:t>
+              <ns3:t>Aditya Monish Kumar K	CB.SC.U4CSE23103</ns3:t>
             </ns3:r>
           </ns3:p>
           <ns4:p xmlns:ns4="http://schemas.openxmlformats.org/drawingml/2006/main">
             <ns4:pPr>
               <ns4:spcAft>
-                <ns4:spcPts val="400"/>
+                <ns4:spcPts val="300"/>
               </ns4:spcAft>
               <ns4:defRPr sz="1875" b="0">
                 <ns4:solidFill>
@@ -4511,6 +4514,9 @@
                 <ns4:ea typeface="Arial"/>
                 <ns4:cs typeface="Arial"/>
               </ns4:defRPr>
+              <ns4:tabLst>
+                <ns4:tab pos="3291840" algn="l"/>
+              </ns4:tabLst>
             </ns4:pPr>
             <ns4:r>
               <ns4:rPr sz="1600" b="0">
@@ -4521,13 +4527,13 @@
                 <ns4:ea typeface="Arial"/>
                 <ns4:cs typeface="Arial"/>
               </ns4:rPr>
-              <ns4:t>Akshay KS (CB.SC.U4CSE23104)  ·  Harshini Vennela (CB.SC.U4CSE23455)</ns4:t>
+              <ns4:t>Regella Krishna Saketh	CB.SC.U4CSE23649</ns4:t>
             </ns4:r>
           </ns4:p>
           <ns5:p xmlns:ns5="http://schemas.openxmlformats.org/drawingml/2006/main">
             <ns5:pPr>
               <ns5:spcAft>
-                <ns5:spcPts val="400"/>
+                <ns5:spcPts val="300"/>
               </ns5:spcAft>
               <ns5:defRPr sz="1875" b="0">
                 <ns5:solidFill>
@@ -4537,6 +4543,9 @@
                 <ns5:ea typeface="Arial"/>
                 <ns5:cs typeface="Arial"/>
               </ns5:defRPr>
+              <ns5:tabLst>
+                <ns5:tab pos="3291840" algn="l"/>
+              </ns5:tabLst>
             </ns5:pPr>
             <ns5:r>
               <ns5:rPr sz="1600" b="0">
@@ -4547,9 +4556,67 @@
                 <ns5:ea typeface="Arial"/>
                 <ns5:cs typeface="Arial"/>
               </ns5:rPr>
-              <ns5:t>Kanishka D (CB.SC.U4CSE23155)</ns5:t>
+              <ns5:t>Akshay KS	CB.SC.U4CSE23104</ns5:t>
             </ns5:r>
           </ns5:p>
+          <ns6:p xmlns:ns6="http://schemas.openxmlformats.org/drawingml/2006/main">
+            <ns6:pPr>
+              <ns6:spcAft>
+                <ns6:spcPts val="300"/>
+              </ns6:spcAft>
+              <ns6:defRPr sz="1875" b="0">
+                <ns6:solidFill>
+                  <ns6:srgbClr val="233247"/>
+                </ns6:solidFill>
+                <ns6:latin typeface="Arial"/>
+                <ns6:ea typeface="Arial"/>
+                <ns6:cs typeface="Arial"/>
+              </ns6:defRPr>
+              <ns6:tabLst>
+                <ns6:tab pos="3291840" algn="l"/>
+              </ns6:tabLst>
+            </ns6:pPr>
+            <ns6:r>
+              <ns6:rPr sz="1600" b="0">
+                <ns6:solidFill>
+                  <ns6:srgbClr val="233247"/>
+                </ns6:solidFill>
+                <ns6:latin typeface="Arial"/>
+                <ns6:ea typeface="Arial"/>
+                <ns6:cs typeface="Arial"/>
+              </ns6:rPr>
+              <ns6:t>Harshini Vennela	CB.SC.U4CSE23455</ns6:t>
+            </ns6:r>
+          </ns6:p>
+          <ns7:p xmlns:ns7="http://schemas.openxmlformats.org/drawingml/2006/main">
+            <ns7:pPr>
+              <ns7:spcAft>
+                <ns7:spcPts val="300"/>
+              </ns7:spcAft>
+              <ns7:defRPr sz="1875" b="0">
+                <ns7:solidFill>
+                  <ns7:srgbClr val="233247"/>
+                </ns7:solidFill>
+                <ns7:latin typeface="Arial"/>
+                <ns7:ea typeface="Arial"/>
+                <ns7:cs typeface="Arial"/>
+              </ns7:defRPr>
+              <ns7:tabLst>
+                <ns7:tab pos="3291840" algn="l"/>
+              </ns7:tabLst>
+            </ns7:pPr>
+            <ns7:r>
+              <ns7:rPr sz="1600" b="0">
+                <ns7:solidFill>
+                  <ns7:srgbClr val="233247"/>
+                </ns7:solidFill>
+                <ns7:latin typeface="Arial"/>
+                <ns7:ea typeface="Arial"/>
+                <ns7:cs typeface="Arial"/>
+              </ns7:rPr>
+              <ns7:t>Kanishka D	CB.SC.U4CSE23155</ns7:t>
+            </ns7:r>
+          </ns7:p>
         </p:txBody>
       </p:sp>
       <p:sp>
@@ -4568,7 +4635,7 @@
         </p:nvSpPr>
         <p:spPr>
           <a:xfrm xmlns:a="http://schemas.openxmlformats.org/drawingml/2006/main">
-            <a:off x="685800" y="5074920"/>
+            <a:off x="685800" y="5120640"/>
             <a:ext cx="10477500" cy="571500"/>
           </a:xfrm>
           <a:prstGeom xmlns:a="http://schemas.openxmlformats.org/drawingml/2006/main" prst="rect">
@@ -4594,73 +4661,73 @@
               </a:defRPr>
             </a:defPPr>
           </a:lstStyle>
-          <ns6:p xmlns:ns6="http://schemas.openxmlformats.org/drawingml/2006/main">
-            <ns6:pPr>
-              <ns6:defRPr sz="1800" b="0">
-                <ns6:solidFill>
-                  <ns6:srgbClr val="233247"/>
-                </ns6:solidFill>
-                <ns6:latin typeface="Arial"/>
-                <ns6:ea typeface="Arial"/>
-                <ns6:cs typeface="Arial"/>
-              </ns6:defRPr>
-            </ns6:pPr>
-            <ns6:r>
-              <ns6:rPr sz="1800" b="1">
-                <ns6:solidFill>
-                  <ns6:srgbClr val="233247"/>
-                </ns6:solidFill>
-                <ns6:latin typeface="Arial"/>
-                <ns6:ea typeface="Arial"/>
-                <ns6:cs typeface="Arial"/>
-              </ns6:rPr>
-              <ns6:t>Guide / Faculty: </ns6:t>
-            </ns6:r>
-            <ns6:r>
-              <ns6:rPr sz="1800" b="0">
-                <ns6:solidFill>
-                  <ns6:srgbClr val="233247"/>
-                </ns6:solidFill>
-                <ns6:latin typeface="Arial"/>
-                <ns6:ea typeface="Arial"/>
-                <ns6:cs typeface="Arial"/>
-              </ns6:rPr>
-              <ns6:t>Rohini S.</ns6:t>
-            </ns6:r>
-            <ns6:r>
-              <ns6:rPr sz="1800" b="0">
-                <ns6:solidFill>
-                  <ns6:srgbClr val="233247"/>
-                </ns6:solidFill>
-                <ns6:latin typeface="Arial"/>
-                <ns6:ea typeface="Arial"/>
-                <ns6:cs typeface="Arial"/>
-              </ns6:rPr>
-              <ns6:t>          </ns6:t>
-            </ns6:r>
-            <ns6:r>
-              <ns6:rPr sz="1800" b="1">
-                <ns6:solidFill>
-                  <ns6:srgbClr val="233247"/>
-                </ns6:solidFill>
-                <ns6:latin typeface="Arial"/>
-                <ns6:ea typeface="Arial"/>
-                <ns6:cs typeface="Arial"/>
-              </ns6:rPr>
-              <ns6:t>Presentation date: </ns6:t>
-            </ns6:r>
-            <ns6:r>
-              <ns6:rPr sz="1800" b="0">
-                <ns6:solidFill>
-                  <ns6:srgbClr val="233247"/>
-                </ns6:solidFill>
-                <ns6:latin typeface="Arial"/>
-                <ns6:ea typeface="Arial"/>
-                <ns6:cs typeface="Arial"/>
-              </ns6:rPr>
-              <ns6:t>20/10/2026</ns6:t>
-            </ns6:r>
-          </ns6:p>
+          <ns8:p xmlns:ns8="http://schemas.openxmlformats.org/drawingml/2006/main">
+            <ns8:pPr>
+              <ns8:defRPr sz="1800" b="0">
+                <ns8:solidFill>
+                  <ns8:srgbClr val="233247"/>
+                </ns8:solidFill>
+                <ns8:latin typeface="Arial"/>
+                <ns8:ea typeface="Arial"/>
+                <ns8:cs typeface="Arial"/>
+              </ns8:defRPr>
+            </ns8:pPr>
+            <ns8:r>
+              <ns8:rPr sz="1800" b="1">
+                <ns8:solidFill>
+                  <ns8:srgbClr val="233247"/>
+                </ns8:solidFill>
+                <ns8:latin typeface="Arial"/>
+                <ns8:ea typeface="Arial"/>
+                <ns8:cs typeface="Arial"/>
+              </ns8:rPr>
+              <ns8:t>Guide / Faculty: </ns8:t>
+            </ns8:r>
+            <ns8:r>
+              <ns8:rPr sz="1800" b="0">
+                <ns8:solidFill>
+                  <ns8:srgbClr val="233247"/>
+                </ns8:solidFill>
+                <ns8:latin typeface="Arial"/>
+                <ns8:ea typeface="Arial"/>
+                <ns8:cs typeface="Arial"/>
+              </ns8:rPr>
+              <ns8:t>Rohini S.</ns8:t>
+            </ns8:r>
+            <ns8:r>
+              <ns8:rPr sz="1800" b="0">
+                <ns8:solidFill>
+                  <ns8:srgbClr val="233247"/>
+                </ns8:solidFill>
+                <ns8:latin typeface="Arial"/>
+                <ns8:ea typeface="Arial"/>
+                <ns8:cs typeface="Arial"/>
+              </ns8:rPr>
+              <ns8:t>          </ns8:t>
+            </ns8:r>
+            <ns8:r>
+              <ns8:rPr sz="1800" b="1">
+                <ns8:solidFill>
+                  <ns8:srgbClr val="233247"/>
+                </ns8:solidFill>
+                <ns8:latin typeface="Arial"/>
+                <ns8:ea typeface="Arial"/>
+                <ns8:cs typeface="Arial"/>
+              </ns8:rPr>
+              <ns8:t>Presentation date: </ns8:t>
+            </ns8:r>
+            <ns8:r>
+              <ns8:rPr sz="1800" b="0">
+                <ns8:solidFill>
+                  <ns8:srgbClr val="233247"/>
+                </ns8:solidFill>
+                <ns8:latin typeface="Arial"/>
+                <ns8:ea typeface="Arial"/>
+                <ns8:cs typeface="Arial"/>
+              </ns8:rPr>
+              <ns8:t>20/10/2026</ns8:t>
+            </ns8:r>
+          </ns8:p>
         </p:txBody>
       </p:sp>
     </p:spTree>

</xml_diff>